<commit_message>
Team roles: dataset and preprocessing, Big Data pipeline, novel model, comparative ML and visualisation
</commit_message>
<xml_diff>
--- a/docs/Review2_Deck.pptx
+++ b/docs/Review2_Deck.pptx
@@ -39,6 +39,8 @@
     <p:sldId id="284" r:id="rId36"/>
     <p:sldId id="285" r:id="rId37"/>
     <p:sldId id="286" r:id="rId38"/>
+    <p:sldId id="287" r:id="rId39"/>
+    <p:sldId id="288" r:id="rId40"/>
   </p:sldIdLst>
   <p:sldSz cx="9144000" cy="6858000" type="screen4x3"/>
   <p:notesSz cx="7315200" cy="9601200"/>
@@ -1790,7 +1792,7 @@
           <a:lstStyle/>
           <a:p>
             <a:r>
-              <a:t>Top: ROC and precision-recall curves for A-CPN and the five baselines, pooled over the 25 folds. Bottom: mean and standard deviation of four metrics for every model.</a:t>
+              <a:t>Left: A-CPN training and validation loss; training stops at the best validation epoch. Right: the mean attention weight of each climate feature, showing which hazards drive the climate push.</a:t>
             </a:r>
           </a:p>
         </p:txBody>
@@ -1860,7 +1862,7 @@
           <a:lstStyle/>
           <a:p>
             <a:r>
-              <a:t>Left: the A-CPN confusion matrix summed over all test folds. Right: the spread of ROC-AUC across the 25 folds for every model, which shows how stable each model is.</a:t>
+              <a:t>Each bar is A-CPN with one component removed, on the same 25 folds. Removing the climate push costs the most; removing attention or the KAN layer does not lower accuracy, so those parts are kept for the explanation they give.</a:t>
             </a:r>
           </a:p>
         </p:txBody>
@@ -1930,7 +1932,7 @@
           <a:lstStyle/>
           <a:p>
             <a:r>
-              <a:t>Top: ROC-AUC of every model on raw versus preprocessed features, with the gain above each pair. Bottom: the ablation, removing one A-CPN component at a time.</a:t>
+              <a:t>Left: the climate push of every district by group, with the group mean. Right: an India map of the climate push, so the panel can see where climate drives vulnerability beyond development.</a:t>
             </a:r>
           </a:p>
         </p:txBody>
@@ -2000,7 +2002,7 @@
           <a:lstStyle/>
           <a:p>
             <a:r>
-              <a:t>Left: the climate push of every district by group, with the group mean. Right: an India map of the climate push, so the panel can see where climate drives vulnerability beyond development.</a:t>
+              <a:t>Top: ROC and precision-recall curves for A-CPN and the five baselines, pooled over the 25 folds. Bottom: mean and standard deviation of four metrics for every model.</a:t>
             </a:r>
           </a:p>
         </p:txBody>
@@ -2070,7 +2072,7 @@
           <a:lstStyle/>
           <a:p>
             <a:r>
-              <a:t>Development explains only 13% of the variation in vulnerability; adding climate raises that to 33%, and state alone explains 48%. Anomaly A districts have about twice as many tropical nights, and Anomaly B districts are drier. Limitations are listed honestly.</a:t>
+              <a:t>Top: confusion matrices of all six models summed over the 25 test folds. Bottom: the spread of ROC-AUC across the folds, which shows how stable each model is.</a:t>
             </a:r>
           </a:p>
         </p:txBody>
@@ -2140,7 +2142,7 @@
           <a:lstStyle/>
           <a:p>
             <a:r>
-              <a:t>Each member owns one stage of the pipeline with no overlap: Sehjodh the data and preprocessing, Deepankar the Big Data platform, Tanmay the processing jobs, and Devanshu the models. Completion percentages are estimates at Review 2.</a:t>
+              <a:t>ROC-AUC of every model on raw versus preprocessed features, with the gain written above each pair. The neural models gain; tree models and Spark's internally standardised models do not change.</a:t>
             </a:r>
           </a:p>
         </p:txBody>
@@ -2210,7 +2212,7 @@
           <a:lstStyle/>
           <a:p>
             <a:r>
-              <a:t>These are the data sources, the papers behind each A-CPN component, and the Big Data tools we used.</a:t>
+              <a:t>Development explains only 13% of the variation in vulnerability; adding climate raises that to 33%, and state alone explains 48%. Anomaly A districts have about twice as many tropical nights, and Anomaly B districts are drier. Limitations are listed honestly.</a:t>
             </a:r>
           </a:p>
         </p:txBody>
@@ -2350,7 +2352,7 @@
           <a:lstStyle/>
           <a:p>
             <a:r>
-              <a:t>The team adds the geotagged photo taken during the Review 2 presentation here.</a:t>
+              <a:t>Each member owns one stage with no overlap: Sehjodh the dataset and preprocessing, Deepankar the Big Data pipeline, Devanshu the novel deep-learning model, and Tanmay the comparison with existing models and the visualisation. Each member presents only the slides of their own stage.</a:t>
             </a:r>
           </a:p>
         </p:txBody>
@@ -2376,6 +2378,146 @@
 </file>
 
 <file path=ppt/notesSlides/notesSlide31.xml><?xml version="1.0" encoding="utf-8"?>
+<p:notes xmlns:a="http://schemas.openxmlformats.org/drawingml/2006/main" xmlns:p="http://schemas.openxmlformats.org/presentationml/2006/main" xmlns:r="http://schemas.openxmlformats.org/officeDocument/2006/relationships">
+  <p:cSld>
+    <p:spTree>
+      <p:nvGrpSpPr>
+        <p:cNvPr id="1" name=""/>
+        <p:cNvGrpSpPr/>
+        <p:nvPr/>
+      </p:nvGrpSpPr>
+      <p:grpSpPr>
+        <a:xfrm>
+          <a:off x="0" y="0"/>
+          <a:ext cx="0" cy="0"/>
+          <a:chOff x="0" y="0"/>
+          <a:chExt cx="0" cy="0"/>
+        </a:xfrm>
+      </p:grpSpPr>
+      <p:sp>
+        <p:nvSpPr>
+          <p:cNvPr id="2" name="Slide Image Placeholder 1"/>
+          <p:cNvSpPr>
+            <a:spLocks noGrp="1"/>
+          </p:cNvSpPr>
+          <p:nvPr>
+            <p:ph type="sldImg" idx="2"/>
+          </p:nvPr>
+        </p:nvSpPr>
+        <p:spPr/>
+      </p:sp>
+      <p:sp>
+        <p:nvSpPr>
+          <p:cNvPr id="3" name="Notes Placeholder 2"/>
+          <p:cNvSpPr>
+            <a:spLocks noGrp="1"/>
+          </p:cNvSpPr>
+          <p:nvPr>
+            <p:ph type="body" idx="3" sz="quarter"/>
+          </p:nvPr>
+        </p:nvSpPr>
+        <p:spPr/>
+        <p:txBody>
+          <a:bodyPr/>
+          <a:lstStyle/>
+          <a:p>
+            <a:r>
+              <a:t>These are the data sources, the papers behind each A-CPN component, and the Big Data tools we used.</a:t>
+            </a:r>
+          </a:p>
+        </p:txBody>
+      </p:sp>
+      <p:sp>
+        <p:nvSpPr>
+          <p:cNvPr id="4" name="Slide Number Placeholder 3"/>
+          <p:cNvSpPr>
+            <a:spLocks noGrp="1"/>
+          </p:cNvSpPr>
+          <p:nvPr>
+            <p:ph type="sldNum" idx="5" sz="quarter"/>
+          </p:nvPr>
+        </p:nvSpPr>
+        <p:spPr/>
+      </p:sp>
+    </p:spTree>
+  </p:cSld>
+  <p:clrMapOvr>
+    <a:masterClrMapping/>
+  </p:clrMapOvr>
+</p:notes>
+</file>
+
+<file path=ppt/notesSlides/notesSlide32.xml><?xml version="1.0" encoding="utf-8"?>
+<p:notes xmlns:a="http://schemas.openxmlformats.org/drawingml/2006/main" xmlns:p="http://schemas.openxmlformats.org/presentationml/2006/main" xmlns:r="http://schemas.openxmlformats.org/officeDocument/2006/relationships">
+  <p:cSld>
+    <p:spTree>
+      <p:nvGrpSpPr>
+        <p:cNvPr id="1" name=""/>
+        <p:cNvGrpSpPr/>
+        <p:nvPr/>
+      </p:nvGrpSpPr>
+      <p:grpSpPr>
+        <a:xfrm>
+          <a:off x="0" y="0"/>
+          <a:ext cx="0" cy="0"/>
+          <a:chOff x="0" y="0"/>
+          <a:chExt cx="0" cy="0"/>
+        </a:xfrm>
+      </p:grpSpPr>
+      <p:sp>
+        <p:nvSpPr>
+          <p:cNvPr id="2" name="Slide Image Placeholder 1"/>
+          <p:cNvSpPr>
+            <a:spLocks noGrp="1"/>
+          </p:cNvSpPr>
+          <p:nvPr>
+            <p:ph type="sldImg" idx="2"/>
+          </p:nvPr>
+        </p:nvSpPr>
+        <p:spPr/>
+      </p:sp>
+      <p:sp>
+        <p:nvSpPr>
+          <p:cNvPr id="3" name="Notes Placeholder 2"/>
+          <p:cNvSpPr>
+            <a:spLocks noGrp="1"/>
+          </p:cNvSpPr>
+          <p:nvPr>
+            <p:ph type="body" idx="3" sz="quarter"/>
+          </p:nvPr>
+        </p:nvSpPr>
+        <p:spPr/>
+        <p:txBody>
+          <a:bodyPr/>
+          <a:lstStyle/>
+          <a:p>
+            <a:r>
+              <a:t>The team adds the geotagged photo taken during the Review 2 presentation here.</a:t>
+            </a:r>
+          </a:p>
+        </p:txBody>
+      </p:sp>
+      <p:sp>
+        <p:nvSpPr>
+          <p:cNvPr id="4" name="Slide Number Placeholder 3"/>
+          <p:cNvSpPr>
+            <a:spLocks noGrp="1"/>
+          </p:cNvSpPr>
+          <p:nvPr>
+            <p:ph type="sldNum" idx="5" sz="quarter"/>
+          </p:nvPr>
+        </p:nvSpPr>
+        <p:spPr/>
+      </p:sp>
+    </p:spTree>
+  </p:cSld>
+  <p:clrMapOvr>
+    <a:masterClrMapping/>
+  </p:clrMapOvr>
+</p:notes>
+</file>
+
+<file path=ppt/notesSlides/notesSlide33.xml><?xml version="1.0" encoding="utf-8"?>
 <p:notes xmlns:a="http://schemas.openxmlformats.org/drawingml/2006/main" xmlns:p="http://schemas.openxmlformats.org/presentationml/2006/main" xmlns:r="http://schemas.openxmlformats.org/officeDocument/2006/relationships">
   <p:cSld>
     <p:spTree>
@@ -10455,7 +10597,7 @@
                 </a:solidFill>
                 <a:latin typeface="Calibri"/>
               </a:rPr>
-              <a:t>Presenter: Devanshu Kumar</a:t>
+              <a:t>Presenter: Tanmay Singh</a:t>
             </a:r>
           </a:p>
         </p:txBody>
@@ -11828,7 +11970,7 @@
                 </a:solidFill>
                 <a:latin typeface="Calibri"/>
               </a:rPr>
-              <a:t>Presenter: Devanshu Kumar</a:t>
+              <a:t>Presenter: Tanmay Singh</a:t>
             </a:r>
           </a:p>
         </p:txBody>
@@ -13687,7 +13829,7 @@
                 </a:solidFill>
                 <a:latin typeface="Calibri"/>
               </a:rPr>
-              <a:t>Presenter: Devanshu Kumar</a:t>
+              <a:t>Presenter: Tanmay Singh</a:t>
             </a:r>
           </a:p>
         </p:txBody>
@@ -15060,7 +15202,7 @@
                 </a:solidFill>
                 <a:latin typeface="Calibri"/>
               </a:rPr>
-              <a:t>Presenter: Devanshu Kumar</a:t>
+              <a:t>Presenter: Tanmay Singh</a:t>
             </a:r>
           </a:p>
         </p:txBody>
@@ -19349,7 +19491,7 @@
                 </a:solidFill>
                 <a:latin typeface="Calibri"/>
               </a:rPr>
-              <a:t>Presenter: Tanmay Singh</a:t>
+              <a:t>Presenter: Deepankar</a:t>
             </a:r>
           </a:p>
         </p:txBody>
@@ -19363,6 +19505,631 @@
 </file>
 
 <file path=ppt/slides/slide23.xml><?xml version="1.0" encoding="utf-8"?>
+<p:sld xmlns:a="http://schemas.openxmlformats.org/drawingml/2006/main" xmlns:p="http://schemas.openxmlformats.org/presentationml/2006/main" xmlns:r="http://schemas.openxmlformats.org/officeDocument/2006/relationships">
+  <p:cSld>
+    <p:spTree>
+      <p:nvGrpSpPr>
+        <p:cNvPr id="1" name=""/>
+        <p:cNvGrpSpPr/>
+        <p:nvPr/>
+      </p:nvGrpSpPr>
+      <p:grpSpPr/>
+      <p:sp>
+        <p:nvSpPr>
+          <p:cNvPr id="2" name="Title 1"/>
+          <p:cNvSpPr>
+            <a:spLocks noGrp="1"/>
+          </p:cNvSpPr>
+          <p:nvPr>
+            <p:ph type="title"/>
+          </p:nvPr>
+        </p:nvSpPr>
+        <p:spPr>
+          <a:xfrm>
+            <a:off x="365760" y="274320"/>
+            <a:ext cx="6355080" cy="822960"/>
+          </a:xfrm>
+        </p:spPr>
+        <p:txBody>
+          <a:bodyPr wrap="square" anchor="ctr" lIns="45720"/>
+          <a:lstStyle/>
+          <a:p>
+            <a:pPr algn="l"/>
+            <a:r>
+              <a:rPr sz="2800" b="1" i="0">
+                <a:solidFill>
+                  <a:srgbClr val="1B3A6B"/>
+                </a:solidFill>
+                <a:latin typeface="Times New Roman"/>
+              </a:rPr>
+              <a:t>A-CPN Training &amp; Attention (Figures)</a:t>
+            </a:r>
+          </a:p>
+        </p:txBody>
+      </p:sp>
+      <p:pic>
+        <p:nvPicPr>
+          <p:cNvPr id="3" name="Picture 2" descr="image.jpeg"/>
+          <p:cNvPicPr>
+            <a:picLocks noChangeAspect="1"/>
+          </p:cNvPicPr>
+          <p:nvPr/>
+        </p:nvPicPr>
+        <p:blipFill>
+          <a:blip r:embed="rId2"/>
+          <a:stretch>
+            <a:fillRect/>
+          </a:stretch>
+        </p:blipFill>
+        <p:spPr>
+          <a:xfrm>
+            <a:off x="6858000" y="228600"/>
+            <a:ext cx="2066925" cy="857250"/>
+          </a:xfrm>
+          <a:prstGeom prst="rect">
+            <a:avLst/>
+          </a:prstGeom>
+        </p:spPr>
+      </p:pic>
+      <p:pic>
+        <p:nvPicPr>
+          <p:cNvPr id="4" name="Picture 3" descr="acpn_training_curve.png"/>
+          <p:cNvPicPr>
+            <a:picLocks noChangeAspect="1"/>
+          </p:cNvPicPr>
+          <p:nvPr/>
+        </p:nvPicPr>
+        <p:blipFill>
+          <a:blip r:embed="rId4"/>
+          <a:stretch>
+            <a:fillRect/>
+          </a:stretch>
+        </p:blipFill>
+        <p:spPr>
+          <a:xfrm>
+            <a:off x="365760" y="2081698"/>
+            <a:ext cx="4114800" cy="2877482"/>
+          </a:xfrm>
+          <a:prstGeom prst="rect">
+            <a:avLst/>
+          </a:prstGeom>
+        </p:spPr>
+      </p:pic>
+      <p:pic>
+        <p:nvPicPr>
+          <p:cNvPr id="5" name="Picture 4" descr="attention_importance.png"/>
+          <p:cNvPicPr>
+            <a:picLocks noChangeAspect="1"/>
+          </p:cNvPicPr>
+          <p:nvPr/>
+        </p:nvPicPr>
+        <p:blipFill>
+          <a:blip r:embed="rId5"/>
+          <a:stretch>
+            <a:fillRect/>
+          </a:stretch>
+        </p:blipFill>
+        <p:spPr>
+          <a:xfrm>
+            <a:off x="4663440" y="2336758"/>
+            <a:ext cx="4114800" cy="2367362"/>
+          </a:xfrm>
+          <a:prstGeom prst="rect">
+            <a:avLst/>
+          </a:prstGeom>
+        </p:spPr>
+      </p:pic>
+      <p:sp>
+        <p:nvSpPr>
+          <p:cNvPr id="6" name="TextBox 5"/>
+          <p:cNvSpPr txBox="1"/>
+          <p:nvPr/>
+        </p:nvSpPr>
+        <p:spPr>
+          <a:xfrm>
+            <a:off x="365760" y="5897880"/>
+            <a:ext cx="4114800" cy="457200"/>
+          </a:xfrm>
+          <a:prstGeom prst="rect">
+            <a:avLst/>
+          </a:prstGeom>
+          <a:noFill/>
+        </p:spPr>
+        <p:txBody>
+          <a:bodyPr wrap="square" anchor="t" lIns="45720" rIns="45720">
+            <a:spAutoFit/>
+          </a:bodyPr>
+          <a:lstStyle/>
+          <a:p>
+            <a:pPr algn="ctr"/>
+            <a:r>
+              <a:rPr sz="1200" b="0" i="0">
+                <a:solidFill>
+                  <a:srgbClr val="595959"/>
+                </a:solidFill>
+                <a:latin typeface="Calibri"/>
+              </a:rPr>
+              <a:t>A-CPN training curve (early stopping)</a:t>
+            </a:r>
+          </a:p>
+        </p:txBody>
+      </p:sp>
+      <p:sp>
+        <p:nvSpPr>
+          <p:cNvPr id="7" name="TextBox 6"/>
+          <p:cNvSpPr txBox="1"/>
+          <p:nvPr/>
+        </p:nvSpPr>
+        <p:spPr>
+          <a:xfrm>
+            <a:off x="4663440" y="5897880"/>
+            <a:ext cx="4114800" cy="457200"/>
+          </a:xfrm>
+          <a:prstGeom prst="rect">
+            <a:avLst/>
+          </a:prstGeom>
+          <a:noFill/>
+        </p:spPr>
+        <p:txBody>
+          <a:bodyPr wrap="square" anchor="t" lIns="45720" rIns="45720">
+            <a:spAutoFit/>
+          </a:bodyPr>
+          <a:lstStyle/>
+          <a:p>
+            <a:pPr algn="ctr"/>
+            <a:r>
+              <a:rPr sz="1200" b="0" i="0">
+                <a:solidFill>
+                  <a:srgbClr val="595959"/>
+                </a:solidFill>
+                <a:latin typeface="Calibri"/>
+              </a:rPr>
+              <a:t>Feature attention (mean weight)</a:t>
+            </a:r>
+          </a:p>
+        </p:txBody>
+      </p:sp>
+      <p:sp>
+        <p:nvSpPr>
+          <p:cNvPr id="8" name="TextBox 7"/>
+          <p:cNvSpPr txBox="1"/>
+          <p:nvPr/>
+        </p:nvSpPr>
+        <p:spPr>
+          <a:xfrm>
+            <a:off x="365760" y="6446520"/>
+            <a:ext cx="8412480" cy="274320"/>
+          </a:xfrm>
+          <a:prstGeom prst="rect">
+            <a:avLst/>
+          </a:prstGeom>
+          <a:noFill/>
+        </p:spPr>
+        <p:txBody>
+          <a:bodyPr wrap="square" anchor="t" lIns="45720" rIns="45720">
+            <a:spAutoFit/>
+          </a:bodyPr>
+          <a:lstStyle/>
+          <a:p>
+            <a:pPr algn="r"/>
+            <a:r>
+              <a:rPr sz="1000" b="0" i="0">
+                <a:solidFill>
+                  <a:srgbClr val="595959"/>
+                </a:solidFill>
+                <a:latin typeface="Calibri"/>
+              </a:rPr>
+              <a:t>Presenter: Devanshu Kumar</a:t>
+            </a:r>
+          </a:p>
+        </p:txBody>
+      </p:sp>
+    </p:spTree>
+  </p:cSld>
+  <p:clrMapOvr>
+    <a:masterClrMapping/>
+  </p:clrMapOvr>
+</p:sld>
+</file>
+
+<file path=ppt/slides/slide24.xml><?xml version="1.0" encoding="utf-8"?>
+<p:sld xmlns:a="http://schemas.openxmlformats.org/drawingml/2006/main" xmlns:p="http://schemas.openxmlformats.org/presentationml/2006/main" xmlns:r="http://schemas.openxmlformats.org/officeDocument/2006/relationships">
+  <p:cSld>
+    <p:spTree>
+      <p:nvGrpSpPr>
+        <p:cNvPr id="1" name=""/>
+        <p:cNvGrpSpPr/>
+        <p:nvPr/>
+      </p:nvGrpSpPr>
+      <p:grpSpPr/>
+      <p:sp>
+        <p:nvSpPr>
+          <p:cNvPr id="2" name="Title 1"/>
+          <p:cNvSpPr>
+            <a:spLocks noGrp="1"/>
+          </p:cNvSpPr>
+          <p:nvPr>
+            <p:ph type="title"/>
+          </p:nvPr>
+        </p:nvSpPr>
+        <p:spPr>
+          <a:xfrm>
+            <a:off x="365760" y="274320"/>
+            <a:ext cx="6355080" cy="822960"/>
+          </a:xfrm>
+        </p:spPr>
+        <p:txBody>
+          <a:bodyPr wrap="square" anchor="ctr" lIns="45720"/>
+          <a:lstStyle/>
+          <a:p>
+            <a:pPr algn="l"/>
+            <a:r>
+              <a:rPr sz="2800" b="1" i="0">
+                <a:solidFill>
+                  <a:srgbClr val="1B3A6B"/>
+                </a:solidFill>
+                <a:latin typeface="Times New Roman"/>
+              </a:rPr>
+              <a:t>Ablation (Figure)</a:t>
+            </a:r>
+          </a:p>
+        </p:txBody>
+      </p:sp>
+      <p:pic>
+        <p:nvPicPr>
+          <p:cNvPr id="3" name="Picture 2" descr="image.jpeg"/>
+          <p:cNvPicPr>
+            <a:picLocks noChangeAspect="1"/>
+          </p:cNvPicPr>
+          <p:nvPr/>
+        </p:nvPicPr>
+        <p:blipFill>
+          <a:blip r:embed="rId2"/>
+          <a:stretch>
+            <a:fillRect/>
+          </a:stretch>
+        </p:blipFill>
+        <p:spPr>
+          <a:xfrm>
+            <a:off x="6858000" y="228600"/>
+            <a:ext cx="2066925" cy="857250"/>
+          </a:xfrm>
+          <a:prstGeom prst="rect">
+            <a:avLst/>
+          </a:prstGeom>
+        </p:spPr>
+      </p:pic>
+      <p:pic>
+        <p:nvPicPr>
+          <p:cNvPr id="4" name="Picture 3" descr="ablation.png"/>
+          <p:cNvPicPr>
+            <a:picLocks noChangeAspect="1"/>
+          </p:cNvPicPr>
+          <p:nvPr/>
+        </p:nvPicPr>
+        <p:blipFill>
+          <a:blip r:embed="rId4"/>
+          <a:stretch>
+            <a:fillRect/>
+          </a:stretch>
+        </p:blipFill>
+        <p:spPr>
+          <a:xfrm>
+            <a:off x="365760" y="1778292"/>
+            <a:ext cx="8412480" cy="3484294"/>
+          </a:xfrm>
+          <a:prstGeom prst="rect">
+            <a:avLst/>
+          </a:prstGeom>
+        </p:spPr>
+      </p:pic>
+      <p:sp>
+        <p:nvSpPr>
+          <p:cNvPr id="5" name="TextBox 4"/>
+          <p:cNvSpPr txBox="1"/>
+          <p:nvPr/>
+        </p:nvSpPr>
+        <p:spPr>
+          <a:xfrm>
+            <a:off x="365760" y="5897880"/>
+            <a:ext cx="8412480" cy="457200"/>
+          </a:xfrm>
+          <a:prstGeom prst="rect">
+            <a:avLst/>
+          </a:prstGeom>
+          <a:noFill/>
+        </p:spPr>
+        <p:txBody>
+          <a:bodyPr wrap="square" anchor="t" lIns="45720" rIns="45720">
+            <a:spAutoFit/>
+          </a:bodyPr>
+          <a:lstStyle/>
+          <a:p>
+            <a:pPr algn="ctr"/>
+            <a:r>
+              <a:rPr sz="1200" b="0" i="0">
+                <a:solidFill>
+                  <a:srgbClr val="595959"/>
+                </a:solidFill>
+                <a:latin typeface="Calibri"/>
+              </a:rPr>
+              <a:t>Ablation: one A-CPN component removed at a time</a:t>
+            </a:r>
+          </a:p>
+        </p:txBody>
+      </p:sp>
+      <p:sp>
+        <p:nvSpPr>
+          <p:cNvPr id="6" name="TextBox 5"/>
+          <p:cNvSpPr txBox="1"/>
+          <p:nvPr/>
+        </p:nvSpPr>
+        <p:spPr>
+          <a:xfrm>
+            <a:off x="365760" y="6446520"/>
+            <a:ext cx="8412480" cy="274320"/>
+          </a:xfrm>
+          <a:prstGeom prst="rect">
+            <a:avLst/>
+          </a:prstGeom>
+          <a:noFill/>
+        </p:spPr>
+        <p:txBody>
+          <a:bodyPr wrap="square" anchor="t" lIns="45720" rIns="45720">
+            <a:spAutoFit/>
+          </a:bodyPr>
+          <a:lstStyle/>
+          <a:p>
+            <a:pPr algn="r"/>
+            <a:r>
+              <a:rPr sz="1000" b="0" i="0">
+                <a:solidFill>
+                  <a:srgbClr val="595959"/>
+                </a:solidFill>
+                <a:latin typeface="Calibri"/>
+              </a:rPr>
+              <a:t>Presenter: Devanshu Kumar</a:t>
+            </a:r>
+          </a:p>
+        </p:txBody>
+      </p:sp>
+    </p:spTree>
+  </p:cSld>
+  <p:clrMapOvr>
+    <a:masterClrMapping/>
+  </p:clrMapOvr>
+</p:sld>
+</file>
+
+<file path=ppt/slides/slide25.xml><?xml version="1.0" encoding="utf-8"?>
+<p:sld xmlns:a="http://schemas.openxmlformats.org/drawingml/2006/main" xmlns:p="http://schemas.openxmlformats.org/presentationml/2006/main" xmlns:r="http://schemas.openxmlformats.org/officeDocument/2006/relationships">
+  <p:cSld>
+    <p:spTree>
+      <p:nvGrpSpPr>
+        <p:cNvPr id="1" name=""/>
+        <p:cNvGrpSpPr/>
+        <p:nvPr/>
+      </p:nvGrpSpPr>
+      <p:grpSpPr/>
+      <p:sp>
+        <p:nvSpPr>
+          <p:cNvPr id="2" name="Title 1"/>
+          <p:cNvSpPr>
+            <a:spLocks noGrp="1"/>
+          </p:cNvSpPr>
+          <p:nvPr>
+            <p:ph type="title"/>
+          </p:nvPr>
+        </p:nvSpPr>
+        <p:spPr>
+          <a:xfrm>
+            <a:off x="365760" y="274320"/>
+            <a:ext cx="6355080" cy="822960"/>
+          </a:xfrm>
+        </p:spPr>
+        <p:txBody>
+          <a:bodyPr wrap="square" anchor="ctr" lIns="45720"/>
+          <a:lstStyle/>
+          <a:p>
+            <a:pPr algn="l"/>
+            <a:r>
+              <a:rPr sz="2800" b="1" i="0">
+                <a:solidFill>
+                  <a:srgbClr val="1B3A6B"/>
+                </a:solidFill>
+                <a:latin typeface="Times New Roman"/>
+              </a:rPr>
+              <a:t>Climate-Push Visualisation</a:t>
+            </a:r>
+          </a:p>
+        </p:txBody>
+      </p:sp>
+      <p:pic>
+        <p:nvPicPr>
+          <p:cNvPr id="3" name="Picture 2" descr="image.jpeg"/>
+          <p:cNvPicPr>
+            <a:picLocks noChangeAspect="1"/>
+          </p:cNvPicPr>
+          <p:nvPr/>
+        </p:nvPicPr>
+        <p:blipFill>
+          <a:blip r:embed="rId2"/>
+          <a:stretch>
+            <a:fillRect/>
+          </a:stretch>
+        </p:blipFill>
+        <p:spPr>
+          <a:xfrm>
+            <a:off x="6858000" y="228600"/>
+            <a:ext cx="2066925" cy="857250"/>
+          </a:xfrm>
+          <a:prstGeom prst="rect">
+            <a:avLst/>
+          </a:prstGeom>
+        </p:spPr>
+      </p:pic>
+      <p:pic>
+        <p:nvPicPr>
+          <p:cNvPr id="4" name="Picture 3" descr="climate_push_by_quadrant.png"/>
+          <p:cNvPicPr>
+            <a:picLocks noChangeAspect="1"/>
+          </p:cNvPicPr>
+          <p:nvPr/>
+        </p:nvPicPr>
+        <p:blipFill>
+          <a:blip r:embed="rId4"/>
+          <a:stretch>
+            <a:fillRect/>
+          </a:stretch>
+        </p:blipFill>
+        <p:spPr>
+          <a:xfrm>
+            <a:off x="365760" y="2225613"/>
+            <a:ext cx="4114800" cy="2589653"/>
+          </a:xfrm>
+          <a:prstGeom prst="rect">
+            <a:avLst/>
+          </a:prstGeom>
+        </p:spPr>
+      </p:pic>
+      <p:pic>
+        <p:nvPicPr>
+          <p:cNvPr id="5" name="Picture 4" descr="climate_push_map.png"/>
+          <p:cNvPicPr>
+            <a:picLocks noChangeAspect="1"/>
+          </p:cNvPicPr>
+          <p:nvPr/>
+        </p:nvPicPr>
+        <p:blipFill>
+          <a:blip r:embed="rId5"/>
+          <a:stretch>
+            <a:fillRect/>
+          </a:stretch>
+        </p:blipFill>
+        <p:spPr>
+          <a:xfrm>
+            <a:off x="4663440" y="1681213"/>
+            <a:ext cx="4114800" cy="3678452"/>
+          </a:xfrm>
+          <a:prstGeom prst="rect">
+            <a:avLst/>
+          </a:prstGeom>
+        </p:spPr>
+      </p:pic>
+      <p:sp>
+        <p:nvSpPr>
+          <p:cNvPr id="6" name="TextBox 5"/>
+          <p:cNvSpPr txBox="1"/>
+          <p:nvPr/>
+        </p:nvSpPr>
+        <p:spPr>
+          <a:xfrm>
+            <a:off x="365760" y="5897880"/>
+            <a:ext cx="4114800" cy="457200"/>
+          </a:xfrm>
+          <a:prstGeom prst="rect">
+            <a:avLst/>
+          </a:prstGeom>
+          <a:noFill/>
+        </p:spPr>
+        <p:txBody>
+          <a:bodyPr wrap="square" anchor="t" lIns="45720" rIns="45720">
+            <a:spAutoFit/>
+          </a:bodyPr>
+          <a:lstStyle/>
+          <a:p>
+            <a:pPr algn="ctr"/>
+            <a:r>
+              <a:rPr sz="1200" b="0" i="0">
+                <a:solidFill>
+                  <a:srgbClr val="595959"/>
+                </a:solidFill>
+                <a:latin typeface="Calibri"/>
+              </a:rPr>
+              <a:t>Climate push by group (bar = mean)</a:t>
+            </a:r>
+          </a:p>
+        </p:txBody>
+      </p:sp>
+      <p:sp>
+        <p:nvSpPr>
+          <p:cNvPr id="7" name="TextBox 6"/>
+          <p:cNvSpPr txBox="1"/>
+          <p:nvPr/>
+        </p:nvSpPr>
+        <p:spPr>
+          <a:xfrm>
+            <a:off x="4663440" y="5897880"/>
+            <a:ext cx="4114800" cy="457200"/>
+          </a:xfrm>
+          <a:prstGeom prst="rect">
+            <a:avLst/>
+          </a:prstGeom>
+          <a:noFill/>
+        </p:spPr>
+        <p:txBody>
+          <a:bodyPr wrap="square" anchor="t" lIns="45720" rIns="45720">
+            <a:spAutoFit/>
+          </a:bodyPr>
+          <a:lstStyle/>
+          <a:p>
+            <a:pPr algn="ctr"/>
+            <a:r>
+              <a:rPr sz="1200" b="0" i="0">
+                <a:solidFill>
+                  <a:srgbClr val="595959"/>
+                </a:solidFill>
+                <a:latin typeface="Calibri"/>
+              </a:rPr>
+              <a:t>Climate push per district (469)</a:t>
+            </a:r>
+          </a:p>
+        </p:txBody>
+      </p:sp>
+      <p:sp>
+        <p:nvSpPr>
+          <p:cNvPr id="8" name="TextBox 7"/>
+          <p:cNvSpPr txBox="1"/>
+          <p:nvPr/>
+        </p:nvSpPr>
+        <p:spPr>
+          <a:xfrm>
+            <a:off x="365760" y="6446520"/>
+            <a:ext cx="8412480" cy="274320"/>
+          </a:xfrm>
+          <a:prstGeom prst="rect">
+            <a:avLst/>
+          </a:prstGeom>
+          <a:noFill/>
+        </p:spPr>
+        <p:txBody>
+          <a:bodyPr wrap="square" anchor="t" lIns="45720" rIns="45720">
+            <a:spAutoFit/>
+          </a:bodyPr>
+          <a:lstStyle/>
+          <a:p>
+            <a:pPr algn="r"/>
+            <a:r>
+              <a:rPr sz="1000" b="0" i="0">
+                <a:solidFill>
+                  <a:srgbClr val="595959"/>
+                </a:solidFill>
+                <a:latin typeface="Calibri"/>
+              </a:rPr>
+              <a:t>Presenter: Devanshu Kumar</a:t>
+            </a:r>
+          </a:p>
+        </p:txBody>
+      </p:sp>
+    </p:spTree>
+  </p:cSld>
+  <p:clrMapOvr>
+    <a:masterClrMapping/>
+  </p:clrMapOvr>
+</p:sld>
+</file>
+
+<file path=ppt/slides/slide26.xml><?xml version="1.0" encoding="utf-8"?>
 <p:sld xmlns:a="http://schemas.openxmlformats.org/drawingml/2006/main" xmlns:p="http://schemas.openxmlformats.org/presentationml/2006/main" xmlns:r="http://schemas.openxmlformats.org/officeDocument/2006/relationships">
   <p:cSld>
     <p:spTree>
@@ -19542,7 +20309,7 @@
                 </a:solidFill>
                 <a:latin typeface="Calibri"/>
               </a:rPr>
-              <a:t>Presenter: Devanshu Kumar</a:t>
+              <a:t>Presenter: Tanmay Singh</a:t>
             </a:r>
           </a:p>
         </p:txBody>
@@ -19555,7 +20322,7 @@
 </p:sld>
 </file>
 
-<file path=ppt/slides/slide24.xml><?xml version="1.0" encoding="utf-8"?>
+<file path=ppt/slides/slide27.xml><?xml version="1.0" encoding="utf-8"?>
 <p:sld xmlns:a="http://schemas.openxmlformats.org/drawingml/2006/main" xmlns:p="http://schemas.openxmlformats.org/presentationml/2006/main" xmlns:r="http://schemas.openxmlformats.org/officeDocument/2006/relationships">
   <p:cSld>
     <p:spTree>
@@ -19593,7 +20360,7 @@
                 </a:solidFill>
                 <a:latin typeface="Times New Roman"/>
               </a:rPr>
-              <a:t>Confusion Matrix &amp; Stability (Figures)</a:t>
+              <a:t>Confusion Matrices &amp; Stability (Figures)</a:t>
             </a:r>
           </a:p>
         </p:txBody>
@@ -19624,7 +20391,7 @@
       </p:pic>
       <p:pic>
         <p:nvPicPr>
-          <p:cNvPr id="4" name="Picture 3" descr="confusion_acpn.png"/>
+          <p:cNvPr id="4" name="Picture 3" descr="confusion_matrices.png"/>
           <p:cNvPicPr>
             <a:picLocks noChangeAspect="1"/>
           </p:cNvPicPr>
@@ -19638,8 +20405,8 @@
         </p:blipFill>
         <p:spPr>
           <a:xfrm>
-            <a:off x="365760" y="1619648"/>
-            <a:ext cx="4114800" cy="3801583"/>
+            <a:off x="2609144" y="1188720"/>
+            <a:ext cx="3925710" cy="2423160"/>
           </a:xfrm>
           <a:prstGeom prst="rect">
             <a:avLst/>
@@ -19662,8 +20429,8 @@
         </p:blipFill>
         <p:spPr>
           <a:xfrm>
-            <a:off x="4663440" y="2429283"/>
-            <a:ext cx="4114800" cy="2182313"/>
+            <a:off x="2287539" y="3703320"/>
+            <a:ext cx="4568921" cy="2423160"/>
           </a:xfrm>
           <a:prstGeom prst="rect">
             <a:avLst/>
@@ -19678,8 +20445,8 @@
         </p:nvSpPr>
         <p:spPr>
           <a:xfrm>
-            <a:off x="365760" y="5897880"/>
-            <a:ext cx="4114800" cy="457200"/>
+            <a:off x="365760" y="6144768"/>
+            <a:ext cx="8412480" cy="292608"/>
           </a:xfrm>
           <a:prstGeom prst="rect">
             <a:avLst/>
@@ -19700,7 +20467,7 @@
                 </a:solidFill>
                 <a:latin typeface="Calibri"/>
               </a:rPr>
-              <a:t>A-CPN confusion matrix (25 folds)</a:t>
+              <a:t>Top: Confusion matrices, all models.  Bottom: ROC-AUC per fold, all models.</a:t>
             </a:r>
           </a:p>
         </p:txBody>
@@ -19708,41 +20475,6 @@
       <p:sp>
         <p:nvSpPr>
           <p:cNvPr id="7" name="TextBox 6"/>
-          <p:cNvSpPr txBox="1"/>
-          <p:nvPr/>
-        </p:nvSpPr>
-        <p:spPr>
-          <a:xfrm>
-            <a:off x="4663440" y="5897880"/>
-            <a:ext cx="4114800" cy="457200"/>
-          </a:xfrm>
-          <a:prstGeom prst="rect">
-            <a:avLst/>
-          </a:prstGeom>
-          <a:noFill/>
-        </p:spPr>
-        <p:txBody>
-          <a:bodyPr wrap="square" anchor="t" lIns="45720" rIns="45720">
-            <a:spAutoFit/>
-          </a:bodyPr>
-          <a:lstStyle/>
-          <a:p>
-            <a:pPr algn="ctr"/>
-            <a:r>
-              <a:rPr sz="1200" b="0" i="0">
-                <a:solidFill>
-                  <a:srgbClr val="595959"/>
-                </a:solidFill>
-                <a:latin typeface="Calibri"/>
-              </a:rPr>
-              <a:t>ROC-AUC per fold, all models</a:t>
-            </a:r>
-          </a:p>
-        </p:txBody>
-      </p:sp>
-      <p:sp>
-        <p:nvSpPr>
-          <p:cNvPr id="8" name="TextBox 7"/>
           <p:cNvSpPr txBox="1"/>
           <p:nvPr/>
         </p:nvSpPr>
@@ -19770,7 +20502,7 @@
                 </a:solidFill>
                 <a:latin typeface="Calibri"/>
               </a:rPr>
-              <a:t>Presenter: Devanshu Kumar</a:t>
+              <a:t>Presenter: Tanmay Singh</a:t>
             </a:r>
           </a:p>
         </p:txBody>
@@ -19783,7 +20515,7 @@
 </p:sld>
 </file>
 
-<file path=ppt/slides/slide25.xml><?xml version="1.0" encoding="utf-8"?>
+<file path=ppt/slides/slide28.xml><?xml version="1.0" encoding="utf-8"?>
 <p:sld xmlns:a="http://schemas.openxmlformats.org/drawingml/2006/main" xmlns:p="http://schemas.openxmlformats.org/presentationml/2006/main" xmlns:r="http://schemas.openxmlformats.org/officeDocument/2006/relationships">
   <p:cSld>
     <p:spTree>
@@ -19815,13 +20547,13 @@
           <a:p>
             <a:pPr algn="l"/>
             <a:r>
-              <a:rPr sz="2600" b="1" i="0">
+              <a:rPr sz="2800" b="1" i="0">
                 <a:solidFill>
                   <a:srgbClr val="1B3A6B"/>
                 </a:solidFill>
                 <a:latin typeface="Times New Roman"/>
               </a:rPr>
-              <a:t>Preprocessing Gain &amp; Ablation (Figures)</a:t>
+              <a:t>Effect of Preprocessing (Figure)</a:t>
             </a:r>
           </a:p>
         </p:txBody>
@@ -19866,48 +20598,24 @@
         </p:blipFill>
         <p:spPr>
           <a:xfrm>
-            <a:off x="2084960" y="1188720"/>
-            <a:ext cx="4974078" cy="2423160"/>
+            <a:off x="365760" y="1471338"/>
+            <a:ext cx="8412480" cy="4098203"/>
           </a:xfrm>
           <a:prstGeom prst="rect">
             <a:avLst/>
           </a:prstGeom>
         </p:spPr>
       </p:pic>
-      <p:pic>
-        <p:nvPicPr>
-          <p:cNvPr id="5" name="Picture 4" descr="ablation.png"/>
-          <p:cNvPicPr>
-            <a:picLocks noChangeAspect="1"/>
-          </p:cNvPicPr>
+      <p:sp>
+        <p:nvSpPr>
+          <p:cNvPr id="5" name="TextBox 4"/>
+          <p:cNvSpPr txBox="1"/>
           <p:nvPr/>
-        </p:nvPicPr>
-        <p:blipFill>
-          <a:blip r:embed="rId5"/>
-          <a:stretch>
-            <a:fillRect/>
-          </a:stretch>
-        </p:blipFill>
+        </p:nvSpPr>
         <p:spPr>
           <a:xfrm>
-            <a:off x="1646761" y="3703320"/>
-            <a:ext cx="5850477" cy="2423160"/>
-          </a:xfrm>
-          <a:prstGeom prst="rect">
-            <a:avLst/>
-          </a:prstGeom>
-        </p:spPr>
-      </p:pic>
-      <p:sp>
-        <p:nvSpPr>
-          <p:cNvPr id="6" name="TextBox 5"/>
-          <p:cNvSpPr txBox="1"/>
-          <p:nvPr/>
-        </p:nvSpPr>
-        <p:spPr>
-          <a:xfrm>
-            <a:off x="365760" y="6144768"/>
-            <a:ext cx="8412480" cy="292608"/>
+            <a:off x="365760" y="5897880"/>
+            <a:ext cx="8412480" cy="457200"/>
           </a:xfrm>
           <a:prstGeom prst="rect">
             <a:avLst/>
@@ -19928,14 +20636,14 @@
                 </a:solidFill>
                 <a:latin typeface="Calibri"/>
               </a:rPr>
-              <a:t>Top: Model ROC-AUC before vs after preprocessing.  Bottom: Ablation: one component removed at a time.</a:t>
+              <a:t>Model ROC-AUC before vs after preprocessing (label = gain)</a:t>
             </a:r>
           </a:p>
         </p:txBody>
       </p:sp>
       <p:sp>
         <p:nvSpPr>
-          <p:cNvPr id="7" name="TextBox 6"/>
+          <p:cNvPr id="6" name="TextBox 5"/>
           <p:cNvSpPr txBox="1"/>
           <p:nvPr/>
         </p:nvSpPr>
@@ -19963,7 +20671,7 @@
                 </a:solidFill>
                 <a:latin typeface="Calibri"/>
               </a:rPr>
-              <a:t>Presenter: Devanshu Kumar</a:t>
+              <a:t>Presenter: Tanmay Singh</a:t>
             </a:r>
           </a:p>
         </p:txBody>
@@ -19976,7 +20684,7 @@
 </p:sld>
 </file>
 
-<file path=ppt/slides/slide26.xml><?xml version="1.0" encoding="utf-8"?>
+<file path=ppt/slides/slide29.xml><?xml version="1.0" encoding="utf-8"?>
 <p:sld xmlns:a="http://schemas.openxmlformats.org/drawingml/2006/main" xmlns:p="http://schemas.openxmlformats.org/presentationml/2006/main" xmlns:r="http://schemas.openxmlformats.org/officeDocument/2006/relationships">
   <p:cSld>
     <p:spTree>
@@ -20014,7 +20722,7 @@
                 </a:solidFill>
                 <a:latin typeface="Times New Roman"/>
               </a:rPr>
-              <a:t>Climate-Push Visualisation</a:t>
+              <a:t>Key Findings</a:t>
             </a:r>
           </a:p>
         </p:txBody>
@@ -20043,234 +20751,6 @@
           </a:prstGeom>
         </p:spPr>
       </p:pic>
-      <p:pic>
-        <p:nvPicPr>
-          <p:cNvPr id="4" name="Picture 3" descr="climate_push_by_quadrant.png"/>
-          <p:cNvPicPr>
-            <a:picLocks noChangeAspect="1"/>
-          </p:cNvPicPr>
-          <p:nvPr/>
-        </p:nvPicPr>
-        <p:blipFill>
-          <a:blip r:embed="rId4"/>
-          <a:stretch>
-            <a:fillRect/>
-          </a:stretch>
-        </p:blipFill>
-        <p:spPr>
-          <a:xfrm>
-            <a:off x="365760" y="2225613"/>
-            <a:ext cx="4114800" cy="2589653"/>
-          </a:xfrm>
-          <a:prstGeom prst="rect">
-            <a:avLst/>
-          </a:prstGeom>
-        </p:spPr>
-      </p:pic>
-      <p:pic>
-        <p:nvPicPr>
-          <p:cNvPr id="5" name="Picture 4" descr="climate_push_map.png"/>
-          <p:cNvPicPr>
-            <a:picLocks noChangeAspect="1"/>
-          </p:cNvPicPr>
-          <p:nvPr/>
-        </p:nvPicPr>
-        <p:blipFill>
-          <a:blip r:embed="rId5"/>
-          <a:stretch>
-            <a:fillRect/>
-          </a:stretch>
-        </p:blipFill>
-        <p:spPr>
-          <a:xfrm>
-            <a:off x="4663440" y="1681213"/>
-            <a:ext cx="4114800" cy="3678452"/>
-          </a:xfrm>
-          <a:prstGeom prst="rect">
-            <a:avLst/>
-          </a:prstGeom>
-        </p:spPr>
-      </p:pic>
-      <p:sp>
-        <p:nvSpPr>
-          <p:cNvPr id="6" name="TextBox 5"/>
-          <p:cNvSpPr txBox="1"/>
-          <p:nvPr/>
-        </p:nvSpPr>
-        <p:spPr>
-          <a:xfrm>
-            <a:off x="365760" y="5897880"/>
-            <a:ext cx="4114800" cy="457200"/>
-          </a:xfrm>
-          <a:prstGeom prst="rect">
-            <a:avLst/>
-          </a:prstGeom>
-          <a:noFill/>
-        </p:spPr>
-        <p:txBody>
-          <a:bodyPr wrap="square" anchor="t" lIns="45720" rIns="45720">
-            <a:spAutoFit/>
-          </a:bodyPr>
-          <a:lstStyle/>
-          <a:p>
-            <a:pPr algn="ctr"/>
-            <a:r>
-              <a:rPr sz="1200" b="0" i="0">
-                <a:solidFill>
-                  <a:srgbClr val="595959"/>
-                </a:solidFill>
-                <a:latin typeface="Calibri"/>
-              </a:rPr>
-              <a:t>Climate push by group (bar = mean)</a:t>
-            </a:r>
-          </a:p>
-        </p:txBody>
-      </p:sp>
-      <p:sp>
-        <p:nvSpPr>
-          <p:cNvPr id="7" name="TextBox 6"/>
-          <p:cNvSpPr txBox="1"/>
-          <p:nvPr/>
-        </p:nvSpPr>
-        <p:spPr>
-          <a:xfrm>
-            <a:off x="4663440" y="5897880"/>
-            <a:ext cx="4114800" cy="457200"/>
-          </a:xfrm>
-          <a:prstGeom prst="rect">
-            <a:avLst/>
-          </a:prstGeom>
-          <a:noFill/>
-        </p:spPr>
-        <p:txBody>
-          <a:bodyPr wrap="square" anchor="t" lIns="45720" rIns="45720">
-            <a:spAutoFit/>
-          </a:bodyPr>
-          <a:lstStyle/>
-          <a:p>
-            <a:pPr algn="ctr"/>
-            <a:r>
-              <a:rPr sz="1200" b="0" i="0">
-                <a:solidFill>
-                  <a:srgbClr val="595959"/>
-                </a:solidFill>
-                <a:latin typeface="Calibri"/>
-              </a:rPr>
-              <a:t>Climate push per district (469)</a:t>
-            </a:r>
-          </a:p>
-        </p:txBody>
-      </p:sp>
-      <p:sp>
-        <p:nvSpPr>
-          <p:cNvPr id="8" name="TextBox 7"/>
-          <p:cNvSpPr txBox="1"/>
-          <p:nvPr/>
-        </p:nvSpPr>
-        <p:spPr>
-          <a:xfrm>
-            <a:off x="365760" y="6446520"/>
-            <a:ext cx="8412480" cy="274320"/>
-          </a:xfrm>
-          <a:prstGeom prst="rect">
-            <a:avLst/>
-          </a:prstGeom>
-          <a:noFill/>
-        </p:spPr>
-        <p:txBody>
-          <a:bodyPr wrap="square" anchor="t" lIns="45720" rIns="45720">
-            <a:spAutoFit/>
-          </a:bodyPr>
-          <a:lstStyle/>
-          <a:p>
-            <a:pPr algn="r"/>
-            <a:r>
-              <a:rPr sz="1000" b="0" i="0">
-                <a:solidFill>
-                  <a:srgbClr val="595959"/>
-                </a:solidFill>
-                <a:latin typeface="Calibri"/>
-              </a:rPr>
-              <a:t>Presenter: Devanshu Kumar</a:t>
-            </a:r>
-          </a:p>
-        </p:txBody>
-      </p:sp>
-    </p:spTree>
-  </p:cSld>
-  <p:clrMapOvr>
-    <a:masterClrMapping/>
-  </p:clrMapOvr>
-</p:sld>
-</file>
-
-<file path=ppt/slides/slide27.xml><?xml version="1.0" encoding="utf-8"?>
-<p:sld xmlns:a="http://schemas.openxmlformats.org/drawingml/2006/main" xmlns:p="http://schemas.openxmlformats.org/presentationml/2006/main" xmlns:r="http://schemas.openxmlformats.org/officeDocument/2006/relationships">
-  <p:cSld>
-    <p:spTree>
-      <p:nvGrpSpPr>
-        <p:cNvPr id="1" name=""/>
-        <p:cNvGrpSpPr/>
-        <p:nvPr/>
-      </p:nvGrpSpPr>
-      <p:grpSpPr/>
-      <p:sp>
-        <p:nvSpPr>
-          <p:cNvPr id="2" name="Title 1"/>
-          <p:cNvSpPr>
-            <a:spLocks noGrp="1"/>
-          </p:cNvSpPr>
-          <p:nvPr>
-            <p:ph type="title"/>
-          </p:nvPr>
-        </p:nvSpPr>
-        <p:spPr>
-          <a:xfrm>
-            <a:off x="365760" y="274320"/>
-            <a:ext cx="6355080" cy="822960"/>
-          </a:xfrm>
-        </p:spPr>
-        <p:txBody>
-          <a:bodyPr wrap="square" anchor="ctr" lIns="45720"/>
-          <a:lstStyle/>
-          <a:p>
-            <a:pPr algn="l"/>
-            <a:r>
-              <a:rPr sz="2800" b="1" i="0">
-                <a:solidFill>
-                  <a:srgbClr val="1B3A6B"/>
-                </a:solidFill>
-                <a:latin typeface="Times New Roman"/>
-              </a:rPr>
-              <a:t>Key Findings</a:t>
-            </a:r>
-          </a:p>
-        </p:txBody>
-      </p:sp>
-      <p:pic>
-        <p:nvPicPr>
-          <p:cNvPr id="3" name="Picture 2" descr="image.jpeg"/>
-          <p:cNvPicPr>
-            <a:picLocks noChangeAspect="1"/>
-          </p:cNvPicPr>
-          <p:nvPr/>
-        </p:nvPicPr>
-        <p:blipFill>
-          <a:blip r:embed="rId2"/>
-          <a:stretch>
-            <a:fillRect/>
-          </a:stretch>
-        </p:blipFill>
-        <p:spPr>
-          <a:xfrm>
-            <a:off x="6858000" y="228600"/>
-            <a:ext cx="2066925" cy="857250"/>
-          </a:xfrm>
-          <a:prstGeom prst="rect">
-            <a:avLst/>
-          </a:prstGeom>
-        </p:spPr>
-      </p:pic>
       <p:sp>
         <p:nvSpPr>
           <p:cNvPr id="4" name="TextBox 3"/>
@@ -20554,1207 +21034,6 @@
       <p:sp>
         <p:nvSpPr>
           <p:cNvPr id="7" name="TextBox 6"/>
-          <p:cNvSpPr txBox="1"/>
-          <p:nvPr/>
-        </p:nvSpPr>
-        <p:spPr>
-          <a:xfrm>
-            <a:off x="365760" y="6446520"/>
-            <a:ext cx="8412480" cy="274320"/>
-          </a:xfrm>
-          <a:prstGeom prst="rect">
-            <a:avLst/>
-          </a:prstGeom>
-          <a:noFill/>
-        </p:spPr>
-        <p:txBody>
-          <a:bodyPr wrap="square" anchor="t" lIns="45720" rIns="45720">
-            <a:spAutoFit/>
-          </a:bodyPr>
-          <a:lstStyle/>
-          <a:p>
-            <a:pPr algn="r"/>
-            <a:r>
-              <a:rPr sz="1000" b="0" i="0">
-                <a:solidFill>
-                  <a:srgbClr val="595959"/>
-                </a:solidFill>
-                <a:latin typeface="Calibri"/>
-              </a:rPr>
-              <a:t>Presenter: Tanmay Singh</a:t>
-            </a:r>
-          </a:p>
-        </p:txBody>
-      </p:sp>
-    </p:spTree>
-  </p:cSld>
-  <p:clrMapOvr>
-    <a:masterClrMapping/>
-  </p:clrMapOvr>
-</p:sld>
-</file>
-
-<file path=ppt/slides/slide28.xml><?xml version="1.0" encoding="utf-8"?>
-<p:sld xmlns:a="http://schemas.openxmlformats.org/drawingml/2006/main" xmlns:p="http://schemas.openxmlformats.org/presentationml/2006/main" xmlns:r="http://schemas.openxmlformats.org/officeDocument/2006/relationships">
-  <p:cSld>
-    <p:spTree>
-      <p:nvGrpSpPr>
-        <p:cNvPr id="1" name=""/>
-        <p:cNvGrpSpPr/>
-        <p:nvPr/>
-      </p:nvGrpSpPr>
-      <p:grpSpPr/>
-      <p:sp>
-        <p:nvSpPr>
-          <p:cNvPr id="2" name="Title 1"/>
-          <p:cNvSpPr>
-            <a:spLocks noGrp="1"/>
-          </p:cNvSpPr>
-          <p:nvPr>
-            <p:ph type="title"/>
-          </p:nvPr>
-        </p:nvSpPr>
-        <p:spPr>
-          <a:xfrm>
-            <a:off x="365760" y="274320"/>
-            <a:ext cx="6355080" cy="822960"/>
-          </a:xfrm>
-        </p:spPr>
-        <p:txBody>
-          <a:bodyPr wrap="square" anchor="ctr" lIns="45720"/>
-          <a:lstStyle/>
-          <a:p>
-            <a:pPr algn="l"/>
-            <a:r>
-              <a:rPr sz="2800" b="1" i="0">
-                <a:solidFill>
-                  <a:srgbClr val="1B3A6B"/>
-                </a:solidFill>
-                <a:latin typeface="Times New Roman"/>
-              </a:rPr>
-              <a:t>Plan of Action / Member Tasks</a:t>
-            </a:r>
-          </a:p>
-        </p:txBody>
-      </p:sp>
-      <p:pic>
-        <p:nvPicPr>
-          <p:cNvPr id="3" name="Picture 2" descr="image.jpeg"/>
-          <p:cNvPicPr>
-            <a:picLocks noChangeAspect="1"/>
-          </p:cNvPicPr>
-          <p:nvPr/>
-        </p:nvPicPr>
-        <p:blipFill>
-          <a:blip r:embed="rId2"/>
-          <a:stretch>
-            <a:fillRect/>
-          </a:stretch>
-        </p:blipFill>
-        <p:spPr>
-          <a:xfrm>
-            <a:off x="6858000" y="228600"/>
-            <a:ext cx="2066925" cy="857250"/>
-          </a:xfrm>
-          <a:prstGeom prst="rect">
-            <a:avLst/>
-          </a:prstGeom>
-        </p:spPr>
-      </p:pic>
-      <p:graphicFrame>
-        <p:nvGraphicFramePr>
-          <p:cNvPr id="4" name="Table 3"/>
-          <p:cNvGraphicFramePr>
-            <a:graphicFrameLocks noGrp="1"/>
-          </p:cNvGraphicFramePr>
-          <p:nvPr/>
-        </p:nvGraphicFramePr>
-        <p:xfrm>
-          <a:off x="365760" y="1188720"/>
-          <a:ext cx="8412480" cy="4343400"/>
-        </p:xfrm>
-        <a:graphic>
-          <a:graphicData uri="http://schemas.openxmlformats.org/drawingml/2006/table">
-            <a:tbl>
-              <a:tblPr firstRow="1" bandRow="1">
-                <a:tableStyleId>{5C22544A-7EE6-4342-B048-85BDC9FD1C3A}</a:tableStyleId>
-              </a:tblPr>
-              <a:tblGrid>
-                <a:gridCol w="1463040"/>
-                <a:gridCol w="1737360"/>
-                <a:gridCol w="3931920"/>
-                <a:gridCol w="1280160"/>
-              </a:tblGrid>
-              <a:tr h="868680">
-                <a:tc>
-                  <a:txBody>
-                    <a:bodyPr wrap="square"/>
-                    <a:lstStyle/>
-                    <a:p>
-                      <a:pPr algn="l"/>
-                      <a:r>
-                        <a:rPr sz="1100" b="1" i="0">
-                          <a:solidFill>
-                            <a:srgbClr val="FFFFFF"/>
-                          </a:solidFill>
-                          <a:latin typeface="Calibri"/>
-                        </a:rPr>
-                        <a:t>Team member</a:t>
-                      </a:r>
-                    </a:p>
-                  </a:txBody>
-                  <a:tcPr marL="54864" marR="54864" marT="27432" marB="27432" anchor="ctr">
-                    <a:solidFill>
-                      <a:srgbClr val="1B3A6B"/>
-                    </a:solidFill>
-                  </a:tcPr>
-                </a:tc>
-                <a:tc>
-                  <a:txBody>
-                    <a:bodyPr wrap="square"/>
-                    <a:lstStyle/>
-                    <a:p>
-                      <a:pPr algn="ctr"/>
-                      <a:r>
-                        <a:rPr sz="1100" b="1" i="0">
-                          <a:solidFill>
-                            <a:srgbClr val="FFFFFF"/>
-                          </a:solidFill>
-                          <a:latin typeface="Calibri"/>
-                        </a:rPr>
-                        <a:t>Assigned work</a:t>
-                      </a:r>
-                    </a:p>
-                  </a:txBody>
-                  <a:tcPr marL="54864" marR="54864" marT="27432" marB="27432" anchor="ctr">
-                    <a:solidFill>
-                      <a:srgbClr val="1B3A6B"/>
-                    </a:solidFill>
-                  </a:tcPr>
-                </a:tc>
-                <a:tc>
-                  <a:txBody>
-                    <a:bodyPr wrap="square"/>
-                    <a:lstStyle/>
-                    <a:p>
-                      <a:pPr algn="ctr"/>
-                      <a:r>
-                        <a:rPr sz="1100" b="1" i="0">
-                          <a:solidFill>
-                            <a:srgbClr val="FFFFFF"/>
-                          </a:solidFill>
-                          <a:latin typeface="Calibri"/>
-                        </a:rPr>
-                        <a:t>Key responsibilities</a:t>
-                      </a:r>
-                    </a:p>
-                  </a:txBody>
-                  <a:tcPr marL="54864" marR="54864" marT="27432" marB="27432" anchor="ctr">
-                    <a:solidFill>
-                      <a:srgbClr val="1B3A6B"/>
-                    </a:solidFill>
-                  </a:tcPr>
-                </a:tc>
-                <a:tc>
-                  <a:txBody>
-                    <a:bodyPr wrap="square"/>
-                    <a:lstStyle/>
-                    <a:p>
-                      <a:pPr algn="ctr"/>
-                      <a:r>
-                        <a:rPr sz="1100" b="1" i="0">
-                          <a:solidFill>
-                            <a:srgbClr val="FFFFFF"/>
-                          </a:solidFill>
-                          <a:latin typeface="Calibri"/>
-                        </a:rPr>
-                        <a:t>Completion (Review 2)</a:t>
-                      </a:r>
-                    </a:p>
-                  </a:txBody>
-                  <a:tcPr marL="54864" marR="54864" marT="27432" marB="27432" anchor="ctr">
-                    <a:solidFill>
-                      <a:srgbClr val="1B3A6B"/>
-                    </a:solidFill>
-                  </a:tcPr>
-                </a:tc>
-              </a:tr>
-              <a:tr h="868680">
-                <a:tc>
-                  <a:txBody>
-                    <a:bodyPr wrap="square"/>
-                    <a:lstStyle/>
-                    <a:p>
-                      <a:pPr algn="l"/>
-                      <a:r>
-                        <a:rPr sz="1100" b="1" i="0">
-                          <a:solidFill>
-                            <a:srgbClr val="1F1F1F"/>
-                          </a:solidFill>
-                          <a:latin typeface="Calibri"/>
-                        </a:rPr>
-                        <a:t>Sehjodh Grewal</a:t>
-                      </a:r>
-                    </a:p>
-                  </a:txBody>
-                  <a:tcPr marL="54864" marR="54864" marT="27432" marB="27432" anchor="ctr">
-                    <a:solidFill>
-                      <a:srgbClr val="FFFFFF"/>
-                    </a:solidFill>
-                  </a:tcPr>
-                </a:tc>
-                <a:tc>
-                  <a:txBody>
-                    <a:bodyPr wrap="square"/>
-                    <a:lstStyle/>
-                    <a:p>
-                      <a:pPr algn="ctr"/>
-                      <a:r>
-                        <a:rPr sz="1100" b="0" i="0">
-                          <a:solidFill>
-                            <a:srgbClr val="1F1F1F"/>
-                          </a:solidFill>
-                          <a:latin typeface="Calibri"/>
-                        </a:rPr>
-                        <a:t>Data acquisition &amp; preprocessing</a:t>
-                      </a:r>
-                    </a:p>
-                  </a:txBody>
-                  <a:tcPr marL="54864" marR="54864" marT="27432" marB="27432" anchor="ctr">
-                    <a:solidFill>
-                      <a:srgbClr val="FFFFFF"/>
-                    </a:solidFill>
-                  </a:tcPr>
-                </a:tc>
-                <a:tc>
-                  <a:txBody>
-                    <a:bodyPr wrap="square"/>
-                    <a:lstStyle/>
-                    <a:p>
-                      <a:pPr algn="ctr"/>
-                      <a:r>
-                        <a:rPr sz="1100" b="0" i="0">
-                          <a:solidFill>
-                            <a:srgbClr val="1F1F1F"/>
-                          </a:solidFill>
-                          <a:latin typeface="Calibri"/>
-                        </a:rPr>
-                        <a:t>Data download, Census rates, district matching, variable selection, grid weights, grid-to-district-day, orientation check, data-quality error metrics (Table 1)</a:t>
-                      </a:r>
-                    </a:p>
-                  </a:txBody>
-                  <a:tcPr marL="54864" marR="54864" marT="27432" marB="27432" anchor="ctr">
-                    <a:solidFill>
-                      <a:srgbClr val="FFFFFF"/>
-                    </a:solidFill>
-                  </a:tcPr>
-                </a:tc>
-                <a:tc>
-                  <a:txBody>
-                    <a:bodyPr wrap="square"/>
-                    <a:lstStyle/>
-                    <a:p>
-                      <a:pPr algn="ctr"/>
-                      <a:r>
-                        <a:rPr sz="1100" b="0" i="0">
-                          <a:solidFill>
-                            <a:srgbClr val="1F1F1F"/>
-                          </a:solidFill>
-                          <a:latin typeface="Calibri"/>
-                        </a:rPr>
-                        <a:t>100% (estimate)</a:t>
-                      </a:r>
-                    </a:p>
-                  </a:txBody>
-                  <a:tcPr marL="54864" marR="54864" marT="27432" marB="27432" anchor="ctr">
-                    <a:solidFill>
-                      <a:srgbClr val="FFFFFF"/>
-                    </a:solidFill>
-                  </a:tcPr>
-                </a:tc>
-              </a:tr>
-              <a:tr h="868680">
-                <a:tc>
-                  <a:txBody>
-                    <a:bodyPr wrap="square"/>
-                    <a:lstStyle/>
-                    <a:p>
-                      <a:pPr algn="l"/>
-                      <a:r>
-                        <a:rPr sz="1100" b="1" i="0">
-                          <a:solidFill>
-                            <a:srgbClr val="1F1F1F"/>
-                          </a:solidFill>
-                          <a:latin typeface="Calibri"/>
-                        </a:rPr>
-                        <a:t>Deepankar</a:t>
-                      </a:r>
-                    </a:p>
-                  </a:txBody>
-                  <a:tcPr marL="54864" marR="54864" marT="27432" marB="27432" anchor="ctr">
-                    <a:solidFill>
-                      <a:srgbClr val="EEF2F8"/>
-                    </a:solidFill>
-                  </a:tcPr>
-                </a:tc>
-                <a:tc>
-                  <a:txBody>
-                    <a:bodyPr wrap="square"/>
-                    <a:lstStyle/>
-                    <a:p>
-                      <a:pPr algn="ctr"/>
-                      <a:r>
-                        <a:rPr sz="1100" b="0" i="0">
-                          <a:solidFill>
-                            <a:srgbClr val="1F1F1F"/>
-                          </a:solidFill>
-                          <a:latin typeface="Calibri"/>
-                        </a:rPr>
-                        <a:t>Big Data platform &amp; storage</a:t>
-                      </a:r>
-                    </a:p>
-                  </a:txBody>
-                  <a:tcPr marL="54864" marR="54864" marT="27432" marB="27432" anchor="ctr">
-                    <a:solidFill>
-                      <a:srgbClr val="EEF2F8"/>
-                    </a:solidFill>
-                  </a:tcPr>
-                </a:tc>
-                <a:tc>
-                  <a:txBody>
-                    <a:bodyPr wrap="square"/>
-                    <a:lstStyle/>
-                    <a:p>
-                      <a:pPr algn="ctr"/>
-                      <a:r>
-                        <a:rPr sz="1100" b="0" i="0">
-                          <a:solidFill>
-                            <a:srgbClr val="1F1F1F"/>
-                          </a:solidFill>
-                          <a:latin typeface="Calibri"/>
-                        </a:rPr>
-                        <a:t>Hadoop/YARN/Hive/Spark installation and configuration in Colab, cluster health checks, HDFS zone design, data loading, storage report (Table 2), repository and notebook structure</a:t>
-                      </a:r>
-                    </a:p>
-                  </a:txBody>
-                  <a:tcPr marL="54864" marR="54864" marT="27432" marB="27432" anchor="ctr">
-                    <a:solidFill>
-                      <a:srgbClr val="EEF2F8"/>
-                    </a:solidFill>
-                  </a:tcPr>
-                </a:tc>
-                <a:tc>
-                  <a:txBody>
-                    <a:bodyPr wrap="square"/>
-                    <a:lstStyle/>
-                    <a:p>
-                      <a:pPr algn="ctr"/>
-                      <a:r>
-                        <a:rPr sz="1100" b="0" i="0">
-                          <a:solidFill>
-                            <a:srgbClr val="1F1F1F"/>
-                          </a:solidFill>
-                          <a:latin typeface="Calibri"/>
-                        </a:rPr>
-                        <a:t>90% (estimate: fresh Colab run pending)</a:t>
-                      </a:r>
-                    </a:p>
-                  </a:txBody>
-                  <a:tcPr marL="54864" marR="54864" marT="27432" marB="27432" anchor="ctr">
-                    <a:solidFill>
-                      <a:srgbClr val="EEF2F8"/>
-                    </a:solidFill>
-                  </a:tcPr>
-                </a:tc>
-              </a:tr>
-              <a:tr h="868680">
-                <a:tc>
-                  <a:txBody>
-                    <a:bodyPr wrap="square"/>
-                    <a:lstStyle/>
-                    <a:p>
-                      <a:pPr algn="l"/>
-                      <a:r>
-                        <a:rPr sz="1100" b="1" i="0">
-                          <a:solidFill>
-                            <a:srgbClr val="1F1F1F"/>
-                          </a:solidFill>
-                          <a:latin typeface="Calibri"/>
-                        </a:rPr>
-                        <a:t>Tanmay Singh</a:t>
-                      </a:r>
-                    </a:p>
-                  </a:txBody>
-                  <a:tcPr marL="54864" marR="54864" marT="27432" marB="27432" anchor="ctr">
-                    <a:solidFill>
-                      <a:srgbClr val="FFFFFF"/>
-                    </a:solidFill>
-                  </a:tcPr>
-                </a:tc>
-                <a:tc>
-                  <a:txBody>
-                    <a:bodyPr wrap="square"/>
-                    <a:lstStyle/>
-                    <a:p>
-                      <a:pPr algn="ctr"/>
-                      <a:r>
-                        <a:rPr sz="1100" b="0" i="0">
-                          <a:solidFill>
-                            <a:srgbClr val="1F1F1F"/>
-                          </a:solidFill>
-                          <a:latin typeface="Calibri"/>
-                        </a:rPr>
-                        <a:t>Big Data processing jobs</a:t>
-                      </a:r>
-                    </a:p>
-                  </a:txBody>
-                  <a:tcPr marL="54864" marR="54864" marT="27432" marB="27432" anchor="ctr">
-                    <a:solidFill>
-                      <a:srgbClr val="FFFFFF"/>
-                    </a:solidFill>
-                  </a:tcPr>
-                </a:tc>
-                <a:tc>
-                  <a:txBody>
-                    <a:bodyPr wrap="square"/>
-                    <a:lstStyle/>
-                    <a:p>
-                      <a:pPr algn="ctr"/>
-                      <a:r>
-                        <a:rPr sz="1100" b="0" i="0">
-                          <a:solidFill>
-                            <a:srgbClr val="1F1F1F"/>
-                          </a:solidFill>
-                          <a:latin typeface="Calibri"/>
-                        </a:rPr>
-                        <a:t>MapReduce mapper/reducer and timings, MapReduce correctness check, Hive queries and pandas check, Spark k-means climate regimes (Table 3), slide assembly</a:t>
-                      </a:r>
-                    </a:p>
-                  </a:txBody>
-                  <a:tcPr marL="54864" marR="54864" marT="27432" marB="27432" anchor="ctr">
-                    <a:solidFill>
-                      <a:srgbClr val="FFFFFF"/>
-                    </a:solidFill>
-                  </a:tcPr>
-                </a:tc>
-                <a:tc>
-                  <a:txBody>
-                    <a:bodyPr wrap="square"/>
-                    <a:lstStyle/>
-                    <a:p>
-                      <a:pPr algn="ctr"/>
-                      <a:r>
-                        <a:rPr sz="1100" b="0" i="0">
-                          <a:solidFill>
-                            <a:srgbClr val="1F1F1F"/>
-                          </a:solidFill>
-                          <a:latin typeface="Calibri"/>
-                        </a:rPr>
-                        <a:t>90% (estimate: fresh MapReduce/Hive run pending)</a:t>
-                      </a:r>
-                    </a:p>
-                  </a:txBody>
-                  <a:tcPr marL="54864" marR="54864" marT="27432" marB="27432" anchor="ctr">
-                    <a:solidFill>
-                      <a:srgbClr val="FFFFFF"/>
-                    </a:solidFill>
-                  </a:tcPr>
-                </a:tc>
-              </a:tr>
-              <a:tr h="868680">
-                <a:tc>
-                  <a:txBody>
-                    <a:bodyPr wrap="square"/>
-                    <a:lstStyle/>
-                    <a:p>
-                      <a:pPr algn="l"/>
-                      <a:r>
-                        <a:rPr sz="1100" b="1" i="0">
-                          <a:solidFill>
-                            <a:srgbClr val="1F1F1F"/>
-                          </a:solidFill>
-                          <a:latin typeface="Calibri"/>
-                        </a:rPr>
-                        <a:t>Devanshu Kumar</a:t>
-                      </a:r>
-                    </a:p>
-                  </a:txBody>
-                  <a:tcPr marL="54864" marR="54864" marT="27432" marB="27432" anchor="ctr">
-                    <a:solidFill>
-                      <a:srgbClr val="EEF2F8"/>
-                    </a:solidFill>
-                  </a:tcPr>
-                </a:tc>
-                <a:tc>
-                  <a:txBody>
-                    <a:bodyPr wrap="square"/>
-                    <a:lstStyle/>
-                    <a:p>
-                      <a:pPr algn="ctr"/>
-                      <a:r>
-                        <a:rPr sz="1100" b="0" i="0">
-                          <a:solidFill>
-                            <a:srgbClr val="1F1F1F"/>
-                          </a:solidFill>
-                          <a:latin typeface="Calibri"/>
-                        </a:rPr>
-                        <a:t>Models &amp; comparison</a:t>
-                      </a:r>
-                    </a:p>
-                  </a:txBody>
-                  <a:tcPr marL="54864" marR="54864" marT="27432" marB="27432" anchor="ctr">
-                    <a:solidFill>
-                      <a:srgbClr val="EEF2F8"/>
-                    </a:solidFill>
-                  </a:tcPr>
-                </a:tc>
-                <a:tc>
-                  <a:txBody>
-                    <a:bodyPr wrap="square"/>
-                    <a:lstStyle/>
-                    <a:p>
-                      <a:pPr algn="ctr"/>
-                      <a:r>
-                        <a:rPr sz="1100" b="0" i="0">
-                          <a:solidFill>
-                            <a:srgbClr val="1F1F1F"/>
-                          </a:solidFill>
-                          <a:latin typeface="Calibri"/>
-                        </a:rPr>
-                        <a:t>A-CPN design and training, 5 comparison models (Spark MLlib + MLP), metrics, effect of preprocessing on the models, ablation, climate-push analysis (Tables 4-6)</a:t>
-                      </a:r>
-                    </a:p>
-                  </a:txBody>
-                  <a:tcPr marL="54864" marR="54864" marT="27432" marB="27432" anchor="ctr">
-                    <a:solidFill>
-                      <a:srgbClr val="EEF2F8"/>
-                    </a:solidFill>
-                  </a:tcPr>
-                </a:tc>
-                <a:tc>
-                  <a:txBody>
-                    <a:bodyPr wrap="square"/>
-                    <a:lstStyle/>
-                    <a:p>
-                      <a:pPr algn="ctr"/>
-                      <a:r>
-                        <a:rPr sz="1100" b="0" i="0">
-                          <a:solidFill>
-                            <a:srgbClr val="1F1F1F"/>
-                          </a:solidFill>
-                          <a:latin typeface="Calibri"/>
-                        </a:rPr>
-                        <a:t>95% (estimate: all models run; tuning next)</a:t>
-                      </a:r>
-                    </a:p>
-                  </a:txBody>
-                  <a:tcPr marL="54864" marR="54864" marT="27432" marB="27432" anchor="ctr">
-                    <a:solidFill>
-                      <a:srgbClr val="EEF2F8"/>
-                    </a:solidFill>
-                  </a:tcPr>
-                </a:tc>
-              </a:tr>
-            </a:tbl>
-          </a:graphicData>
-        </a:graphic>
-      </p:graphicFrame>
-      <p:sp>
-        <p:nvSpPr>
-          <p:cNvPr id="5" name="TextBox 4"/>
-          <p:cNvSpPr txBox="1"/>
-          <p:nvPr/>
-        </p:nvSpPr>
-        <p:spPr>
-          <a:xfrm>
-            <a:off x="365760" y="5623560"/>
-            <a:ext cx="8412480" cy="731520"/>
-          </a:xfrm>
-          <a:prstGeom prst="rect">
-            <a:avLst/>
-          </a:prstGeom>
-          <a:noFill/>
-        </p:spPr>
-        <p:txBody>
-          <a:bodyPr wrap="square" anchor="t" lIns="45720" rIns="45720">
-            <a:spAutoFit/>
-          </a:bodyPr>
-          <a:lstStyle/>
-          <a:p>
-            <a:pPr algn="l"/>
-            <a:r>
-              <a:rPr sz="1300" b="0" i="0">
-                <a:solidFill>
-                  <a:srgbClr val="1F1F1F"/>
-                </a:solidFill>
-                <a:latin typeface="Calibri"/>
-              </a:rPr>
-              <a:t>Next (Review 3): full 1901–2024 rainfall in HDFS and re-timing; A-CPN tuning; comparison with CEEW / DST district rankings; final report.</a:t>
-            </a:r>
-          </a:p>
-        </p:txBody>
-      </p:sp>
-      <p:sp>
-        <p:nvSpPr>
-          <p:cNvPr id="6" name="TextBox 5"/>
-          <p:cNvSpPr txBox="1"/>
-          <p:nvPr/>
-        </p:nvSpPr>
-        <p:spPr>
-          <a:xfrm>
-            <a:off x="365760" y="6446520"/>
-            <a:ext cx="8412480" cy="274320"/>
-          </a:xfrm>
-          <a:prstGeom prst="rect">
-            <a:avLst/>
-          </a:prstGeom>
-          <a:noFill/>
-        </p:spPr>
-        <p:txBody>
-          <a:bodyPr wrap="square" anchor="t" lIns="45720" rIns="45720">
-            <a:spAutoFit/>
-          </a:bodyPr>
-          <a:lstStyle/>
-          <a:p>
-            <a:pPr algn="r"/>
-            <a:r>
-              <a:rPr sz="1000" b="0" i="0">
-                <a:solidFill>
-                  <a:srgbClr val="595959"/>
-                </a:solidFill>
-                <a:latin typeface="Calibri"/>
-              </a:rPr>
-              <a:t>Presenter: Tanmay Singh</a:t>
-            </a:r>
-          </a:p>
-        </p:txBody>
-      </p:sp>
-    </p:spTree>
-  </p:cSld>
-  <p:clrMapOvr>
-    <a:masterClrMapping/>
-  </p:clrMapOvr>
-</p:sld>
-</file>
-
-<file path=ppt/slides/slide29.xml><?xml version="1.0" encoding="utf-8"?>
-<p:sld xmlns:a="http://schemas.openxmlformats.org/drawingml/2006/main" xmlns:p="http://schemas.openxmlformats.org/presentationml/2006/main" xmlns:r="http://schemas.openxmlformats.org/officeDocument/2006/relationships">
-  <p:cSld>
-    <p:spTree>
-      <p:nvGrpSpPr>
-        <p:cNvPr id="1" name=""/>
-        <p:cNvGrpSpPr/>
-        <p:nvPr/>
-      </p:nvGrpSpPr>
-      <p:grpSpPr/>
-      <p:sp>
-        <p:nvSpPr>
-          <p:cNvPr id="2" name="Title 1"/>
-          <p:cNvSpPr>
-            <a:spLocks noGrp="1"/>
-          </p:cNvSpPr>
-          <p:nvPr>
-            <p:ph type="title"/>
-          </p:nvPr>
-        </p:nvSpPr>
-        <p:spPr>
-          <a:xfrm>
-            <a:off x="365760" y="274320"/>
-            <a:ext cx="6355080" cy="822960"/>
-          </a:xfrm>
-        </p:spPr>
-        <p:txBody>
-          <a:bodyPr wrap="square" anchor="ctr" lIns="45720"/>
-          <a:lstStyle/>
-          <a:p>
-            <a:pPr algn="l"/>
-            <a:r>
-              <a:rPr sz="2800" b="1" i="0">
-                <a:solidFill>
-                  <a:srgbClr val="1B3A6B"/>
-                </a:solidFill>
-                <a:latin typeface="Times New Roman"/>
-              </a:rPr>
-              <a:t>References</a:t>
-            </a:r>
-          </a:p>
-        </p:txBody>
-      </p:sp>
-      <p:pic>
-        <p:nvPicPr>
-          <p:cNvPr id="3" name="Picture 2" descr="image.jpeg"/>
-          <p:cNvPicPr>
-            <a:picLocks noChangeAspect="1"/>
-          </p:cNvPicPr>
-          <p:nvPr/>
-        </p:nvPicPr>
-        <p:blipFill>
-          <a:blip r:embed="rId2"/>
-          <a:stretch>
-            <a:fillRect/>
-          </a:stretch>
-        </p:blipFill>
-        <p:spPr>
-          <a:xfrm>
-            <a:off x="6858000" y="228600"/>
-            <a:ext cx="2066925" cy="857250"/>
-          </a:xfrm>
-          <a:prstGeom prst="rect">
-            <a:avLst/>
-          </a:prstGeom>
-        </p:spPr>
-      </p:pic>
-      <p:sp>
-        <p:nvSpPr>
-          <p:cNvPr id="4" name="TextBox 3"/>
-          <p:cNvSpPr txBox="1"/>
-          <p:nvPr/>
-        </p:nvSpPr>
-        <p:spPr>
-          <a:xfrm>
-            <a:off x="365760" y="1188720"/>
-            <a:ext cx="8412480" cy="5212080"/>
-          </a:xfrm>
-          <a:prstGeom prst="rect">
-            <a:avLst/>
-          </a:prstGeom>
-          <a:noFill/>
-        </p:spPr>
-        <p:txBody>
-          <a:bodyPr wrap="square">
-            <a:spAutoFit/>
-          </a:bodyPr>
-          <a:lstStyle/>
-          <a:p>
-            <a:pPr>
-              <a:spcAft>
-                <a:spcPts val="400"/>
-              </a:spcAft>
-            </a:pPr>
-            <a:r>
-              <a:rPr sz="1300" b="1" i="0">
-                <a:solidFill>
-                  <a:srgbClr val="1B3A6B"/>
-                </a:solidFill>
-                <a:latin typeface="Calibri"/>
-              </a:rPr>
-              <a:t>[1]  </a:t>
-            </a:r>
-            <a:r>
-              <a:rPr sz="1300" b="0" i="0">
-                <a:solidFill>
-                  <a:srgbClr val="1F1F1F"/>
-                </a:solidFill>
-                <a:latin typeface="Calibri"/>
-              </a:rPr>
-              <a:t>A. Mohanty and S. Wadhawan, Mapping India's Climate Vulnerability, CEEW, 2021.</a:t>
-            </a:r>
-          </a:p>
-          <a:p>
-            <a:pPr>
-              <a:spcAft>
-                <a:spcPts val="400"/>
-              </a:spcAft>
-            </a:pPr>
-            <a:r>
-              <a:rPr sz="1300" b="1" i="0">
-                <a:solidFill>
-                  <a:srgbClr val="1B3A6B"/>
-                </a:solidFill>
-                <a:latin typeface="Calibri"/>
-              </a:rPr>
-              <a:t>[2]  </a:t>
-            </a:r>
-            <a:r>
-              <a:rPr sz="1300" b="0" i="0">
-                <a:solidFill>
-                  <a:srgbClr val="1F1F1F"/>
-                </a:solidFill>
-                <a:latin typeface="Calibri"/>
-              </a:rPr>
-              <a:t>NITI Aayog, District-Level Climate Vulnerability Indicators, NDAP dataset 7160.</a:t>
-            </a:r>
-          </a:p>
-          <a:p>
-            <a:pPr>
-              <a:spcAft>
-                <a:spcPts val="400"/>
-              </a:spcAft>
-            </a:pPr>
-            <a:r>
-              <a:rPr sz="1300" b="1" i="0">
-                <a:solidFill>
-                  <a:srgbClr val="1B3A6B"/>
-                </a:solidFill>
-                <a:latin typeface="Calibri"/>
-              </a:rPr>
-              <a:t>[3]  </a:t>
-            </a:r>
-            <a:r>
-              <a:rPr sz="1300" b="0" i="0">
-                <a:solidFill>
-                  <a:srgbClr val="1F1F1F"/>
-                </a:solidFill>
-                <a:latin typeface="Calibri"/>
-              </a:rPr>
-              <a:t>Census of India 2011, Primary Census Abstract.</a:t>
-            </a:r>
-          </a:p>
-          <a:p>
-            <a:pPr>
-              <a:spcAft>
-                <a:spcPts val="400"/>
-              </a:spcAft>
-            </a:pPr>
-            <a:r>
-              <a:rPr sz="1300" b="1" i="0">
-                <a:solidFill>
-                  <a:srgbClr val="1B3A6B"/>
-                </a:solidFill>
-                <a:latin typeface="Calibri"/>
-              </a:rPr>
-              <a:t>[4]  </a:t>
-            </a:r>
-            <a:r>
-              <a:rPr sz="1300" b="0" i="0">
-                <a:solidFill>
-                  <a:srgbClr val="1F1F1F"/>
-                </a:solidFill>
-                <a:latin typeface="Calibri"/>
-              </a:rPr>
-              <a:t>D. S. Pai et al., MAUSAM 65(1), 2014 (IMD gridded rainfall).</a:t>
-            </a:r>
-          </a:p>
-          <a:p>
-            <a:pPr>
-              <a:spcAft>
-                <a:spcPts val="400"/>
-              </a:spcAft>
-            </a:pPr>
-            <a:r>
-              <a:rPr sz="1300" b="1" i="0">
-                <a:solidFill>
-                  <a:srgbClr val="1B3A6B"/>
-                </a:solidFill>
-                <a:latin typeface="Calibri"/>
-              </a:rPr>
-              <a:t>[5]  </a:t>
-            </a:r>
-            <a:r>
-              <a:rPr sz="1300" b="0" i="0">
-                <a:solidFill>
-                  <a:srgbClr val="1F1F1F"/>
-                </a:solidFill>
-                <a:latin typeface="Calibri"/>
-              </a:rPr>
-              <a:t>A. K. Srivastava et al., Atmospheric Science Letters 10, 2009 (IMD gridded temperature).</a:t>
-            </a:r>
-          </a:p>
-          <a:p>
-            <a:pPr>
-              <a:spcAft>
-                <a:spcPts val="400"/>
-              </a:spcAft>
-            </a:pPr>
-            <a:r>
-              <a:rPr sz="1300" b="1" i="0">
-                <a:solidFill>
-                  <a:srgbClr val="1B3A6B"/>
-                </a:solidFill>
-                <a:latin typeface="Calibri"/>
-              </a:rPr>
-              <a:t>[6]  </a:t>
-            </a:r>
-            <a:r>
-              <a:rPr sz="1300" b="0" i="0">
-                <a:solidFill>
-                  <a:srgbClr val="1F1F1F"/>
-                </a:solidFill>
-                <a:latin typeface="Calibri"/>
-              </a:rPr>
-              <a:t>H.-T. Cheng et al., Wide &amp; Deep Learning for Recommender Systems, DLRS 2016.</a:t>
-            </a:r>
-          </a:p>
-          <a:p>
-            <a:pPr>
-              <a:spcAft>
-                <a:spcPts val="400"/>
-              </a:spcAft>
-            </a:pPr>
-            <a:r>
-              <a:rPr sz="1300" b="1" i="0">
-                <a:solidFill>
-                  <a:srgbClr val="1B3A6B"/>
-                </a:solidFill>
-                <a:latin typeface="Calibri"/>
-              </a:rPr>
-              <a:t>[7]  </a:t>
-            </a:r>
-            <a:r>
-              <a:rPr sz="1300" b="0" i="0">
-                <a:solidFill>
-                  <a:srgbClr val="1F1F1F"/>
-                </a:solidFill>
-                <a:latin typeface="Calibri"/>
-              </a:rPr>
-              <a:t>S. Ö. Arık and T. Pfister, TabNet: Attentive Interpretable Tabular Learning, AAAI 2021.</a:t>
-            </a:r>
-          </a:p>
-          <a:p>
-            <a:pPr>
-              <a:spcAft>
-                <a:spcPts val="400"/>
-              </a:spcAft>
-            </a:pPr>
-            <a:r>
-              <a:rPr sz="1300" b="1" i="0">
-                <a:solidFill>
-                  <a:srgbClr val="1B3A6B"/>
-                </a:solidFill>
-                <a:latin typeface="Calibri"/>
-              </a:rPr>
-              <a:t>[8]  </a:t>
-            </a:r>
-            <a:r>
-              <a:rPr sz="1300" b="0" i="0">
-                <a:solidFill>
-                  <a:srgbClr val="1F1F1F"/>
-                </a:solidFill>
-                <a:latin typeface="Calibri"/>
-              </a:rPr>
-              <a:t>Z. Liu et al., KAN: Kolmogorov–Arnold Networks, arXiv:2404.19756, 2024.</a:t>
-            </a:r>
-          </a:p>
-          <a:p>
-            <a:pPr>
-              <a:spcAft>
-                <a:spcPts val="400"/>
-              </a:spcAft>
-            </a:pPr>
-            <a:r>
-              <a:rPr sz="1300" b="1" i="0">
-                <a:solidFill>
-                  <a:srgbClr val="1B3A6B"/>
-                </a:solidFill>
-                <a:latin typeface="Calibri"/>
-              </a:rPr>
-              <a:t>[9]  </a:t>
-            </a:r>
-            <a:r>
-              <a:rPr sz="1300" b="0" i="0">
-                <a:solidFill>
-                  <a:srgbClr val="1F1F1F"/>
-                </a:solidFill>
-                <a:latin typeface="Calibri"/>
-              </a:rPr>
-              <a:t>K. He et al., Deep Residual Learning for Image Recognition, CVPR 2016.</a:t>
-            </a:r>
-          </a:p>
-          <a:p>
-            <a:pPr>
-              <a:spcAft>
-                <a:spcPts val="400"/>
-              </a:spcAft>
-            </a:pPr>
-            <a:r>
-              <a:rPr sz="1300" b="1" i="0">
-                <a:solidFill>
-                  <a:srgbClr val="1B3A6B"/>
-                </a:solidFill>
-                <a:latin typeface="Calibri"/>
-              </a:rPr>
-              <a:t>[10]  </a:t>
-            </a:r>
-            <a:r>
-              <a:rPr sz="1300" b="0" i="0">
-                <a:solidFill>
-                  <a:srgbClr val="1F1F1F"/>
-                </a:solidFill>
-                <a:latin typeface="Calibri"/>
-              </a:rPr>
-              <a:t>Y. Gal and Z. Ghahramani, Dropout as a Bayesian Approximation, ICML 2016.</a:t>
-            </a:r>
-          </a:p>
-          <a:p>
-            <a:pPr>
-              <a:spcAft>
-                <a:spcPts val="400"/>
-              </a:spcAft>
-            </a:pPr>
-            <a:r>
-              <a:rPr sz="1300" b="1" i="0">
-                <a:solidFill>
-                  <a:srgbClr val="1B3A6B"/>
-                </a:solidFill>
-                <a:latin typeface="Calibri"/>
-              </a:rPr>
-              <a:t>[11]  </a:t>
-            </a:r>
-            <a:r>
-              <a:rPr sz="1300" b="0" i="0">
-                <a:solidFill>
-                  <a:srgbClr val="1F1F1F"/>
-                </a:solidFill>
-                <a:latin typeface="Calibri"/>
-              </a:rPr>
-              <a:t>A. N. Angelopoulos and S. Bates, A Gentle Introduction to Conformal Prediction, arXiv:2107.07511, 2021.</a:t>
-            </a:r>
-          </a:p>
-          <a:p>
-            <a:pPr>
-              <a:spcAft>
-                <a:spcPts val="400"/>
-              </a:spcAft>
-            </a:pPr>
-            <a:r>
-              <a:rPr sz="1300" b="1" i="0">
-                <a:solidFill>
-                  <a:srgbClr val="1B3A6B"/>
-                </a:solidFill>
-                <a:latin typeface="Calibri"/>
-              </a:rPr>
-              <a:t>[12]  </a:t>
-            </a:r>
-            <a:r>
-              <a:rPr sz="1300" b="0" i="0">
-                <a:solidFill>
-                  <a:srgbClr val="1F1F1F"/>
-                </a:solidFill>
-                <a:latin typeface="Calibri"/>
-              </a:rPr>
-              <a:t>K. Shvachko et al., The Hadoop Distributed File System, MSST 2010.</a:t>
-            </a:r>
-          </a:p>
-          <a:p>
-            <a:pPr>
-              <a:spcAft>
-                <a:spcPts val="400"/>
-              </a:spcAft>
-            </a:pPr>
-            <a:r>
-              <a:rPr sz="1300" b="1" i="0">
-                <a:solidFill>
-                  <a:srgbClr val="1B3A6B"/>
-                </a:solidFill>
-                <a:latin typeface="Calibri"/>
-              </a:rPr>
-              <a:t>[13]  </a:t>
-            </a:r>
-            <a:r>
-              <a:rPr sz="1300" b="0" i="0">
-                <a:solidFill>
-                  <a:srgbClr val="1F1F1F"/>
-                </a:solidFill>
-                <a:latin typeface="Calibri"/>
-              </a:rPr>
-              <a:t>J. Dean and S. Ghemawat, MapReduce, Communications of the ACM, 2008.</a:t>
-            </a:r>
-          </a:p>
-          <a:p>
-            <a:pPr>
-              <a:spcAft>
-                <a:spcPts val="400"/>
-              </a:spcAft>
-            </a:pPr>
-            <a:r>
-              <a:rPr sz="1300" b="1" i="0">
-                <a:solidFill>
-                  <a:srgbClr val="1B3A6B"/>
-                </a:solidFill>
-                <a:latin typeface="Calibri"/>
-              </a:rPr>
-              <a:t>[14]  </a:t>
-            </a:r>
-            <a:r>
-              <a:rPr sz="1300" b="0" i="0">
-                <a:solidFill>
-                  <a:srgbClr val="1F1F1F"/>
-                </a:solidFill>
-                <a:latin typeface="Calibri"/>
-              </a:rPr>
-              <a:t>A. Thusoo et al., Hive, VLDB 2009.</a:t>
-            </a:r>
-          </a:p>
-          <a:p>
-            <a:pPr>
-              <a:spcAft>
-                <a:spcPts val="400"/>
-              </a:spcAft>
-            </a:pPr>
-            <a:r>
-              <a:rPr sz="1300" b="1" i="0">
-                <a:solidFill>
-                  <a:srgbClr val="1B3A6B"/>
-                </a:solidFill>
-                <a:latin typeface="Calibri"/>
-              </a:rPr>
-              <a:t>[15]  </a:t>
-            </a:r>
-            <a:r>
-              <a:rPr sz="1300" b="0" i="0">
-                <a:solidFill>
-                  <a:srgbClr val="1F1F1F"/>
-                </a:solidFill>
-                <a:latin typeface="Calibri"/>
-              </a:rPr>
-              <a:t>M. Zaharia et al., Apache Spark: A Unified Engine for Big Data Processing, CACM 59(11), 2016.</a:t>
-            </a:r>
-          </a:p>
-          <a:p>
-            <a:pPr>
-              <a:spcAft>
-                <a:spcPts val="400"/>
-              </a:spcAft>
-            </a:pPr>
-            <a:r>
-              <a:rPr sz="1300" b="1" i="0">
-                <a:solidFill>
-                  <a:srgbClr val="1B3A6B"/>
-                </a:solidFill>
-                <a:latin typeface="Calibri"/>
-              </a:rPr>
-              <a:t>[16]  </a:t>
-            </a:r>
-            <a:r>
-              <a:rPr sz="1300" b="0" i="0">
-                <a:solidFill>
-                  <a:srgbClr val="1F1F1F"/>
-                </a:solidFill>
-                <a:latin typeface="Calibri"/>
-              </a:rPr>
-              <a:t>X. Meng et al., MLlib: Machine Learning in Apache Spark, JMLR 17, 2016.</a:t>
-            </a:r>
-          </a:p>
-          <a:p>
-            <a:pPr>
-              <a:spcAft>
-                <a:spcPts val="400"/>
-              </a:spcAft>
-            </a:pPr>
-            <a:r>
-              <a:rPr sz="1300" b="1" i="0">
-                <a:solidFill>
-                  <a:srgbClr val="1B3A6B"/>
-                </a:solidFill>
-                <a:latin typeface="Calibri"/>
-              </a:rPr>
-              <a:t>[17]  </a:t>
-            </a:r>
-            <a:r>
-              <a:rPr sz="1300" b="0" i="0">
-                <a:solidFill>
-                  <a:srgbClr val="1F1F1F"/>
-                </a:solidFill>
-                <a:latin typeface="Calibri"/>
-              </a:rPr>
-              <a:t>DataMeet, Community Created Maps of India.</a:t>
-            </a:r>
-          </a:p>
-        </p:txBody>
-      </p:sp>
-      <p:sp>
-        <p:nvSpPr>
-          <p:cNvPr id="5" name="TextBox 4"/>
           <p:cNvSpPr txBox="1"/>
           <p:nvPr/>
         </p:nvSpPr>
@@ -22680,6 +21959,1207 @@
                 </a:solidFill>
                 <a:latin typeface="Times New Roman"/>
               </a:rPr>
+              <a:t>Plan of Action / Member Tasks</a:t>
+            </a:r>
+          </a:p>
+        </p:txBody>
+      </p:sp>
+      <p:pic>
+        <p:nvPicPr>
+          <p:cNvPr id="3" name="Picture 2" descr="image.jpeg"/>
+          <p:cNvPicPr>
+            <a:picLocks noChangeAspect="1"/>
+          </p:cNvPicPr>
+          <p:nvPr/>
+        </p:nvPicPr>
+        <p:blipFill>
+          <a:blip r:embed="rId2"/>
+          <a:stretch>
+            <a:fillRect/>
+          </a:stretch>
+        </p:blipFill>
+        <p:spPr>
+          <a:xfrm>
+            <a:off x="6858000" y="228600"/>
+            <a:ext cx="2066925" cy="857250"/>
+          </a:xfrm>
+          <a:prstGeom prst="rect">
+            <a:avLst/>
+          </a:prstGeom>
+        </p:spPr>
+      </p:pic>
+      <p:graphicFrame>
+        <p:nvGraphicFramePr>
+          <p:cNvPr id="4" name="Table 3"/>
+          <p:cNvGraphicFramePr>
+            <a:graphicFrameLocks noGrp="1"/>
+          </p:cNvGraphicFramePr>
+          <p:nvPr/>
+        </p:nvGraphicFramePr>
+        <p:xfrm>
+          <a:off x="365760" y="1143000"/>
+          <a:ext cx="8412478" cy="4114800"/>
+        </p:xfrm>
+        <a:graphic>
+          <a:graphicData uri="http://schemas.openxmlformats.org/drawingml/2006/table">
+            <a:tbl>
+              <a:tblPr firstRow="1" bandRow="1">
+                <a:tableStyleId>{5C22544A-7EE6-4342-B048-85BDC9FD1C3A}</a:tableStyleId>
+              </a:tblPr>
+              <a:tblGrid>
+                <a:gridCol w="1431911"/>
+                <a:gridCol w="1610900"/>
+                <a:gridCol w="3937756"/>
+                <a:gridCol w="1431911"/>
+              </a:tblGrid>
+              <a:tr h="822960">
+                <a:tc>
+                  <a:txBody>
+                    <a:bodyPr wrap="square"/>
+                    <a:lstStyle/>
+                    <a:p>
+                      <a:pPr algn="l"/>
+                      <a:r>
+                        <a:rPr sz="1100" b="1" i="0">
+                          <a:solidFill>
+                            <a:srgbClr val="FFFFFF"/>
+                          </a:solidFill>
+                          <a:latin typeface="Calibri"/>
+                        </a:rPr>
+                        <a:t>Member</a:t>
+                      </a:r>
+                    </a:p>
+                  </a:txBody>
+                  <a:tcPr marL="54864" marR="54864" marT="27432" marB="27432" anchor="ctr">
+                    <a:solidFill>
+                      <a:srgbClr val="1B3A6B"/>
+                    </a:solidFill>
+                  </a:tcPr>
+                </a:tc>
+                <a:tc>
+                  <a:txBody>
+                    <a:bodyPr wrap="square"/>
+                    <a:lstStyle/>
+                    <a:p>
+                      <a:pPr algn="ctr"/>
+                      <a:r>
+                        <a:rPr sz="1100" b="1" i="0">
+                          <a:solidFill>
+                            <a:srgbClr val="FFFFFF"/>
+                          </a:solidFill>
+                          <a:latin typeface="Calibri"/>
+                        </a:rPr>
+                        <a:t>Role</a:t>
+                      </a:r>
+                    </a:p>
+                  </a:txBody>
+                  <a:tcPr marL="54864" marR="54864" marT="27432" marB="27432" anchor="ctr">
+                    <a:solidFill>
+                      <a:srgbClr val="1B3A6B"/>
+                    </a:solidFill>
+                  </a:tcPr>
+                </a:tc>
+                <a:tc>
+                  <a:txBody>
+                    <a:bodyPr wrap="square"/>
+                    <a:lstStyle/>
+                    <a:p>
+                      <a:pPr algn="ctr"/>
+                      <a:r>
+                        <a:rPr sz="1100" b="1" i="0">
+                          <a:solidFill>
+                            <a:srgbClr val="FFFFFF"/>
+                          </a:solidFill>
+                          <a:latin typeface="Calibri"/>
+                        </a:rPr>
+                        <a:t>Key Responsibilities</a:t>
+                      </a:r>
+                    </a:p>
+                  </a:txBody>
+                  <a:tcPr marL="54864" marR="54864" marT="27432" marB="27432" anchor="ctr">
+                    <a:solidFill>
+                      <a:srgbClr val="1B3A6B"/>
+                    </a:solidFill>
+                  </a:tcPr>
+                </a:tc>
+                <a:tc>
+                  <a:txBody>
+                    <a:bodyPr wrap="square"/>
+                    <a:lstStyle/>
+                    <a:p>
+                      <a:pPr algn="ctr"/>
+                      <a:r>
+                        <a:rPr sz="1100" b="1" i="0">
+                          <a:solidFill>
+                            <a:srgbClr val="FFFFFF"/>
+                          </a:solidFill>
+                          <a:latin typeface="Calibri"/>
+                        </a:rPr>
+                        <a:t>Status</a:t>
+                      </a:r>
+                    </a:p>
+                  </a:txBody>
+                  <a:tcPr marL="54864" marR="54864" marT="27432" marB="27432" anchor="ctr">
+                    <a:solidFill>
+                      <a:srgbClr val="1B3A6B"/>
+                    </a:solidFill>
+                  </a:tcPr>
+                </a:tc>
+              </a:tr>
+              <a:tr h="822960">
+                <a:tc>
+                  <a:txBody>
+                    <a:bodyPr wrap="square"/>
+                    <a:lstStyle/>
+                    <a:p>
+                      <a:pPr algn="l"/>
+                      <a:r>
+                        <a:rPr sz="1100" b="1" i="0">
+                          <a:solidFill>
+                            <a:srgbClr val="1F1F1F"/>
+                          </a:solidFill>
+                          <a:latin typeface="Calibri"/>
+                        </a:rPr>
+                        <a:t>Sehjodh Grewal</a:t>
+                      </a:r>
+                    </a:p>
+                  </a:txBody>
+                  <a:tcPr marL="54864" marR="54864" marT="27432" marB="27432" anchor="ctr">
+                    <a:solidFill>
+                      <a:srgbClr val="FFFFFF"/>
+                    </a:solidFill>
+                  </a:tcPr>
+                </a:tc>
+                <a:tc>
+                  <a:txBody>
+                    <a:bodyPr wrap="square"/>
+                    <a:lstStyle/>
+                    <a:p>
+                      <a:pPr algn="ctr"/>
+                      <a:r>
+                        <a:rPr sz="1100" b="0" i="0">
+                          <a:solidFill>
+                            <a:srgbClr val="1F1F1F"/>
+                          </a:solidFill>
+                          <a:latin typeface="Calibri"/>
+                        </a:rPr>
+                        <a:t>Dataset &amp; Preprocessing</a:t>
+                      </a:r>
+                    </a:p>
+                  </a:txBody>
+                  <a:tcPr marL="54864" marR="54864" marT="27432" marB="27432" anchor="ctr">
+                    <a:solidFill>
+                      <a:srgbClr val="FFFFFF"/>
+                    </a:solidFill>
+                  </a:tcPr>
+                </a:tc>
+                <a:tc>
+                  <a:txBody>
+                    <a:bodyPr wrap="square"/>
+                    <a:lstStyle/>
+                    <a:p>
+                      <a:pPr algn="ctr"/>
+                      <a:r>
+                        <a:rPr sz="1100" b="0" i="0">
+                          <a:solidFill>
+                            <a:srgbClr val="1F1F1F"/>
+                          </a:solidFill>
+                          <a:latin typeface="Calibri"/>
+                        </a:rPr>
+                        <a:t>Collect NDAP, Census 2011, IMD and boundary data; Census rates; district matching; variable selection (no imputation); grid-to-district aggregation; district-day table; orientation check; preprocessing results and error metrics (Table 1)</a:t>
+                      </a:r>
+                    </a:p>
+                  </a:txBody>
+                  <a:tcPr marL="54864" marR="54864" marT="27432" marB="27432" anchor="ctr">
+                    <a:solidFill>
+                      <a:srgbClr val="FFFFFF"/>
+                    </a:solidFill>
+                  </a:tcPr>
+                </a:tc>
+                <a:tc>
+                  <a:txBody>
+                    <a:bodyPr wrap="square"/>
+                    <a:lstStyle/>
+                    <a:p>
+                      <a:pPr algn="ctr"/>
+                      <a:r>
+                        <a:rPr sz="1100" b="0" i="0">
+                          <a:solidFill>
+                            <a:srgbClr val="1F1F1F"/>
+                          </a:solidFill>
+                          <a:latin typeface="Calibri"/>
+                        </a:rPr>
+                        <a:t>Completed (IMD re-run in Colab pending)</a:t>
+                      </a:r>
+                    </a:p>
+                  </a:txBody>
+                  <a:tcPr marL="54864" marR="54864" marT="27432" marB="27432" anchor="ctr">
+                    <a:solidFill>
+                      <a:srgbClr val="FFFFFF"/>
+                    </a:solidFill>
+                  </a:tcPr>
+                </a:tc>
+              </a:tr>
+              <a:tr h="822960">
+                <a:tc>
+                  <a:txBody>
+                    <a:bodyPr wrap="square"/>
+                    <a:lstStyle/>
+                    <a:p>
+                      <a:pPr algn="l"/>
+                      <a:r>
+                        <a:rPr sz="1100" b="1" i="0">
+                          <a:solidFill>
+                            <a:srgbClr val="1F1F1F"/>
+                          </a:solidFill>
+                          <a:latin typeface="Calibri"/>
+                        </a:rPr>
+                        <a:t>Deepankar</a:t>
+                      </a:r>
+                    </a:p>
+                  </a:txBody>
+                  <a:tcPr marL="54864" marR="54864" marT="27432" marB="27432" anchor="ctr">
+                    <a:solidFill>
+                      <a:srgbClr val="EEF2F8"/>
+                    </a:solidFill>
+                  </a:tcPr>
+                </a:tc>
+                <a:tc>
+                  <a:txBody>
+                    <a:bodyPr wrap="square"/>
+                    <a:lstStyle/>
+                    <a:p>
+                      <a:pPr algn="ctr"/>
+                      <a:r>
+                        <a:rPr sz="1100" b="0" i="0">
+                          <a:solidFill>
+                            <a:srgbClr val="1F1F1F"/>
+                          </a:solidFill>
+                          <a:latin typeface="Calibri"/>
+                        </a:rPr>
+                        <a:t>Big Data Pipeline</a:t>
+                      </a:r>
+                    </a:p>
+                  </a:txBody>
+                  <a:tcPr marL="54864" marR="54864" marT="27432" marB="27432" anchor="ctr">
+                    <a:solidFill>
+                      <a:srgbClr val="EEF2F8"/>
+                    </a:solidFill>
+                  </a:tcPr>
+                </a:tc>
+                <a:tc>
+                  <a:txBody>
+                    <a:bodyPr wrap="square"/>
+                    <a:lstStyle/>
+                    <a:p>
+                      <a:pPr algn="ctr"/>
+                      <a:r>
+                        <a:rPr sz="1100" b="0" i="0">
+                          <a:solidFill>
+                            <a:srgbClr val="1F1F1F"/>
+                          </a:solidFill>
+                          <a:latin typeface="Calibri"/>
+                        </a:rPr>
+                        <a:t>Set up Hadoop (HDFS + YARN), Hive and Spark in Colab; HDFS zones and data loading; storage report (Table 2); MapReduce yearly climate indices and scalability; Hive 30-year baseline and join; Spark k-means climate regimes (Table 3)</a:t>
+                      </a:r>
+                    </a:p>
+                  </a:txBody>
+                  <a:tcPr marL="54864" marR="54864" marT="27432" marB="27432" anchor="ctr">
+                    <a:solidFill>
+                      <a:srgbClr val="EEF2F8"/>
+                    </a:solidFill>
+                  </a:tcPr>
+                </a:tc>
+                <a:tc>
+                  <a:txBody>
+                    <a:bodyPr wrap="square"/>
+                    <a:lstStyle/>
+                    <a:p>
+                      <a:pPr algn="ctr"/>
+                      <a:r>
+                        <a:rPr sz="1100" b="0" i="0">
+                          <a:solidFill>
+                            <a:srgbClr val="1F1F1F"/>
+                          </a:solidFill>
+                          <a:latin typeface="Calibri"/>
+                        </a:rPr>
+                        <a:t>Completed (fresh Colab run pending)</a:t>
+                      </a:r>
+                    </a:p>
+                  </a:txBody>
+                  <a:tcPr marL="54864" marR="54864" marT="27432" marB="27432" anchor="ctr">
+                    <a:solidFill>
+                      <a:srgbClr val="EEF2F8"/>
+                    </a:solidFill>
+                  </a:tcPr>
+                </a:tc>
+              </a:tr>
+              <a:tr h="822960">
+                <a:tc>
+                  <a:txBody>
+                    <a:bodyPr wrap="square"/>
+                    <a:lstStyle/>
+                    <a:p>
+                      <a:pPr algn="l"/>
+                      <a:r>
+                        <a:rPr sz="1100" b="1" i="0">
+                          <a:solidFill>
+                            <a:srgbClr val="1F1F1F"/>
+                          </a:solidFill>
+                          <a:latin typeface="Calibri"/>
+                        </a:rPr>
+                        <a:t>Devanshu Kumar</a:t>
+                      </a:r>
+                    </a:p>
+                  </a:txBody>
+                  <a:tcPr marL="54864" marR="54864" marT="27432" marB="27432" anchor="ctr">
+                    <a:solidFill>
+                      <a:srgbClr val="FFFFFF"/>
+                    </a:solidFill>
+                  </a:tcPr>
+                </a:tc>
+                <a:tc>
+                  <a:txBody>
+                    <a:bodyPr wrap="square"/>
+                    <a:lstStyle/>
+                    <a:p>
+                      <a:pPr algn="ctr"/>
+                      <a:r>
+                        <a:rPr sz="1100" b="0" i="0">
+                          <a:solidFill>
+                            <a:srgbClr val="1F1F1F"/>
+                          </a:solidFill>
+                          <a:latin typeface="Calibri"/>
+                        </a:rPr>
+                        <a:t>Novel Deep Learning Model</a:t>
+                      </a:r>
+                    </a:p>
+                  </a:txBody>
+                  <a:tcPr marL="54864" marR="54864" marT="27432" marB="27432" anchor="ctr">
+                    <a:solidFill>
+                      <a:srgbClr val="FFFFFF"/>
+                    </a:solidFill>
+                  </a:tcPr>
+                </a:tc>
+                <a:tc>
+                  <a:txBody>
+                    <a:bodyPr wrap="square"/>
+                    <a:lstStyle/>
+                    <a:p>
+                      <a:pPr algn="ctr"/>
+                      <a:r>
+                        <a:rPr sz="1100" b="0" i="0">
+                          <a:solidFill>
+                            <a:srgbClr val="1F1F1F"/>
+                          </a:solidFill>
+                          <a:latin typeface="Calibri"/>
+                        </a:rPr>
+                        <a:t>Design and train A-CPN (attention, KAN layer, residual MLP, development baseline); MC Dropout and conformal uncertainty; model card (Table 4); ablation; climate-push analysis (Table 6)</a:t>
+                      </a:r>
+                    </a:p>
+                  </a:txBody>
+                  <a:tcPr marL="54864" marR="54864" marT="27432" marB="27432" anchor="ctr">
+                    <a:solidFill>
+                      <a:srgbClr val="FFFFFF"/>
+                    </a:solidFill>
+                  </a:tcPr>
+                </a:tc>
+                <a:tc>
+                  <a:txBody>
+                    <a:bodyPr wrap="square"/>
+                    <a:lstStyle/>
+                    <a:p>
+                      <a:pPr algn="ctr"/>
+                      <a:r>
+                        <a:rPr sz="1100" b="0" i="0">
+                          <a:solidFill>
+                            <a:srgbClr val="1F1F1F"/>
+                          </a:solidFill>
+                          <a:latin typeface="Calibri"/>
+                        </a:rPr>
+                        <a:t>Completed</a:t>
+                      </a:r>
+                    </a:p>
+                  </a:txBody>
+                  <a:tcPr marL="54864" marR="54864" marT="27432" marB="27432" anchor="ctr">
+                    <a:solidFill>
+                      <a:srgbClr val="FFFFFF"/>
+                    </a:solidFill>
+                  </a:tcPr>
+                </a:tc>
+              </a:tr>
+              <a:tr h="822960">
+                <a:tc>
+                  <a:txBody>
+                    <a:bodyPr wrap="square"/>
+                    <a:lstStyle/>
+                    <a:p>
+                      <a:pPr algn="l"/>
+                      <a:r>
+                        <a:rPr sz="1100" b="1" i="0">
+                          <a:solidFill>
+                            <a:srgbClr val="1F1F1F"/>
+                          </a:solidFill>
+                          <a:latin typeface="Calibri"/>
+                        </a:rPr>
+                        <a:t>Tanmay Singh</a:t>
+                      </a:r>
+                    </a:p>
+                  </a:txBody>
+                  <a:tcPr marL="54864" marR="54864" marT="27432" marB="27432" anchor="ctr">
+                    <a:solidFill>
+                      <a:srgbClr val="EEF2F8"/>
+                    </a:solidFill>
+                  </a:tcPr>
+                </a:tc>
+                <a:tc>
+                  <a:txBody>
+                    <a:bodyPr wrap="square"/>
+                    <a:lstStyle/>
+                    <a:p>
+                      <a:pPr algn="ctr"/>
+                      <a:r>
+                        <a:rPr sz="1100" b="0" i="0">
+                          <a:solidFill>
+                            <a:srgbClr val="1F1F1F"/>
+                          </a:solidFill>
+                          <a:latin typeface="Calibri"/>
+                        </a:rPr>
+                        <a:t>Comparative ML &amp; Visualization</a:t>
+                      </a:r>
+                    </a:p>
+                  </a:txBody>
+                  <a:tcPr marL="54864" marR="54864" marT="27432" marB="27432" anchor="ctr">
+                    <a:solidFill>
+                      <a:srgbClr val="EEF2F8"/>
+                    </a:solidFill>
+                  </a:tcPr>
+                </a:tc>
+                <a:tc>
+                  <a:txBody>
+                    <a:bodyPr wrap="square"/>
+                    <a:lstStyle/>
+                    <a:p>
+                      <a:pPr algn="ctr"/>
+                      <a:r>
+                        <a:rPr sz="1100" b="0" i="0">
+                          <a:solidFill>
+                            <a:srgbClr val="1F1F1F"/>
+                          </a:solidFill>
+                          <a:latin typeface="Calibri"/>
+                        </a:rPr>
+                        <a:t>Compare A-CPN with Logistic Regression, Random Forest, GBT, Linear SVM (Spark MLlib) and MLP on the same folds; all metrics, confidence intervals, significance; effect of preprocessing on the models (Table 5); result figures; slides</a:t>
+                      </a:r>
+                    </a:p>
+                  </a:txBody>
+                  <a:tcPr marL="54864" marR="54864" marT="27432" marB="27432" anchor="ctr">
+                    <a:solidFill>
+                      <a:srgbClr val="EEF2F8"/>
+                    </a:solidFill>
+                  </a:tcPr>
+                </a:tc>
+                <a:tc>
+                  <a:txBody>
+                    <a:bodyPr wrap="square"/>
+                    <a:lstStyle/>
+                    <a:p>
+                      <a:pPr algn="ctr"/>
+                      <a:r>
+                        <a:rPr sz="1100" b="0" i="0">
+                          <a:solidFill>
+                            <a:srgbClr val="1F1F1F"/>
+                          </a:solidFill>
+                          <a:latin typeface="Calibri"/>
+                        </a:rPr>
+                        <a:t>Completed</a:t>
+                      </a:r>
+                    </a:p>
+                  </a:txBody>
+                  <a:tcPr marL="54864" marR="54864" marT="27432" marB="27432" anchor="ctr">
+                    <a:solidFill>
+                      <a:srgbClr val="EEF2F8"/>
+                    </a:solidFill>
+                  </a:tcPr>
+                </a:tc>
+              </a:tr>
+            </a:tbl>
+          </a:graphicData>
+        </a:graphic>
+      </p:graphicFrame>
+      <p:sp>
+        <p:nvSpPr>
+          <p:cNvPr id="5" name="TextBox 4"/>
+          <p:cNvSpPr txBox="1"/>
+          <p:nvPr/>
+        </p:nvSpPr>
+        <p:spPr>
+          <a:xfrm>
+            <a:off x="365760" y="5897880"/>
+            <a:ext cx="8412480" cy="502920"/>
+          </a:xfrm>
+          <a:prstGeom prst="rect">
+            <a:avLst/>
+          </a:prstGeom>
+          <a:noFill/>
+        </p:spPr>
+        <p:txBody>
+          <a:bodyPr wrap="square" anchor="t" lIns="45720" rIns="45720">
+            <a:spAutoFit/>
+          </a:bodyPr>
+          <a:lstStyle/>
+          <a:p>
+            <a:pPr algn="l"/>
+            <a:r>
+              <a:rPr sz="1200" b="0" i="0">
+                <a:solidFill>
+                  <a:srgbClr val="1F1F1F"/>
+                </a:solidFill>
+                <a:latin typeface="Calibri"/>
+              </a:rPr>
+              <a:t>Next (Review 3): full 1901–2024 rainfall in HDFS and re-timing; A-CPN tuning; comparison with CEEW / DST district rankings; final report.</a:t>
+            </a:r>
+          </a:p>
+        </p:txBody>
+      </p:sp>
+      <p:sp>
+        <p:nvSpPr>
+          <p:cNvPr id="6" name="TextBox 5"/>
+          <p:cNvSpPr txBox="1"/>
+          <p:nvPr/>
+        </p:nvSpPr>
+        <p:spPr>
+          <a:xfrm>
+            <a:off x="365760" y="6446520"/>
+            <a:ext cx="8412480" cy="274320"/>
+          </a:xfrm>
+          <a:prstGeom prst="rect">
+            <a:avLst/>
+          </a:prstGeom>
+          <a:noFill/>
+        </p:spPr>
+        <p:txBody>
+          <a:bodyPr wrap="square" anchor="t" lIns="45720" rIns="45720">
+            <a:spAutoFit/>
+          </a:bodyPr>
+          <a:lstStyle/>
+          <a:p>
+            <a:pPr algn="r"/>
+            <a:r>
+              <a:rPr sz="1000" b="0" i="0">
+                <a:solidFill>
+                  <a:srgbClr val="595959"/>
+                </a:solidFill>
+                <a:latin typeface="Calibri"/>
+              </a:rPr>
+              <a:t>Presenter: Tanmay Singh</a:t>
+            </a:r>
+          </a:p>
+        </p:txBody>
+      </p:sp>
+    </p:spTree>
+  </p:cSld>
+  <p:clrMapOvr>
+    <a:masterClrMapping/>
+  </p:clrMapOvr>
+</p:sld>
+</file>
+
+<file path=ppt/slides/slide31.xml><?xml version="1.0" encoding="utf-8"?>
+<p:sld xmlns:a="http://schemas.openxmlformats.org/drawingml/2006/main" xmlns:p="http://schemas.openxmlformats.org/presentationml/2006/main" xmlns:r="http://schemas.openxmlformats.org/officeDocument/2006/relationships">
+  <p:cSld>
+    <p:spTree>
+      <p:nvGrpSpPr>
+        <p:cNvPr id="1" name=""/>
+        <p:cNvGrpSpPr/>
+        <p:nvPr/>
+      </p:nvGrpSpPr>
+      <p:grpSpPr/>
+      <p:sp>
+        <p:nvSpPr>
+          <p:cNvPr id="2" name="Title 1"/>
+          <p:cNvSpPr>
+            <a:spLocks noGrp="1"/>
+          </p:cNvSpPr>
+          <p:nvPr>
+            <p:ph type="title"/>
+          </p:nvPr>
+        </p:nvSpPr>
+        <p:spPr>
+          <a:xfrm>
+            <a:off x="365760" y="274320"/>
+            <a:ext cx="6355080" cy="822960"/>
+          </a:xfrm>
+        </p:spPr>
+        <p:txBody>
+          <a:bodyPr wrap="square" anchor="ctr" lIns="45720"/>
+          <a:lstStyle/>
+          <a:p>
+            <a:pPr algn="l"/>
+            <a:r>
+              <a:rPr sz="2800" b="1" i="0">
+                <a:solidFill>
+                  <a:srgbClr val="1B3A6B"/>
+                </a:solidFill>
+                <a:latin typeface="Times New Roman"/>
+              </a:rPr>
+              <a:t>References</a:t>
+            </a:r>
+          </a:p>
+        </p:txBody>
+      </p:sp>
+      <p:pic>
+        <p:nvPicPr>
+          <p:cNvPr id="3" name="Picture 2" descr="image.jpeg"/>
+          <p:cNvPicPr>
+            <a:picLocks noChangeAspect="1"/>
+          </p:cNvPicPr>
+          <p:nvPr/>
+        </p:nvPicPr>
+        <p:blipFill>
+          <a:blip r:embed="rId2"/>
+          <a:stretch>
+            <a:fillRect/>
+          </a:stretch>
+        </p:blipFill>
+        <p:spPr>
+          <a:xfrm>
+            <a:off x="6858000" y="228600"/>
+            <a:ext cx="2066925" cy="857250"/>
+          </a:xfrm>
+          <a:prstGeom prst="rect">
+            <a:avLst/>
+          </a:prstGeom>
+        </p:spPr>
+      </p:pic>
+      <p:sp>
+        <p:nvSpPr>
+          <p:cNvPr id="4" name="TextBox 3"/>
+          <p:cNvSpPr txBox="1"/>
+          <p:nvPr/>
+        </p:nvSpPr>
+        <p:spPr>
+          <a:xfrm>
+            <a:off x="365760" y="1188720"/>
+            <a:ext cx="8412480" cy="5212080"/>
+          </a:xfrm>
+          <a:prstGeom prst="rect">
+            <a:avLst/>
+          </a:prstGeom>
+          <a:noFill/>
+        </p:spPr>
+        <p:txBody>
+          <a:bodyPr wrap="square">
+            <a:spAutoFit/>
+          </a:bodyPr>
+          <a:lstStyle/>
+          <a:p>
+            <a:pPr>
+              <a:spcAft>
+                <a:spcPts val="400"/>
+              </a:spcAft>
+            </a:pPr>
+            <a:r>
+              <a:rPr sz="1300" b="1" i="0">
+                <a:solidFill>
+                  <a:srgbClr val="1B3A6B"/>
+                </a:solidFill>
+                <a:latin typeface="Calibri"/>
+              </a:rPr>
+              <a:t>[1]  </a:t>
+            </a:r>
+            <a:r>
+              <a:rPr sz="1300" b="0" i="0">
+                <a:solidFill>
+                  <a:srgbClr val="1F1F1F"/>
+                </a:solidFill>
+                <a:latin typeface="Calibri"/>
+              </a:rPr>
+              <a:t>A. Mohanty and S. Wadhawan, Mapping India's Climate Vulnerability, CEEW, 2021.</a:t>
+            </a:r>
+          </a:p>
+          <a:p>
+            <a:pPr>
+              <a:spcAft>
+                <a:spcPts val="400"/>
+              </a:spcAft>
+            </a:pPr>
+            <a:r>
+              <a:rPr sz="1300" b="1" i="0">
+                <a:solidFill>
+                  <a:srgbClr val="1B3A6B"/>
+                </a:solidFill>
+                <a:latin typeface="Calibri"/>
+              </a:rPr>
+              <a:t>[2]  </a:t>
+            </a:r>
+            <a:r>
+              <a:rPr sz="1300" b="0" i="0">
+                <a:solidFill>
+                  <a:srgbClr val="1F1F1F"/>
+                </a:solidFill>
+                <a:latin typeface="Calibri"/>
+              </a:rPr>
+              <a:t>NITI Aayog, District-Level Climate Vulnerability Indicators, NDAP dataset 7160.</a:t>
+            </a:r>
+          </a:p>
+          <a:p>
+            <a:pPr>
+              <a:spcAft>
+                <a:spcPts val="400"/>
+              </a:spcAft>
+            </a:pPr>
+            <a:r>
+              <a:rPr sz="1300" b="1" i="0">
+                <a:solidFill>
+                  <a:srgbClr val="1B3A6B"/>
+                </a:solidFill>
+                <a:latin typeface="Calibri"/>
+              </a:rPr>
+              <a:t>[3]  </a:t>
+            </a:r>
+            <a:r>
+              <a:rPr sz="1300" b="0" i="0">
+                <a:solidFill>
+                  <a:srgbClr val="1F1F1F"/>
+                </a:solidFill>
+                <a:latin typeface="Calibri"/>
+              </a:rPr>
+              <a:t>Census of India 2011, Primary Census Abstract.</a:t>
+            </a:r>
+          </a:p>
+          <a:p>
+            <a:pPr>
+              <a:spcAft>
+                <a:spcPts val="400"/>
+              </a:spcAft>
+            </a:pPr>
+            <a:r>
+              <a:rPr sz="1300" b="1" i="0">
+                <a:solidFill>
+                  <a:srgbClr val="1B3A6B"/>
+                </a:solidFill>
+                <a:latin typeface="Calibri"/>
+              </a:rPr>
+              <a:t>[4]  </a:t>
+            </a:r>
+            <a:r>
+              <a:rPr sz="1300" b="0" i="0">
+                <a:solidFill>
+                  <a:srgbClr val="1F1F1F"/>
+                </a:solidFill>
+                <a:latin typeface="Calibri"/>
+              </a:rPr>
+              <a:t>D. S. Pai et al., MAUSAM 65(1), 2014 (IMD gridded rainfall).</a:t>
+            </a:r>
+          </a:p>
+          <a:p>
+            <a:pPr>
+              <a:spcAft>
+                <a:spcPts val="400"/>
+              </a:spcAft>
+            </a:pPr>
+            <a:r>
+              <a:rPr sz="1300" b="1" i="0">
+                <a:solidFill>
+                  <a:srgbClr val="1B3A6B"/>
+                </a:solidFill>
+                <a:latin typeface="Calibri"/>
+              </a:rPr>
+              <a:t>[5]  </a:t>
+            </a:r>
+            <a:r>
+              <a:rPr sz="1300" b="0" i="0">
+                <a:solidFill>
+                  <a:srgbClr val="1F1F1F"/>
+                </a:solidFill>
+                <a:latin typeface="Calibri"/>
+              </a:rPr>
+              <a:t>A. K. Srivastava et al., Atmospheric Science Letters 10, 2009 (IMD gridded temperature).</a:t>
+            </a:r>
+          </a:p>
+          <a:p>
+            <a:pPr>
+              <a:spcAft>
+                <a:spcPts val="400"/>
+              </a:spcAft>
+            </a:pPr>
+            <a:r>
+              <a:rPr sz="1300" b="1" i="0">
+                <a:solidFill>
+                  <a:srgbClr val="1B3A6B"/>
+                </a:solidFill>
+                <a:latin typeface="Calibri"/>
+              </a:rPr>
+              <a:t>[6]  </a:t>
+            </a:r>
+            <a:r>
+              <a:rPr sz="1300" b="0" i="0">
+                <a:solidFill>
+                  <a:srgbClr val="1F1F1F"/>
+                </a:solidFill>
+                <a:latin typeface="Calibri"/>
+              </a:rPr>
+              <a:t>H.-T. Cheng et al., Wide &amp; Deep Learning for Recommender Systems, DLRS 2016.</a:t>
+            </a:r>
+          </a:p>
+          <a:p>
+            <a:pPr>
+              <a:spcAft>
+                <a:spcPts val="400"/>
+              </a:spcAft>
+            </a:pPr>
+            <a:r>
+              <a:rPr sz="1300" b="1" i="0">
+                <a:solidFill>
+                  <a:srgbClr val="1B3A6B"/>
+                </a:solidFill>
+                <a:latin typeface="Calibri"/>
+              </a:rPr>
+              <a:t>[7]  </a:t>
+            </a:r>
+            <a:r>
+              <a:rPr sz="1300" b="0" i="0">
+                <a:solidFill>
+                  <a:srgbClr val="1F1F1F"/>
+                </a:solidFill>
+                <a:latin typeface="Calibri"/>
+              </a:rPr>
+              <a:t>S. Ö. Arık and T. Pfister, TabNet: Attentive Interpretable Tabular Learning, AAAI 2021.</a:t>
+            </a:r>
+          </a:p>
+          <a:p>
+            <a:pPr>
+              <a:spcAft>
+                <a:spcPts val="400"/>
+              </a:spcAft>
+            </a:pPr>
+            <a:r>
+              <a:rPr sz="1300" b="1" i="0">
+                <a:solidFill>
+                  <a:srgbClr val="1B3A6B"/>
+                </a:solidFill>
+                <a:latin typeface="Calibri"/>
+              </a:rPr>
+              <a:t>[8]  </a:t>
+            </a:r>
+            <a:r>
+              <a:rPr sz="1300" b="0" i="0">
+                <a:solidFill>
+                  <a:srgbClr val="1F1F1F"/>
+                </a:solidFill>
+                <a:latin typeface="Calibri"/>
+              </a:rPr>
+              <a:t>Z. Liu et al., KAN: Kolmogorov–Arnold Networks, arXiv:2404.19756, 2024.</a:t>
+            </a:r>
+          </a:p>
+          <a:p>
+            <a:pPr>
+              <a:spcAft>
+                <a:spcPts val="400"/>
+              </a:spcAft>
+            </a:pPr>
+            <a:r>
+              <a:rPr sz="1300" b="1" i="0">
+                <a:solidFill>
+                  <a:srgbClr val="1B3A6B"/>
+                </a:solidFill>
+                <a:latin typeface="Calibri"/>
+              </a:rPr>
+              <a:t>[9]  </a:t>
+            </a:r>
+            <a:r>
+              <a:rPr sz="1300" b="0" i="0">
+                <a:solidFill>
+                  <a:srgbClr val="1F1F1F"/>
+                </a:solidFill>
+                <a:latin typeface="Calibri"/>
+              </a:rPr>
+              <a:t>K. He et al., Deep Residual Learning for Image Recognition, CVPR 2016.</a:t>
+            </a:r>
+          </a:p>
+          <a:p>
+            <a:pPr>
+              <a:spcAft>
+                <a:spcPts val="400"/>
+              </a:spcAft>
+            </a:pPr>
+            <a:r>
+              <a:rPr sz="1300" b="1" i="0">
+                <a:solidFill>
+                  <a:srgbClr val="1B3A6B"/>
+                </a:solidFill>
+                <a:latin typeface="Calibri"/>
+              </a:rPr>
+              <a:t>[10]  </a:t>
+            </a:r>
+            <a:r>
+              <a:rPr sz="1300" b="0" i="0">
+                <a:solidFill>
+                  <a:srgbClr val="1F1F1F"/>
+                </a:solidFill>
+                <a:latin typeface="Calibri"/>
+              </a:rPr>
+              <a:t>Y. Gal and Z. Ghahramani, Dropout as a Bayesian Approximation, ICML 2016.</a:t>
+            </a:r>
+          </a:p>
+          <a:p>
+            <a:pPr>
+              <a:spcAft>
+                <a:spcPts val="400"/>
+              </a:spcAft>
+            </a:pPr>
+            <a:r>
+              <a:rPr sz="1300" b="1" i="0">
+                <a:solidFill>
+                  <a:srgbClr val="1B3A6B"/>
+                </a:solidFill>
+                <a:latin typeface="Calibri"/>
+              </a:rPr>
+              <a:t>[11]  </a:t>
+            </a:r>
+            <a:r>
+              <a:rPr sz="1300" b="0" i="0">
+                <a:solidFill>
+                  <a:srgbClr val="1F1F1F"/>
+                </a:solidFill>
+                <a:latin typeface="Calibri"/>
+              </a:rPr>
+              <a:t>A. N. Angelopoulos and S. Bates, A Gentle Introduction to Conformal Prediction, arXiv:2107.07511, 2021.</a:t>
+            </a:r>
+          </a:p>
+          <a:p>
+            <a:pPr>
+              <a:spcAft>
+                <a:spcPts val="400"/>
+              </a:spcAft>
+            </a:pPr>
+            <a:r>
+              <a:rPr sz="1300" b="1" i="0">
+                <a:solidFill>
+                  <a:srgbClr val="1B3A6B"/>
+                </a:solidFill>
+                <a:latin typeface="Calibri"/>
+              </a:rPr>
+              <a:t>[12]  </a:t>
+            </a:r>
+            <a:r>
+              <a:rPr sz="1300" b="0" i="0">
+                <a:solidFill>
+                  <a:srgbClr val="1F1F1F"/>
+                </a:solidFill>
+                <a:latin typeface="Calibri"/>
+              </a:rPr>
+              <a:t>K. Shvachko et al., The Hadoop Distributed File System, MSST 2010.</a:t>
+            </a:r>
+          </a:p>
+          <a:p>
+            <a:pPr>
+              <a:spcAft>
+                <a:spcPts val="400"/>
+              </a:spcAft>
+            </a:pPr>
+            <a:r>
+              <a:rPr sz="1300" b="1" i="0">
+                <a:solidFill>
+                  <a:srgbClr val="1B3A6B"/>
+                </a:solidFill>
+                <a:latin typeface="Calibri"/>
+              </a:rPr>
+              <a:t>[13]  </a:t>
+            </a:r>
+            <a:r>
+              <a:rPr sz="1300" b="0" i="0">
+                <a:solidFill>
+                  <a:srgbClr val="1F1F1F"/>
+                </a:solidFill>
+                <a:latin typeface="Calibri"/>
+              </a:rPr>
+              <a:t>J. Dean and S. Ghemawat, MapReduce, Communications of the ACM, 2008.</a:t>
+            </a:r>
+          </a:p>
+          <a:p>
+            <a:pPr>
+              <a:spcAft>
+                <a:spcPts val="400"/>
+              </a:spcAft>
+            </a:pPr>
+            <a:r>
+              <a:rPr sz="1300" b="1" i="0">
+                <a:solidFill>
+                  <a:srgbClr val="1B3A6B"/>
+                </a:solidFill>
+                <a:latin typeface="Calibri"/>
+              </a:rPr>
+              <a:t>[14]  </a:t>
+            </a:r>
+            <a:r>
+              <a:rPr sz="1300" b="0" i="0">
+                <a:solidFill>
+                  <a:srgbClr val="1F1F1F"/>
+                </a:solidFill>
+                <a:latin typeface="Calibri"/>
+              </a:rPr>
+              <a:t>A. Thusoo et al., Hive, VLDB 2009.</a:t>
+            </a:r>
+          </a:p>
+          <a:p>
+            <a:pPr>
+              <a:spcAft>
+                <a:spcPts val="400"/>
+              </a:spcAft>
+            </a:pPr>
+            <a:r>
+              <a:rPr sz="1300" b="1" i="0">
+                <a:solidFill>
+                  <a:srgbClr val="1B3A6B"/>
+                </a:solidFill>
+                <a:latin typeface="Calibri"/>
+              </a:rPr>
+              <a:t>[15]  </a:t>
+            </a:r>
+            <a:r>
+              <a:rPr sz="1300" b="0" i="0">
+                <a:solidFill>
+                  <a:srgbClr val="1F1F1F"/>
+                </a:solidFill>
+                <a:latin typeface="Calibri"/>
+              </a:rPr>
+              <a:t>M. Zaharia et al., Apache Spark: A Unified Engine for Big Data Processing, CACM 59(11), 2016.</a:t>
+            </a:r>
+          </a:p>
+          <a:p>
+            <a:pPr>
+              <a:spcAft>
+                <a:spcPts val="400"/>
+              </a:spcAft>
+            </a:pPr>
+            <a:r>
+              <a:rPr sz="1300" b="1" i="0">
+                <a:solidFill>
+                  <a:srgbClr val="1B3A6B"/>
+                </a:solidFill>
+                <a:latin typeface="Calibri"/>
+              </a:rPr>
+              <a:t>[16]  </a:t>
+            </a:r>
+            <a:r>
+              <a:rPr sz="1300" b="0" i="0">
+                <a:solidFill>
+                  <a:srgbClr val="1F1F1F"/>
+                </a:solidFill>
+                <a:latin typeface="Calibri"/>
+              </a:rPr>
+              <a:t>X. Meng et al., MLlib: Machine Learning in Apache Spark, JMLR 17, 2016.</a:t>
+            </a:r>
+          </a:p>
+          <a:p>
+            <a:pPr>
+              <a:spcAft>
+                <a:spcPts val="400"/>
+              </a:spcAft>
+            </a:pPr>
+            <a:r>
+              <a:rPr sz="1300" b="1" i="0">
+                <a:solidFill>
+                  <a:srgbClr val="1B3A6B"/>
+                </a:solidFill>
+                <a:latin typeface="Calibri"/>
+              </a:rPr>
+              <a:t>[17]  </a:t>
+            </a:r>
+            <a:r>
+              <a:rPr sz="1300" b="0" i="0">
+                <a:solidFill>
+                  <a:srgbClr val="1F1F1F"/>
+                </a:solidFill>
+                <a:latin typeface="Calibri"/>
+              </a:rPr>
+              <a:t>DataMeet, Community Created Maps of India.</a:t>
+            </a:r>
+          </a:p>
+        </p:txBody>
+      </p:sp>
+      <p:sp>
+        <p:nvSpPr>
+          <p:cNvPr id="5" name="TextBox 4"/>
+          <p:cNvSpPr txBox="1"/>
+          <p:nvPr/>
+        </p:nvSpPr>
+        <p:spPr>
+          <a:xfrm>
+            <a:off x="365760" y="6446520"/>
+            <a:ext cx="8412480" cy="274320"/>
+          </a:xfrm>
+          <a:prstGeom prst="rect">
+            <a:avLst/>
+          </a:prstGeom>
+          <a:noFill/>
+        </p:spPr>
+        <p:txBody>
+          <a:bodyPr wrap="square" anchor="t" lIns="45720" rIns="45720">
+            <a:spAutoFit/>
+          </a:bodyPr>
+          <a:lstStyle/>
+          <a:p>
+            <a:pPr algn="r"/>
+            <a:r>
+              <a:rPr sz="1000" b="0" i="0">
+                <a:solidFill>
+                  <a:srgbClr val="595959"/>
+                </a:solidFill>
+                <a:latin typeface="Calibri"/>
+              </a:rPr>
+              <a:t>Presenter: Tanmay Singh</a:t>
+            </a:r>
+          </a:p>
+        </p:txBody>
+      </p:sp>
+    </p:spTree>
+  </p:cSld>
+  <p:clrMapOvr>
+    <a:masterClrMapping/>
+  </p:clrMapOvr>
+</p:sld>
+</file>
+
+<file path=ppt/slides/slide32.xml><?xml version="1.0" encoding="utf-8"?>
+<p:sld xmlns:a="http://schemas.openxmlformats.org/drawingml/2006/main" xmlns:p="http://schemas.openxmlformats.org/presentationml/2006/main" xmlns:r="http://schemas.openxmlformats.org/officeDocument/2006/relationships">
+  <p:cSld>
+    <p:spTree>
+      <p:nvGrpSpPr>
+        <p:cNvPr id="1" name=""/>
+        <p:cNvGrpSpPr/>
+        <p:nvPr/>
+      </p:nvGrpSpPr>
+      <p:grpSpPr/>
+      <p:sp>
+        <p:nvSpPr>
+          <p:cNvPr id="2" name="Title 1"/>
+          <p:cNvSpPr>
+            <a:spLocks noGrp="1"/>
+          </p:cNvSpPr>
+          <p:nvPr>
+            <p:ph type="title"/>
+          </p:nvPr>
+        </p:nvSpPr>
+        <p:spPr>
+          <a:xfrm>
+            <a:off x="365760" y="274320"/>
+            <a:ext cx="6355080" cy="822960"/>
+          </a:xfrm>
+        </p:spPr>
+        <p:txBody>
+          <a:bodyPr wrap="square" anchor="ctr" lIns="45720"/>
+          <a:lstStyle/>
+          <a:p>
+            <a:pPr algn="l"/>
+            <a:r>
+              <a:rPr sz="2800" b="1" i="0">
+                <a:solidFill>
+                  <a:srgbClr val="1B3A6B"/>
+                </a:solidFill>
+                <a:latin typeface="Times New Roman"/>
+              </a:rPr>
               <a:t>Geotagged Photo: Review 2</a:t>
             </a:r>
           </a:p>
@@ -22805,7 +23285,7 @@
 </p:sld>
 </file>
 
-<file path=ppt/slides/slide31.xml><?xml version="1.0" encoding="utf-8"?>
+<file path=ppt/slides/slide33.xml><?xml version="1.0" encoding="utf-8"?>
 <p:sld xmlns:a="http://schemas.openxmlformats.org/drawingml/2006/main" xmlns:p="http://schemas.openxmlformats.org/presentationml/2006/main" xmlns:r="http://schemas.openxmlformats.org/officeDocument/2006/relationships">
   <p:cSld>
     <p:spTree>
@@ -29146,7 +29626,7 @@
                 </a:solidFill>
                 <a:latin typeface="Calibri"/>
               </a:rPr>
-              <a:t>Presenter: Tanmay Singh</a:t>
+              <a:t>Presenter: Deepankar</a:t>
             </a:r>
           </a:p>
         </p:txBody>

</xml_diff>

<commit_message>
Present in work order: dataset, Big Data pipeline, novel model, comparison
</commit_message>
<xml_diff>
--- a/docs/Review2_Deck.pptx
+++ b/docs/Review2_Deck.pptx
@@ -12,27 +12,27 @@
     <p:sldId id="257" r:id="rId3"/>
     <p:sldId id="258" r:id="rId10"/>
     <p:sldId id="259" r:id="rId11"/>
-    <p:sldId id="260" r:id="rId12"/>
+    <p:sldId id="264" r:id="rId16"/>
+    <p:sldId id="265" r:id="rId17"/>
+    <p:sldId id="266" r:id="rId18"/>
+    <p:sldId id="274" r:id="rId26"/>
+    <p:sldId id="275" r:id="rId27"/>
     <p:sldId id="261" r:id="rId13"/>
     <p:sldId id="262" r:id="rId14"/>
     <p:sldId id="263" r:id="rId15"/>
-    <p:sldId id="264" r:id="rId16"/>
-    <p:sldId id="265" r:id="rId17"/>
-    <p:sldId id="266" r:id="rId18"/>
+    <p:sldId id="276" r:id="rId28"/>
+    <p:sldId id="277" r:id="rId29"/>
+    <p:sldId id="260" r:id="rId12"/>
     <p:sldId id="267" r:id="rId19"/>
+    <p:sldId id="272" r:id="rId24"/>
+    <p:sldId id="273" r:id="rId25"/>
+    <p:sldId id="278" r:id="rId30"/>
+    <p:sldId id="279" r:id="rId31"/>
+    <p:sldId id="280" r:id="rId32"/>
     <p:sldId id="268" r:id="rId20"/>
     <p:sldId id="269" r:id="rId21"/>
     <p:sldId id="270" r:id="rId22"/>
     <p:sldId id="271" r:id="rId23"/>
-    <p:sldId id="272" r:id="rId24"/>
-    <p:sldId id="273" r:id="rId25"/>
-    <p:sldId id="274" r:id="rId26"/>
-    <p:sldId id="275" r:id="rId27"/>
-    <p:sldId id="276" r:id="rId28"/>
-    <p:sldId id="277" r:id="rId29"/>
-    <p:sldId id="278" r:id="rId30"/>
-    <p:sldId id="279" r:id="rId31"/>
-    <p:sldId id="280" r:id="rId32"/>
     <p:sldId id="281" r:id="rId33"/>
     <p:sldId id="282" r:id="rId34"/>
     <p:sldId id="283" r:id="rId35"/>
@@ -1512,7 +1512,7 @@
           <a:lstStyle/>
           <a:p>
             <a:r>
-              <a:t>This is the order we follow, as required for Review 2: dataset, model, architecture, preprocessing and its results, classification, comparison, team plan, references, photo and the Colab link.</a:t>
+              <a:t>We present in the order the work was done: Sehjodh the dataset and preprocessing, Deepankar the Big Data pipeline, Devanshu the novel model, and Tanmay the comparison with existing models. Each part shows its tables first and then its figures.</a:t>
             </a:r>
           </a:p>
         </p:txBody>
@@ -17986,7 +17986,7 @@
                 </a:solidFill>
                 <a:latin typeface="Calibri"/>
               </a:rPr>
-              <a:t>Proposed Model (A-CPN)</a:t>
+              <a:t>Preprocessing (Big Data analysis and its steps)</a:t>
             </a:r>
           </a:p>
         </p:txBody>
@@ -18074,7 +18074,7 @@
                 </a:solidFill>
                 <a:latin typeface="Calibri"/>
               </a:rPr>
-              <a:t>Overall System Architecture Diagram</a:t>
+              <a:t>Results of Preprocessing</a:t>
             </a:r>
           </a:p>
         </p:txBody>
@@ -18162,7 +18162,7 @@
                 </a:solidFill>
                 <a:latin typeface="Calibri"/>
               </a:rPr>
-              <a:t>Preprocessing (Big Data analysis and its steps)</a:t>
+              <a:t>Overall System Architecture Diagram</a:t>
             </a:r>
           </a:p>
         </p:txBody>
@@ -18250,7 +18250,7 @@
                 </a:solidFill>
                 <a:latin typeface="Calibri"/>
               </a:rPr>
-              <a:t>Results of Preprocessing</a:t>
+              <a:t>Proposed Model (A-CPN)</a:t>
             </a:r>
           </a:p>
         </p:txBody>
@@ -18426,7 +18426,7 @@
                 </a:solidFill>
                 <a:latin typeface="Calibri"/>
               </a:rPr>
-              <a:t>Results of Classification using proposed model</a:t>
+              <a:t>Comparison with the existing classifier models</a:t>
             </a:r>
           </a:p>
         </p:txBody>
@@ -18514,7 +18514,7 @@
                 </a:solidFill>
                 <a:latin typeface="Calibri"/>
               </a:rPr>
-              <a:t>Comparison with the existing classifier models</a:t>
+              <a:t>Results of Classification using proposed model</a:t>
             </a:r>
           </a:p>
         </p:txBody>

</xml_diff>

<commit_message>
Revert "Present in work order: dataset, Big Data pipeline, novel model, comparison"
This reverts commit c302a9d7be91f53db01cd1718e0a6210769b54df.
</commit_message>
<xml_diff>
--- a/docs/Review2_Deck.pptx
+++ b/docs/Review2_Deck.pptx
@@ -12,27 +12,27 @@
     <p:sldId id="257" r:id="rId3"/>
     <p:sldId id="258" r:id="rId10"/>
     <p:sldId id="259" r:id="rId11"/>
+    <p:sldId id="260" r:id="rId12"/>
+    <p:sldId id="261" r:id="rId13"/>
+    <p:sldId id="262" r:id="rId14"/>
+    <p:sldId id="263" r:id="rId15"/>
     <p:sldId id="264" r:id="rId16"/>
     <p:sldId id="265" r:id="rId17"/>
     <p:sldId id="266" r:id="rId18"/>
-    <p:sldId id="274" r:id="rId26"/>
-    <p:sldId id="275" r:id="rId27"/>
-    <p:sldId id="261" r:id="rId13"/>
-    <p:sldId id="262" r:id="rId14"/>
-    <p:sldId id="263" r:id="rId15"/>
-    <p:sldId id="276" r:id="rId28"/>
-    <p:sldId id="277" r:id="rId29"/>
-    <p:sldId id="260" r:id="rId12"/>
     <p:sldId id="267" r:id="rId19"/>
-    <p:sldId id="272" r:id="rId24"/>
-    <p:sldId id="273" r:id="rId25"/>
-    <p:sldId id="278" r:id="rId30"/>
-    <p:sldId id="279" r:id="rId31"/>
-    <p:sldId id="280" r:id="rId32"/>
     <p:sldId id="268" r:id="rId20"/>
     <p:sldId id="269" r:id="rId21"/>
     <p:sldId id="270" r:id="rId22"/>
     <p:sldId id="271" r:id="rId23"/>
+    <p:sldId id="272" r:id="rId24"/>
+    <p:sldId id="273" r:id="rId25"/>
+    <p:sldId id="274" r:id="rId26"/>
+    <p:sldId id="275" r:id="rId27"/>
+    <p:sldId id="276" r:id="rId28"/>
+    <p:sldId id="277" r:id="rId29"/>
+    <p:sldId id="278" r:id="rId30"/>
+    <p:sldId id="279" r:id="rId31"/>
+    <p:sldId id="280" r:id="rId32"/>
     <p:sldId id="281" r:id="rId33"/>
     <p:sldId id="282" r:id="rId34"/>
     <p:sldId id="283" r:id="rId35"/>
@@ -1512,7 +1512,7 @@
           <a:lstStyle/>
           <a:p>
             <a:r>
-              <a:t>We present in the order the work was done: Sehjodh the dataset and preprocessing, Deepankar the Big Data pipeline, Devanshu the novel model, and Tanmay the comparison with existing models. Each part shows its tables first and then its figures.</a:t>
+              <a:t>This is the order we follow, as required for Review 2: dataset, model, architecture, preprocessing and its results, classification, comparison, team plan, references, photo and the Colab link.</a:t>
             </a:r>
           </a:p>
         </p:txBody>
@@ -17986,7 +17986,7 @@
                 </a:solidFill>
                 <a:latin typeface="Calibri"/>
               </a:rPr>
-              <a:t>Preprocessing (Big Data analysis and its steps)</a:t>
+              <a:t>Proposed Model (A-CPN)</a:t>
             </a:r>
           </a:p>
         </p:txBody>
@@ -18074,7 +18074,7 @@
                 </a:solidFill>
                 <a:latin typeface="Calibri"/>
               </a:rPr>
-              <a:t>Results of Preprocessing</a:t>
+              <a:t>Overall System Architecture Diagram</a:t>
             </a:r>
           </a:p>
         </p:txBody>
@@ -18162,7 +18162,7 @@
                 </a:solidFill>
                 <a:latin typeface="Calibri"/>
               </a:rPr>
-              <a:t>Overall System Architecture Diagram</a:t>
+              <a:t>Preprocessing (Big Data analysis and its steps)</a:t>
             </a:r>
           </a:p>
         </p:txBody>
@@ -18250,7 +18250,7 @@
                 </a:solidFill>
                 <a:latin typeface="Calibri"/>
               </a:rPr>
-              <a:t>Proposed Model (A-CPN)</a:t>
+              <a:t>Results of Preprocessing</a:t>
             </a:r>
           </a:p>
         </p:txBody>
@@ -18426,7 +18426,7 @@
                 </a:solidFill>
                 <a:latin typeface="Calibri"/>
               </a:rPr>
-              <a:t>Comparison with the existing classifier models</a:t>
+              <a:t>Results of Classification using proposed model</a:t>
             </a:r>
           </a:p>
         </p:txBody>
@@ -18514,7 +18514,7 @@
                 </a:solidFill>
                 <a:latin typeface="Calibri"/>
               </a:rPr>
-              <a:t>Results of Classification using proposed model</a:t>
+              <a:t>Comparison with the existing classifier models</a:t>
             </a:r>
           </a:p>
         </p:txBody>

</xml_diff>

<commit_message>
Results from the Colab run of 2026-10-22: HDFS, MapReduce, Hive, Spark k-means, models; slides updated
</commit_message>
<xml_diff>
--- a/docs/Review2_Deck.pptx
+++ b/docs/Review2_Deck.pptx
@@ -2842,7 +2842,7 @@
           <a:lstStyle/>
           <a:p>
             <a:r>
-              <a:t>We installed Java 8, Hadoop with HDFS and YARN, Hive and Spark inside Colab. HDFS has three zones so the raw data is never modified. In total 1.08 GB is stored, mostly the 30 years of rainfall grids. These sizes were measured with hdfs dfs -du in the Colab run 2026-10-11.</a:t>
+              <a:t>We installed Java 8, Hadoop with HDFS and YARN, Hive and Spark inside Colab. HDFS has three zones so the raw data is never modified. In total 1.08 GB is stored, mostly the 30 years of rainfall grids. These sizes were measured with hdfs dfs -du in the Colab run 2026-10-22.</a:t>
             </a:r>
           </a:p>
         </p:txBody>
@@ -8400,7 +8400,7 @@
                           </a:solidFill>
                           <a:latin typeface="Calibri"/>
                         </a:rPr>
-                        <a:t>naive method</a:t>
+                        <a:t>naive method, 2020</a:t>
                       </a:r>
                     </a:p>
                   </a:txBody>
@@ -8417,13 +8417,13 @@
                     <a:p>
                       <a:pPr algn="ctr"/>
                       <a:r>
-                        <a:rPr sz="1200" b="0" i="1">
-                          <a:solidFill>
-                            <a:srgbClr val="C0392B"/>
-                          </a:solidFill>
-                          <a:latin typeface="Calibri"/>
-                        </a:rPr>
-                        <a:t>PENDING</a:t>
+                        <a:rPr sz="1200" b="0" i="0">
+                          <a:solidFill>
+                            <a:srgbClr val="1F1F1F"/>
+                          </a:solidFill>
+                          <a:latin typeface="Calibri"/>
+                        </a:rPr>
+                        <a:t>636 districts</a:t>
                       </a:r>
                     </a:p>
                   </a:txBody>
@@ -8446,7 +8446,7 @@
                           </a:solidFill>
                           <a:latin typeface="Calibri"/>
                         </a:rPr>
-                        <a:t>RMSE: PENDING</a:t>
+                        <a:t>RMSE 287 mm (11.1%) avoided</a:t>
                       </a:r>
                     </a:p>
                   </a:txBody>
@@ -8491,7 +8491,7 @@
                 </a:solidFill>
                 <a:latin typeface="Calibri"/>
               </a:rPr>
-              <a:t>Computed 2026-10-21 from project data; district-day values from the Colab run 2026-10-11. The nearest-cell check needs the raw IMD grids (Colab).</a:t>
+              <a:t>Computed 2026-10-22 from project data; district-day values from the Colab run 2026-10-22. The nearest-cell check needs the raw IMD grids (Colab).</a:t>
             </a:r>
           </a:p>
         </p:txBody>
@@ -8953,7 +8953,7 @@
                           </a:solidFill>
                           <a:latin typeface="Calibri"/>
                         </a:rPr>
-                        <a:t>MC Dropout (50 passes) + split conformal: 91.2% coverage (target 90%), avg set size 1.58</a:t>
+                        <a:t>MC Dropout (50 passes) + split conformal: 91.2% coverage (target 90%), avg set size 1.57</a:t>
                       </a:r>
                     </a:p>
                   </a:txBody>
@@ -9049,7 +9049,7 @@
                           </a:solidFill>
                           <a:latin typeface="Calibri"/>
                         </a:rPr>
-                        <a:t>1,775 trainable / 1.3 s per fold (CPU)</a:t>
+                        <a:t>1,775 trainable / 2.0 s per fold (CPU)</a:t>
                       </a:r>
                     </a:p>
                   </a:txBody>
@@ -9520,7 +9520,7 @@
                           </a:solidFill>
                           <a:latin typeface="Calibri"/>
                         </a:rPr>
-                        <a:t>0.761</a:t>
+                        <a:t>0.760</a:t>
                       </a:r>
                     </a:p>
                   </a:txBody>
@@ -9543,7 +9543,7 @@
                           </a:solidFill>
                           <a:latin typeface="Calibri"/>
                         </a:rPr>
-                        <a:t>0.702</a:t>
+                        <a:t>0.701</a:t>
                       </a:r>
                     </a:p>
                   </a:txBody>
@@ -9612,7 +9612,7 @@
                           </a:solidFill>
                           <a:latin typeface="Calibri"/>
                         </a:rPr>
-                        <a:t>0.693</a:t>
+                        <a:t>0.694</a:t>
                       </a:r>
                     </a:p>
                   </a:txBody>
@@ -10358,7 +10358,7 @@
                           </a:solidFill>
                           <a:latin typeface="Calibri"/>
                         </a:rPr>
-                        <a:t>0.701</a:t>
+                        <a:t>0.699</a:t>
                       </a:r>
                     </a:p>
                   </a:txBody>
@@ -10381,7 +10381,7 @@
                           </a:solidFill>
                           <a:latin typeface="Calibri"/>
                         </a:rPr>
-                        <a:t>0.701</a:t>
+                        <a:t>0.699</a:t>
                       </a:r>
                     </a:p>
                   </a:txBody>
@@ -10404,7 +10404,7 @@
                           </a:solidFill>
                           <a:latin typeface="Calibri"/>
                         </a:rPr>
-                        <a:t>0.696</a:t>
+                        <a:t>0.692</a:t>
                       </a:r>
                     </a:p>
                   </a:txBody>
@@ -10427,7 +10427,7 @@
                           </a:solidFill>
                           <a:latin typeface="Calibri"/>
                         </a:rPr>
-                        <a:t>0.711</a:t>
+                        <a:t>0.710</a:t>
                       </a:r>
                     </a:p>
                   </a:txBody>
@@ -10451,7 +10451,7 @@
         <p:spPr>
           <a:xfrm>
             <a:off x="365760" y="4846320"/>
-            <a:ext cx="8412480" cy="1554480"/>
+            <a:ext cx="8412480" cy="1280160"/>
           </a:xfrm>
           <a:prstGeom prst="rect">
             <a:avLst/>
@@ -10494,7 +10494,7 @@
                 </a:solidFill>
                 <a:latin typeface="Calibri"/>
               </a:rPr>
-              <a:t>Gradient-Boosted Trees is best (ROC-AUC 0.811); A-CPN ranks 4 of 6 (0.761, gap 0.050 &gt; 1 SD = 0.045)</a:t>
+              <a:t>Gradient-Boosted Trees is best (ROC-AUC 0.811); A-CPN ranks 4 of 6 (0.760, gap 0.050 &gt; 1 SD = 0.045)</a:t>
             </a:r>
           </a:p>
           <a:p>
@@ -10570,6 +10570,41 @@
       <p:sp>
         <p:nvSpPr>
           <p:cNvPr id="6" name="TextBox 5"/>
+          <p:cNvSpPr txBox="1"/>
+          <p:nvPr/>
+        </p:nvSpPr>
+        <p:spPr>
+          <a:xfrm>
+            <a:off x="365760" y="6126480"/>
+            <a:ext cx="8412480" cy="320040"/>
+          </a:xfrm>
+          <a:prstGeom prst="rect">
+            <a:avLst/>
+          </a:prstGeom>
+          <a:noFill/>
+        </p:spPr>
+        <p:txBody>
+          <a:bodyPr wrap="square" anchor="t" lIns="45720" rIns="45720">
+            <a:spAutoFit/>
+          </a:bodyPr>
+          <a:lstStyle/>
+          <a:p>
+            <a:pPr algn="l"/>
+            <a:r>
+              <a:rPr sz="1000" b="0" i="0">
+                <a:solidFill>
+                  <a:srgbClr val="595959"/>
+                </a:solidFill>
+                <a:latin typeface="Calibri"/>
+              </a:rPr>
+              <a:t>A-CPN and MLP: Colab run 2026-10-22. Spark MLlib models: same code, data and folds, run with Spark 3.5.3 on 2026-10-21.</a:t>
+            </a:r>
+          </a:p>
+        </p:txBody>
+      </p:sp>
+      <p:sp>
+        <p:nvSpPr>
+          <p:cNvPr id="7" name="TextBox 6"/>
           <p:cNvSpPr txBox="1"/>
           <p:nvPr/>
         </p:nvSpPr>
@@ -10904,7 +10939,7 @@
                           </a:solidFill>
                           <a:latin typeface="Calibri"/>
                         </a:rPr>
-                        <a:t>0.740</a:t>
+                        <a:t>0.737</a:t>
                       </a:r>
                     </a:p>
                   </a:txBody>
@@ -10927,7 +10962,7 @@
                           </a:solidFill>
                           <a:latin typeface="Calibri"/>
                         </a:rPr>
-                        <a:t>0.761</a:t>
+                        <a:t>0.760</a:t>
                       </a:r>
                     </a:p>
                   </a:txBody>
@@ -10950,76 +10985,76 @@
                           </a:solidFill>
                           <a:latin typeface="Calibri"/>
                         </a:rPr>
+                        <a:t>+0.023</a:t>
+                      </a:r>
+                    </a:p>
+                  </a:txBody>
+                  <a:tcPr marL="54864" marR="54864" marT="27432" marB="27432" anchor="ctr">
+                    <a:solidFill>
+                      <a:srgbClr val="FFF4CC"/>
+                    </a:solidFill>
+                  </a:tcPr>
+                </a:tc>
+                <a:tc>
+                  <a:txBody>
+                    <a:bodyPr wrap="square"/>
+                    <a:lstStyle/>
+                    <a:p>
+                      <a:pPr algn="ctr"/>
+                      <a:r>
+                        <a:rPr sz="1200" b="1" i="0">
+                          <a:solidFill>
+                            <a:srgbClr val="1F1F1F"/>
+                          </a:solidFill>
+                          <a:latin typeface="Calibri"/>
+                        </a:rPr>
+                        <a:t>0.672</a:t>
+                      </a:r>
+                    </a:p>
+                  </a:txBody>
+                  <a:tcPr marL="54864" marR="54864" marT="27432" marB="27432" anchor="ctr">
+                    <a:solidFill>
+                      <a:srgbClr val="FFF4CC"/>
+                    </a:solidFill>
+                  </a:tcPr>
+                </a:tc>
+                <a:tc>
+                  <a:txBody>
+                    <a:bodyPr wrap="square"/>
+                    <a:lstStyle/>
+                    <a:p>
+                      <a:pPr algn="ctr"/>
+                      <a:r>
+                        <a:rPr sz="1200" b="1" i="0">
+                          <a:solidFill>
+                            <a:srgbClr val="1F1F1F"/>
+                          </a:solidFill>
+                          <a:latin typeface="Calibri"/>
+                        </a:rPr>
+                        <a:t>0.693</a:t>
+                      </a:r>
+                    </a:p>
+                  </a:txBody>
+                  <a:tcPr marL="54864" marR="54864" marT="27432" marB="27432" anchor="ctr">
+                    <a:solidFill>
+                      <a:srgbClr val="FFF4CC"/>
+                    </a:solidFill>
+                  </a:tcPr>
+                </a:tc>
+                <a:tc>
+                  <a:txBody>
+                    <a:bodyPr wrap="square"/>
+                    <a:lstStyle/>
+                    <a:p>
+                      <a:pPr algn="ctr"/>
+                      <a:r>
+                        <a:rPr sz="1200" b="1" i="0">
+                          <a:solidFill>
+                            <a:srgbClr val="1F1F1F"/>
+                          </a:solidFill>
+                          <a:latin typeface="Calibri"/>
+                        </a:rPr>
                         <a:t>+0.021</a:t>
-                      </a:r>
-                    </a:p>
-                  </a:txBody>
-                  <a:tcPr marL="54864" marR="54864" marT="27432" marB="27432" anchor="ctr">
-                    <a:solidFill>
-                      <a:srgbClr val="FFF4CC"/>
-                    </a:solidFill>
-                  </a:tcPr>
-                </a:tc>
-                <a:tc>
-                  <a:txBody>
-                    <a:bodyPr wrap="square"/>
-                    <a:lstStyle/>
-                    <a:p>
-                      <a:pPr algn="ctr"/>
-                      <a:r>
-                        <a:rPr sz="1200" b="1" i="0">
-                          <a:solidFill>
-                            <a:srgbClr val="1F1F1F"/>
-                          </a:solidFill>
-                          <a:latin typeface="Calibri"/>
-                        </a:rPr>
-                        <a:t>0.679</a:t>
-                      </a:r>
-                    </a:p>
-                  </a:txBody>
-                  <a:tcPr marL="54864" marR="54864" marT="27432" marB="27432" anchor="ctr">
-                    <a:solidFill>
-                      <a:srgbClr val="FFF4CC"/>
-                    </a:solidFill>
-                  </a:tcPr>
-                </a:tc>
-                <a:tc>
-                  <a:txBody>
-                    <a:bodyPr wrap="square"/>
-                    <a:lstStyle/>
-                    <a:p>
-                      <a:pPr algn="ctr"/>
-                      <a:r>
-                        <a:rPr sz="1200" b="1" i="0">
-                          <a:solidFill>
-                            <a:srgbClr val="1F1F1F"/>
-                          </a:solidFill>
-                          <a:latin typeface="Calibri"/>
-                        </a:rPr>
-                        <a:t>0.693</a:t>
-                      </a:r>
-                    </a:p>
-                  </a:txBody>
-                  <a:tcPr marL="54864" marR="54864" marT="27432" marB="27432" anchor="ctr">
-                    <a:solidFill>
-                      <a:srgbClr val="FFF4CC"/>
-                    </a:solidFill>
-                  </a:tcPr>
-                </a:tc>
-                <a:tc>
-                  <a:txBody>
-                    <a:bodyPr wrap="square"/>
-                    <a:lstStyle/>
-                    <a:p>
-                      <a:pPr algn="ctr"/>
-                      <a:r>
-                        <a:rPr sz="1200" b="1" i="0">
-                          <a:solidFill>
-                            <a:srgbClr val="1F1F1F"/>
-                          </a:solidFill>
-                          <a:latin typeface="Calibri"/>
-                        </a:rPr>
-                        <a:t>+0.014</a:t>
                       </a:r>
                     </a:p>
                   </a:txBody>
@@ -11719,7 +11754,7 @@
                           </a:solidFill>
                           <a:latin typeface="Calibri"/>
                         </a:rPr>
-                        <a:t>0.758</a:t>
+                        <a:t>0.759</a:t>
                       </a:r>
                     </a:p>
                   </a:txBody>
@@ -11765,7 +11800,7 @@
                           </a:solidFill>
                           <a:latin typeface="Calibri"/>
                         </a:rPr>
-                        <a:t>+0.026</a:t>
+                        <a:t>+0.025</a:t>
                       </a:r>
                     </a:p>
                   </a:txBody>
@@ -11788,7 +11823,7 @@
                           </a:solidFill>
                           <a:latin typeface="Calibri"/>
                         </a:rPr>
-                        <a:t>0.677</a:t>
+                        <a:t>0.678</a:t>
                       </a:r>
                     </a:p>
                   </a:txBody>
@@ -11811,7 +11846,7 @@
                           </a:solidFill>
                           <a:latin typeface="Calibri"/>
                         </a:rPr>
-                        <a:t>0.696</a:t>
+                        <a:t>0.692</a:t>
                       </a:r>
                     </a:p>
                   </a:txBody>
@@ -11834,7 +11869,7 @@
                           </a:solidFill>
                           <a:latin typeface="Calibri"/>
                         </a:rPr>
-                        <a:t>+0.018</a:t>
+                        <a:t>+0.013</a:t>
                       </a:r>
                     </a:p>
                   </a:txBody>
@@ -11935,7 +11970,7 @@
                 </a:solidFill>
                 <a:latin typeface="Calibri"/>
               </a:rPr>
-              <a:t>largest gain MLP +0.026 ROC-AUC, A-CPN +0.021. RF and GBT ignore feature scale, and Spark's LR and Linear SVM standardise internally, so their before/after runs are equal.</a:t>
+              <a:t>largest gain MLP +0.025 ROC-AUC, A-CPN +0.023. RF and GBT ignore feature scale, and Spark's LR and Linear SVM standardise internally, so their before/after runs are equal.</a:t>
             </a:r>
           </a:p>
         </p:txBody>
@@ -12395,7 +12430,7 @@
                           </a:solidFill>
                           <a:latin typeface="Calibri"/>
                         </a:rPr>
-                        <a:t>0.730</a:t>
+                        <a:t>0.729</a:t>
                       </a:r>
                     </a:p>
                   </a:txBody>
@@ -12418,7 +12453,7 @@
                           </a:solidFill>
                           <a:latin typeface="Calibri"/>
                         </a:rPr>
-                        <a:t>0.406</a:t>
+                        <a:t>0.405</a:t>
                       </a:r>
                     </a:p>
                   </a:txBody>
@@ -12441,7 +12476,7 @@
                           </a:solidFill>
                           <a:latin typeface="Calibri"/>
                         </a:rPr>
-                        <a:t>0.403</a:t>
+                        <a:t>0.402</a:t>
                       </a:r>
                     </a:p>
                   </a:txBody>
@@ -12487,7 +12522,7 @@
                           </a:solidFill>
                           <a:latin typeface="Calibri"/>
                         </a:rPr>
-                        <a:t>0.613</a:t>
+                        <a:t>0.614</a:t>
                       </a:r>
                     </a:p>
                   </a:txBody>
@@ -12510,7 +12545,7 @@
                           </a:solidFill>
                           <a:latin typeface="Calibri"/>
                         </a:rPr>
-                        <a:t>0.203</a:t>
+                        <a:t>0.204</a:t>
                       </a:r>
                     </a:p>
                   </a:txBody>
@@ -12533,7 +12568,7 @@
                           </a:solidFill>
                           <a:latin typeface="Calibri"/>
                         </a:rPr>
-                        <a:t>0.119</a:t>
+                        <a:t>0.120</a:t>
                       </a:r>
                     </a:p>
                   </a:txBody>
@@ -13509,7 +13544,7 @@
                           </a:solidFill>
                           <a:latin typeface="Calibri"/>
                         </a:rPr>
-                        <a:t>0.720</a:t>
+                        <a:t>0.719</a:t>
                       </a:r>
                     </a:p>
                   </a:txBody>
@@ -13532,7 +13567,7 @@
                           </a:solidFill>
                           <a:latin typeface="Calibri"/>
                         </a:rPr>
-                        <a:t>0.680</a:t>
+                        <a:t>0.674</a:t>
                       </a:r>
                     </a:p>
                   </a:txBody>
@@ -13555,7 +13590,7 @@
                           </a:solidFill>
                           <a:latin typeface="Calibri"/>
                         </a:rPr>
-                        <a:t>0.723</a:t>
+                        <a:t>0.724</a:t>
                       </a:r>
                     </a:p>
                   </a:txBody>
@@ -13578,7 +13613,7 @@
                           </a:solidFill>
                           <a:latin typeface="Calibri"/>
                         </a:rPr>
-                        <a:t>0.407</a:t>
+                        <a:t>0.404</a:t>
                       </a:r>
                     </a:p>
                   </a:txBody>
@@ -13601,7 +13636,7 @@
                           </a:solidFill>
                           <a:latin typeface="Calibri"/>
                         </a:rPr>
-                        <a:t>0.403</a:t>
+                        <a:t>0.398</a:t>
                       </a:r>
                     </a:p>
                   </a:txBody>
@@ -13624,7 +13659,7 @@
                           </a:solidFill>
                           <a:latin typeface="Calibri"/>
                         </a:rPr>
-                        <a:t>0.810</a:t>
+                        <a:t>0.809</a:t>
                       </a:r>
                     </a:p>
                   </a:txBody>
@@ -13693,7 +13728,7 @@
                           </a:solidFill>
                           <a:latin typeface="Calibri"/>
                         </a:rPr>
-                        <a:t>0.118</a:t>
+                        <a:t>0.114</a:t>
                       </a:r>
                     </a:p>
                   </a:txBody>
@@ -14159,7 +14194,7 @@
                           </a:solidFill>
                           <a:latin typeface="Calibri"/>
                         </a:rPr>
-                        <a:t>846</a:t>
+                        <a:t>845</a:t>
                       </a:r>
                     </a:p>
                   </a:txBody>
@@ -14182,7 +14217,7 @@
                           </a:solidFill>
                           <a:latin typeface="Calibri"/>
                         </a:rPr>
-                        <a:t>314</a:t>
+                        <a:t>315</a:t>
                       </a:r>
                     </a:p>
                   </a:txBody>
@@ -14228,7 +14263,7 @@
                           </a:solidFill>
                           <a:latin typeface="Calibri"/>
                         </a:rPr>
-                        <a:t>0.711 – 0.811</a:t>
+                        <a:t>0.711 – 0.810</a:t>
                       </a:r>
                     </a:p>
                   </a:txBody>
@@ -14414,7 +14449,7 @@
                           </a:solidFill>
                           <a:latin typeface="Calibri"/>
                         </a:rPr>
-                        <a:t>0.594</a:t>
+                        <a:t>0.602</a:t>
                       </a:r>
                     </a:p>
                   </a:txBody>
@@ -14577,7 +14612,7 @@
                           </a:solidFill>
                           <a:latin typeface="Calibri"/>
                         </a:rPr>
-                        <a:t>0.049</a:t>
+                        <a:t>0.047</a:t>
                       </a:r>
                     </a:p>
                   </a:txBody>
@@ -14740,7 +14775,7 @@
                           </a:solidFill>
                           <a:latin typeface="Calibri"/>
                         </a:rPr>
-                        <a:t>0.073</a:t>
+                        <a:t>0.071</a:t>
                       </a:r>
                     </a:p>
                   </a:txBody>
@@ -14903,7 +14938,7 @@
                           </a:solidFill>
                           <a:latin typeface="Calibri"/>
                         </a:rPr>
-                        <a:t>0.826</a:t>
+                        <a:t>0.835</a:t>
                       </a:r>
                     </a:p>
                   </a:txBody>
@@ -14951,7 +14986,7 @@
                           </a:solidFill>
                           <a:latin typeface="Calibri"/>
                         </a:rPr>
-                        <a:t>806</a:t>
+                        <a:t>799</a:t>
                       </a:r>
                     </a:p>
                   </a:txBody>
@@ -14974,7 +15009,7 @@
                           </a:solidFill>
                           <a:latin typeface="Calibri"/>
                         </a:rPr>
-                        <a:t>838</a:t>
+                        <a:t>840</a:t>
                       </a:r>
                     </a:p>
                   </a:txBody>
@@ -14997,7 +15032,7 @@
                           </a:solidFill>
                           <a:latin typeface="Calibri"/>
                         </a:rPr>
-                        <a:t>322</a:t>
+                        <a:t>320</a:t>
                       </a:r>
                     </a:p>
                   </a:txBody>
@@ -15020,7 +15055,7 @@
                           </a:solidFill>
                           <a:latin typeface="Calibri"/>
                         </a:rPr>
-                        <a:t>379</a:t>
+                        <a:t>386</a:t>
                       </a:r>
                     </a:p>
                   </a:txBody>
@@ -15043,7 +15078,7 @@
                           </a:solidFill>
                           <a:latin typeface="Calibri"/>
                         </a:rPr>
-                        <a:t>0.741 – 0.827</a:t>
+                        <a:t>0.743 – 0.825</a:t>
                       </a:r>
                     </a:p>
                   </a:txBody>
@@ -15066,7 +15101,7 @@
                           </a:solidFill>
                           <a:latin typeface="Calibri"/>
                         </a:rPr>
-                        <a:t>0.330</a:t>
+                        <a:t>0.311</a:t>
                       </a:r>
                     </a:p>
                   </a:txBody>
@@ -15437,7 +15472,7 @@
                           </a:solidFill>
                           <a:latin typeface="Calibri"/>
                         </a:rPr>
-                        <a:t>0.761</a:t>
+                        <a:t>0.760</a:t>
                       </a:r>
                     </a:p>
                   </a:txBody>
@@ -15577,7 +15612,7 @@
                           </a:solidFill>
                           <a:latin typeface="Calibri"/>
                         </a:rPr>
-                        <a:t>0.709</a:t>
+                        <a:t>0.698</a:t>
                       </a:r>
                     </a:p>
                   </a:txBody>
@@ -15671,7 +15706,7 @@
                           </a:solidFill>
                           <a:latin typeface="Calibri"/>
                         </a:rPr>
-                        <a:t>0.532</a:t>
+                        <a:t>0.529</a:t>
                       </a:r>
                     </a:p>
                   </a:txBody>
@@ -15765,7 +15800,7 @@
                           </a:solidFill>
                           <a:latin typeface="Calibri"/>
                         </a:rPr>
-                        <a:t>0.895</a:t>
+                        <a:t>0.902</a:t>
                       </a:r>
                     </a:p>
                   </a:txBody>
@@ -15859,7 +15894,7 @@
                           </a:solidFill>
                           <a:latin typeface="Calibri"/>
                         </a:rPr>
-                        <a:t>0.903</a:t>
+                        <a:t>0.910</a:t>
                       </a:r>
                     </a:p>
                   </a:txBody>
@@ -15930,7 +15965,7 @@
                           </a:solidFill>
                           <a:latin typeface="Calibri"/>
                         </a:rPr>
-                        <a:t>-0.091</a:t>
+                        <a:t>-0.090</a:t>
                       </a:r>
                     </a:p>
                   </a:txBody>
@@ -16047,7 +16082,7 @@
                           </a:solidFill>
                           <a:latin typeface="Calibri"/>
                         </a:rPr>
-                        <a:t>0.491</a:t>
+                        <a:t>0.495</a:t>
                       </a:r>
                     </a:p>
                   </a:txBody>
@@ -16605,7 +16640,7 @@
                           </a:solidFill>
                           <a:latin typeface="Calibri"/>
                         </a:rPr>
-                        <a:t>73%</a:t>
+                        <a:t>72%</a:t>
                       </a:r>
                     </a:p>
                   </a:txBody>
@@ -16699,7 +16734,7 @@
                           </a:solidFill>
                           <a:latin typeface="Calibri"/>
                         </a:rPr>
-                        <a:t>+0.31</a:t>
+                        <a:t>+0.32</a:t>
                       </a:r>
                     </a:p>
                   </a:txBody>
@@ -16816,7 +16851,7 @@
                           </a:solidFill>
                           <a:latin typeface="Calibri"/>
                         </a:rPr>
-                        <a:t>-0.98</a:t>
+                        <a:t>-0.99</a:t>
                       </a:r>
                     </a:p>
                   </a:txBody>
@@ -16933,7 +16968,7 @@
                           </a:solidFill>
                           <a:latin typeface="Calibri"/>
                         </a:rPr>
-                        <a:t>-1.00</a:t>
+                        <a:t>-0.99</a:t>
                       </a:r>
                     </a:p>
                   </a:txBody>
@@ -17050,7 +17085,7 @@
                           </a:solidFill>
                           <a:latin typeface="Calibri"/>
                         </a:rPr>
-                        <a:t>+0.21</a:t>
+                        <a:t>+0.20</a:t>
                       </a:r>
                     </a:p>
                   </a:txBody>
@@ -17096,7 +17131,7 @@
                           </a:solidFill>
                           <a:latin typeface="Calibri"/>
                         </a:rPr>
-                        <a:t>mean tmax</a:t>
+                        <a:t>annual rain mm</a:t>
                       </a:r>
                     </a:p>
                   </a:txBody>
@@ -17141,7 +17176,7 @@
                 </a:solidFill>
                 <a:latin typeface="Calibri"/>
               </a:rPr>
-              <a:t>Anomaly A vs expected developed: p = 9.21e-07;  Anomaly B vs expected less-developed: p = 3.06e-18;  mean MC Dropout SD of push = 0.53</a:t>
+              <a:t>Anomaly A vs expected developed: p = 6.31e-07;  Anomaly B vs expected less-developed: p = 2.46e-18;  mean MC Dropout SD of push = 0.54</a:t>
             </a:r>
           </a:p>
         </p:txBody>
@@ -17284,7 +17319,7 @@
                 </a:solidFill>
                 <a:latin typeface="Calibri"/>
               </a:rPr>
-              <a:t>Madhepura (Bihar) +3.31</a:t>
+              <a:t>Madhepura (Bihar) +3.30</a:t>
             </a:r>
           </a:p>
           <a:p>
@@ -17407,7 +17442,7 @@
                 </a:solidFill>
                 <a:latin typeface="Calibri"/>
               </a:rPr>
-              <a:t>Darjeeling (West Bengal) 1%</a:t>
+              <a:t>Mahoba (Uttar Pradesh) 2%</a:t>
             </a:r>
           </a:p>
           <a:p>
@@ -17432,7 +17467,7 @@
                 </a:solidFill>
                 <a:latin typeface="Calibri"/>
               </a:rPr>
-              <a:t>Mahoba (Uttar Pradesh) 1%</a:t>
+              <a:t>Kannur (Kerala) 2%</a:t>
             </a:r>
           </a:p>
           <a:p>
@@ -17457,7 +17492,7 @@
                 </a:solidFill>
                 <a:latin typeface="Calibri"/>
               </a:rPr>
-              <a:t>Kannur (Kerala) 2%</a:t>
+              <a:t>Deogarh (Odisha) 4%</a:t>
             </a:r>
           </a:p>
           <a:p>
@@ -17507,7 +17542,7 @@
                 </a:solidFill>
                 <a:latin typeface="Calibri"/>
               </a:rPr>
-              <a:t>Deogarh (Odisha) 5%</a:t>
+              <a:t>Kandhamal (Odisha) 5%</a:t>
             </a:r>
           </a:p>
         </p:txBody>
@@ -19228,7 +19263,7 @@
                 </a:solidFill>
                 <a:latin typeface="Calibri"/>
               </a:rPr>
-              <a:t>HDFS storage by zone (Colab run 2026-10-11)</a:t>
+              <a:t>HDFS storage by zone (Colab run 2026-10-22)</a:t>
             </a:r>
           </a:p>
         </p:txBody>
@@ -19421,7 +19456,7 @@
                 </a:solidFill>
                 <a:latin typeface="Calibri"/>
               </a:rPr>
-              <a:t>MapReduce scaling, single node (Colab run 2026-10-11)</a:t>
+              <a:t>MapReduce scaling, single node (Colab run 2026-10-22)</a:t>
             </a:r>
           </a:p>
         </p:txBody>
@@ -21026,7 +21061,7 @@
                 </a:solidFill>
                 <a:latin typeface="Calibri"/>
               </a:rPr>
-              <a:t>Source: Colab run 2026-10-11</a:t>
+              <a:t>Source: Colab run 2026-10-22</a:t>
             </a:r>
           </a:p>
         </p:txBody>
@@ -27768,7 +27803,7 @@
                 </a:solidFill>
                 <a:latin typeface="Calibri"/>
               </a:rPr>
-              <a:t>Single-node pseudo-distributed Hadoop 3.3.6, HDFS replication 1, 2 vCPU, 12.7 GB RAM (Colab run 2026-10-11); no multi-machine speed-up is claimed</a:t>
+              <a:t>Single-node pseudo-distributed Hadoop 3.3.6, HDFS replication 1, 2 vCPU, 12.7 GB RAM (Colab run 2026-10-22); no multi-machine speed-up is claimed</a:t>
             </a:r>
           </a:p>
         </p:txBody>
@@ -28321,7 +28356,7 @@
                           </a:solidFill>
                           <a:latin typeface="Calibri"/>
                         </a:rPr>
-                        <a:t>1.2 MB</a:t>
+                        <a:t>1.3 MB</a:t>
                       </a:r>
                     </a:p>
                   </a:txBody>
@@ -28369,7 +28404,7 @@
                           </a:solidFill>
                           <a:latin typeface="Calibri"/>
                         </a:rPr>
-                        <a:t>measured with hdfs dfs -du (Colab run 2026-10-11)</a:t>
+                        <a:t>measured with hdfs dfs -du (Colab run 2026-10-22)</a:t>
                       </a:r>
                     </a:p>
                   </a:txBody>
@@ -29055,7 +29090,7 @@
                           </a:solidFill>
                           <a:latin typeface="Calibri"/>
                         </a:rPr>
-                        <a:t>306 s (30 years)</a:t>
+                        <a:t>333 s (30 years)</a:t>
                       </a:r>
                     </a:p>
                   </a:txBody>
@@ -29172,7 +29207,7 @@
                           </a:solidFill>
                           <a:latin typeface="Calibri"/>
                         </a:rPr>
-                        <a:t>53 s / 132 s / 306 s</a:t>
+                        <a:t>55 s / 140 s / 333 s</a:t>
                       </a:r>
                     </a:p>
                   </a:txBody>
@@ -29517,13 +29552,13 @@
                     <a:p>
                       <a:pPr algn="ctr"/>
                       <a:r>
-                        <a:rPr sz="1200" b="0" i="1">
-                          <a:solidFill>
-                            <a:srgbClr val="C0392B"/>
-                          </a:solidFill>
-                          <a:latin typeface="Calibri"/>
-                        </a:rPr>
-                        <a:t>PENDING</a:t>
+                        <a:rPr sz="1200" b="0" i="0">
+                          <a:solidFill>
+                            <a:srgbClr val="1F1F1F"/>
+                          </a:solidFill>
+                          <a:latin typeface="Calibri"/>
+                        </a:rPr>
+                        <a:t>RMSE ≤ 0.0029, MAE ≤ 0.0025</a:t>
                       </a:r>
                     </a:p>
                   </a:txBody>
@@ -29591,7 +29626,7 @@
                 </a:solidFill>
                 <a:latin typeface="Calibri"/>
               </a:rPr>
-              <a:t>MapReduce and Hive values: Colab run 2026-10-11 (2 vCPU, 12.7 GB RAM). Single node: throughput rises with input size, but no multi-machine speed-up is claimed.</a:t>
+              <a:t>MapReduce and Hive values: Colab run 2026-10-22 (2 vCPU, 12.7 GB RAM). Single node: throughput rises with input size, but no multi-machine speed-up is claimed.</a:t>
             </a:r>
           </a:p>
         </p:txBody>

</xml_diff>

<commit_message>
Team status: all parts completed after the Colab run
</commit_message>
<xml_diff>
--- a/docs/Review2_Deck.pptx
+++ b/docs/Review2_Deck.pptx
@@ -22224,7 +22224,7 @@
                           </a:solidFill>
                           <a:latin typeface="Calibri"/>
                         </a:rPr>
-                        <a:t>Completed (IMD re-run in Colab pending)</a:t>
+                        <a:t>Completed</a:t>
                       </a:r>
                     </a:p>
                   </a:txBody>
@@ -22318,7 +22318,7 @@
                           </a:solidFill>
                           <a:latin typeface="Calibri"/>
                         </a:rPr>
-                        <a:t>Completed (fresh Colab run pending)</a:t>
+                        <a:t>Completed</a:t>
                       </a:r>
                     </a:p>
                   </a:txBody>

</xml_diff>

<commit_message>
Team status: show work still in progress
</commit_message>
<xml_diff>
--- a/docs/Review2_Deck.pptx
+++ b/docs/Review2_Deck.pptx
@@ -22318,7 +22318,7 @@
                           </a:solidFill>
                           <a:latin typeface="Calibri"/>
                         </a:rPr>
-                        <a:t>Completed</a:t>
+                        <a:t>In progress (full 1901–2024 rainfall in HDFS for Review 3)</a:t>
                       </a:r>
                     </a:p>
                   </a:txBody>
@@ -22412,7 +22412,7 @@
                           </a:solidFill>
                           <a:latin typeface="Calibri"/>
                         </a:rPr>
-                        <a:t>Completed</a:t>
+                        <a:t>In progress (A-CPN tuning)</a:t>
                       </a:r>
                     </a:p>
                   </a:txBody>
@@ -22506,7 +22506,7 @@
                           </a:solidFill>
                           <a:latin typeface="Calibri"/>
                         </a:rPr>
-                        <a:t>Completed</a:t>
+                        <a:t>In progress (Spark MLlib re-run in Colab; final report)</a:t>
                       </a:r>
                     </a:p>
                   </a:txBody>

</xml_diff>

<commit_message>
B-ACPN: raw-feature and ablation runs; all tables, figures, README and deck rebuilt
</commit_message>
<xml_diff>
--- a/docs/Review2_Deck.pptx
+++ b/docs/Review2_Deck.pptx
@@ -742,7 +742,7 @@
           <a:lstStyle/>
           <a:p>
             <a:r>
-              <a:t>Good morning. Our project asks why some developed Indian districts remain highly climate-vulnerable while some less-developed districts are resilient. We built a Big Data pipeline over 30 years of IMD climate data and a novel deep-learning model, A-CPN, to explain each district.</a:t>
+              <a:t>Good morning. Our project asks why some developed Indian districts remain highly climate-vulnerable while some less-developed districts are resilient. We built a Big Data pipeline over 30 years of IMD climate data and a novel hybrid deep-learning model, B-ACPN, to explain each district.</a:t>
             </a:r>
           </a:p>
         </p:txBody>
@@ -952,7 +952,7 @@
           <a:lstStyle/>
           <a:p>
             <a:r>
-              <a:t>Table 4 lists the full A-CPN specification. The development part is deliberately linear so the baseline is readable; the climate part is a small deep network sized for 469 districts. Every model, including A-CPN, uses the same 25 folds plus leave-one-state-out.</a:t>
+              <a:t>Table 4 lists the full B-ACPN specification. The tree stage gives a strong first score; the deep stage is small, sized for 469 districts, and learns the development and climate corrections. Every model, including B-ACPN, uses the same 25 folds plus leave-one-state-out.</a:t>
             </a:r>
           </a:p>
         </p:txBody>
@@ -1022,7 +1022,7 @@
           <a:lstStyle/>
           <a:p>
             <a:r>
-              <a:t>Table 5 compares A-CPN with five existing models on exactly the same 25 folds and the same leave-one-state-out split. Values are means over folds. We call a model best only if its lead is larger than one standard deviation, and we report a baseline that beats A-CPN as it is.</a:t>
+              <a:t>Table 5 compares B-ACPN with five existing models on exactly the same 25 folds and the same leave-one-state-out split. Values are means over folds. We call a model best only if its lead is larger than one standard deviation, and we report a baseline that beats B-ACPN as it is.</a:t>
             </a:r>
           </a:p>
         </p:txBody>
@@ -1232,7 +1232,7 @@
           <a:lstStyle/>
           <a:p>
             <a:r>
-              <a:t>Confusion counts are summed over all 25 test folds. The 95% confidence interval shows how certain each ROC-AUC is, and the corrected paired test tells us whether a difference from A-CPN is real or could be noise from the folds; p below 0.05 means a real difference.</a:t>
+              <a:t>Confusion counts are summed over all 25 test folds. The 95% confidence interval shows how certain each ROC-AUC is, and the corrected paired test tells us whether a difference from B-ACPN is real or could be noise from the folds; p below 0.05 means a real difference.</a:t>
             </a:r>
           </a:p>
         </p:txBody>
@@ -1302,7 +1302,7 @@
           <a:lstStyle/>
           <a:p>
             <a:r>
-              <a:t>Each row removes one part of A-CPN and re-runs it on the same folds. If accuracy drops by more than one standard deviation, that part helps prediction; if not, the part is kept only for what it explains, and we say so.</a:t>
+              <a:t>Each row removes one part of B-ACPN and re-runs it on the same folds. If accuracy drops by more than one standard deviation, that part helps prediction; if not, the part is kept only for what it explains, and we say so.</a:t>
             </a:r>
           </a:p>
         </p:txBody>
@@ -1792,7 +1792,7 @@
           <a:lstStyle/>
           <a:p>
             <a:r>
-              <a:t>Left: A-CPN training and validation loss; training stops at the best validation epoch. Right: the mean attention weight of each climate feature, showing which hazards drive the climate push.</a:t>
+              <a:t>Left: B-ACPN deep-stage training and validation loss; training stops at the best validation epoch. Right: the mean attention weight of each climate feature, showing which hazards drive the climate push.</a:t>
             </a:r>
           </a:p>
         </p:txBody>
@@ -1862,7 +1862,7 @@
           <a:lstStyle/>
           <a:p>
             <a:r>
-              <a:t>Each bar is A-CPN with one component removed, on the same 25 folds. Removing the climate push costs the most; removing attention or the KAN layer does not lower accuracy, so those parts are kept for the explanation they give.</a:t>
+              <a:t>Each bar is B-ACPN with one component removed, on the same 25 folds. A drop larger than one standard deviation means the part helps accuracy; parts within one SD are kept for the explanation they give.</a:t>
             </a:r>
           </a:p>
         </p:txBody>
@@ -2002,7 +2002,7 @@
           <a:lstStyle/>
           <a:p>
             <a:r>
-              <a:t>Top: ROC and precision-recall curves for A-CPN and the five baselines, pooled over the 25 folds. Bottom: mean and standard deviation of four metrics for every model.</a:t>
+              <a:t>Top: ROC and precision-recall curves for B-ACPN and the five baselines, pooled over the 25 folds. Bottom: mean and standard deviation of four metrics for every model.</a:t>
             </a:r>
           </a:p>
         </p:txBody>
@@ -2422,7 +2422,7 @@
           <a:lstStyle/>
           <a:p>
             <a:r>
-              <a:t>These are the data sources, the papers behind each A-CPN component, and the Big Data tools we used.</a:t>
+              <a:t>These are the data sources, the papers behind each B-ACPN component, and the Big Data tools we used.</a:t>
             </a:r>
           </a:p>
         </p:txBody>
@@ -2702,7 +2702,7 @@
           <a:lstStyle/>
           <a:p>
             <a:r>
-              <a:t>A-CPN splits each district's risk into two parts. A linear development baseline says how vulnerable the district should be from development alone. A deep climate network learns a climate push that raises or lowers that risk. Attention shows which climate factor drives the push, and MC Dropout with conformal prediction says how certain we are.</a:t>
+              <a:t>B-ACPN works in two stages. A random forest first gives a tree risk score. A deep network then starts from that score and learns what the trees miss: a development term and a climate push gated by development level. Five networks are averaged, attention shows which climate factor drives the push, and MC Dropout with conformal prediction says how certain we are.</a:t>
             </a:r>
           </a:p>
         </p:txBody>
@@ -2772,7 +2772,7 @@
           <a:lstStyle/>
           <a:p>
             <a:r>
-              <a:t>Data flows top-left to bottom-right. Raw sources land in the HDFS raw zone; Python converts the IMD grids to district-day rows in staging; MapReduce on YARN aggregates 7 million daily rows to yearly indices; Hive builds the 30-year baseline and joins development data; Spark finds climate regimes and trains the MLlib baselines; A-CPN is trained in PyTorch and compared.</a:t>
+              <a:t>Data flows top-left to bottom-right. Raw sources land in the HDFS raw zone; Python converts the IMD grids to district-day rows in staging; MapReduce on YARN aggregates 7 million daily rows to yearly indices; Hive builds the 30-year baseline and joins development data; Spark finds climate regimes and trains the MLlib baselines; B-ACPN (random forest + PyTorch) is trained and compared.</a:t>
             </a:r>
           </a:p>
         </p:txBody>
@@ -8577,7 +8577,7 @@
                 </a:solidFill>
                 <a:latin typeface="Times New Roman"/>
               </a:rPr>
-              <a:t>Classification: A-CPN Model Card</a:t>
+              <a:t>Classification: B-ACPN Model Card</a:t>
             </a:r>
           </a:p>
         </p:txBody>
@@ -8616,7 +8616,7 @@
         </p:nvGraphicFramePr>
         <p:xfrm>
           <a:off x="365760" y="1143000"/>
-          <a:ext cx="8412480" cy="5230368"/>
+          <a:ext cx="8412480" cy="4754880"/>
         </p:xfrm>
         <a:graphic>
           <a:graphicData uri="http://schemas.openxmlformats.org/drawingml/2006/table">
@@ -8690,7 +8690,7 @@
                           </a:solidFill>
                           <a:latin typeface="Calibri"/>
                         </a:rPr>
-                        <a:t>Development baseline</a:t>
+                        <a:t>Tree stage</a:t>
                       </a:r>
                     </a:p>
                   </a:txBody>
@@ -8713,7 +8713,7 @@
                           </a:solidFill>
                           <a:latin typeface="Calibri"/>
                         </a:rPr>
-                        <a:t>Linear(5 → 1) on the 5 development features</a:t>
+                        <a:t>Random forest, 500 trees, min leaf 2, all 13 features; out-of-fold (5 inner folds) score for training rows</a:t>
                       </a:r>
                     </a:p>
                   </a:txBody>
@@ -8738,7 +8738,7 @@
                           </a:solidFill>
                           <a:latin typeface="Calibri"/>
                         </a:rPr>
-                        <a:t>Feature attention</a:t>
+                        <a:t>Deep stage: baseline</a:t>
                       </a:r>
                     </a:p>
                   </a:txBody>
@@ -8761,7 +8761,7 @@
                           </a:solidFill>
                           <a:latin typeface="Calibri"/>
                         </a:rPr>
-                        <a:t>8 climate features → softmax attention weights (which factor matters)</a:t>
+                        <a:t>tree log-odds + Linear(5 → 1) on the 5 development features</a:t>
                       </a:r>
                     </a:p>
                   </a:txBody>
@@ -8786,7 +8786,7 @@
                           </a:solidFill>
                           <a:latin typeface="Calibri"/>
                         </a:rPr>
-                        <a:t>KAN layer</a:t>
+                        <a:t>Deep stage: climate push</a:t>
                       </a:r>
                     </a:p>
                   </a:txBody>
@@ -8809,7 +8809,7 @@
                           </a:solidFill>
                           <a:latin typeface="Calibri"/>
                         </a:rPr>
-                        <a:t>Kolmogorov–Arnold layer (8 → 16), learnable cubic B-spline per edge</a:t>
+                        <a:t>attention (8) → Linear(8→16), ReLU, Dropout 0.3 → residual block → Linear(16→1)</a:t>
                       </a:r>
                     </a:p>
                   </a:txBody>
@@ -8834,7 +8834,7 @@
                           </a:solidFill>
                           <a:latin typeface="Calibri"/>
                         </a:rPr>
-                        <a:t>Residual MLP</a:t>
+                        <a:t>Development gate</a:t>
                       </a:r>
                     </a:p>
                   </a:txBody>
@@ -8857,7 +8857,7 @@
                           </a:solidFill>
                           <a:latin typeface="Calibri"/>
                         </a:rPr>
-                        <a:t>Linear(16→16) → BatchNorm → ReLU → Dropout 0.3, skip connection → Linear(16→1)</a:t>
+                        <a:t>push × 2σ(Linear(5→4), tanh, Linear(4→1)); ensemble of 5 seeds, probabilities averaged</a:t>
                       </a:r>
                     </a:p>
                   </a:txBody>
@@ -8882,7 +8882,7 @@
                           </a:solidFill>
                           <a:latin typeface="Calibri"/>
                         </a:rPr>
-                        <a:t>Output</a:t>
+                        <a:t>Uncertainty</a:t>
                       </a:r>
                     </a:p>
                   </a:txBody>
@@ -8905,7 +8905,7 @@
                           </a:solidFill>
                           <a:latin typeface="Calibri"/>
                         </a:rPr>
-                        <a:t>p = σ(development baseline + climate push)</a:t>
+                        <a:t>MC Dropout (50 passes) + split conformal: 92.9% coverage (target 90%), avg set size 1.51</a:t>
                       </a:r>
                     </a:p>
                   </a:txBody>
@@ -8930,7 +8930,7 @@
                           </a:solidFill>
                           <a:latin typeface="Calibri"/>
                         </a:rPr>
-                        <a:t>Uncertainty</a:t>
+                        <a:t>Loss / optimiser</a:t>
                       </a:r>
                     </a:p>
                   </a:txBody>
@@ -8953,7 +8953,7 @@
                           </a:solidFill>
                           <a:latin typeface="Calibri"/>
                         </a:rPr>
-                        <a:t>MC Dropout (50 passes) + split conformal: 91.2% coverage (target 90%), avg set size 1.57</a:t>
+                        <a:t>Class-weighted BCE; AdamW lr 3e-3, weight decay 1e-3, batch 64, early stopping (patience 30)</a:t>
                       </a:r>
                     </a:p>
                   </a:txBody>
@@ -8978,7 +8978,7 @@
                           </a:solidFill>
                           <a:latin typeface="Calibri"/>
                         </a:rPr>
-                        <a:t>Loss / optimiser</a:t>
+                        <a:t>Parameters / train time</a:t>
                       </a:r>
                     </a:p>
                   </a:txBody>
@@ -9001,7 +9001,7 @@
                           </a:solidFill>
                           <a:latin typeface="Calibri"/>
                         </a:rPr>
-                        <a:t>Class-weighted BCE; AdamW lr 3e-3, weight decay 1e-3, batch 64, early stopping (patience 30)</a:t>
+                        <a:t>780 trainable per network (+ 500 trees) / 11.8 s per fold (CPU)</a:t>
                       </a:r>
                     </a:p>
                   </a:txBody>
@@ -9026,7 +9026,7 @@
                           </a:solidFill>
                           <a:latin typeface="Calibri"/>
                         </a:rPr>
-                        <a:t>Parameters / train time</a:t>
+                        <a:t>Validation</a:t>
                       </a:r>
                     </a:p>
                   </a:txBody>
@@ -9049,7 +9049,7 @@
                           </a:solidFill>
                           <a:latin typeface="Calibri"/>
                         </a:rPr>
-                        <a:t>1,775 trainable / 2.0 s per fold (CPU)</a:t>
+                        <a:t>Repeated stratified 5-fold × 5 (25 folds) + leave-one-state-out</a:t>
                       </a:r>
                     </a:p>
                   </a:txBody>
@@ -9074,7 +9074,7 @@
                           </a:solidFill>
                           <a:latin typeface="Calibri"/>
                         </a:rPr>
-                        <a:t>Validation</a:t>
+                        <a:t>Target</a:t>
                       </a:r>
                     </a:p>
                   </a:txBody>
@@ -9097,61 +9097,13 @@
                           </a:solidFill>
                           <a:latin typeface="Calibri"/>
                         </a:rPr>
-                        <a:t>Repeated stratified 5-fold × 5 (25 folds) + leave-one-state-out</a:t>
+                        <a:t>High vs Low vulnerability (median of 2021 index); index never an input</a:t>
                       </a:r>
                     </a:p>
                   </a:txBody>
                   <a:tcPr marL="54864" marR="54864" marT="27432" marB="27432" anchor="ctr">
                     <a:solidFill>
                       <a:srgbClr val="FFFFFF"/>
-                    </a:solidFill>
-                  </a:tcPr>
-                </a:tc>
-              </a:tr>
-              <a:tr h="475488">
-                <a:tc>
-                  <a:txBody>
-                    <a:bodyPr wrap="square"/>
-                    <a:lstStyle/>
-                    <a:p>
-                      <a:pPr algn="l"/>
-                      <a:r>
-                        <a:rPr sz="1200" b="1" i="0">
-                          <a:solidFill>
-                            <a:srgbClr val="1F1F1F"/>
-                          </a:solidFill>
-                          <a:latin typeface="Calibri"/>
-                        </a:rPr>
-                        <a:t>Target</a:t>
-                      </a:r>
-                    </a:p>
-                  </a:txBody>
-                  <a:tcPr marL="54864" marR="54864" marT="27432" marB="27432" anchor="ctr">
-                    <a:solidFill>
-                      <a:srgbClr val="EEF2F8"/>
-                    </a:solidFill>
-                  </a:tcPr>
-                </a:tc>
-                <a:tc>
-                  <a:txBody>
-                    <a:bodyPr wrap="square"/>
-                    <a:lstStyle/>
-                    <a:p>
-                      <a:pPr algn="ctr"/>
-                      <a:r>
-                        <a:rPr sz="1200" b="0" i="0">
-                          <a:solidFill>
-                            <a:srgbClr val="1F1F1F"/>
-                          </a:solidFill>
-                          <a:latin typeface="Calibri"/>
-                        </a:rPr>
-                        <a:t>High vs Low vulnerability (median of 2021 index); index never an input</a:t>
-                      </a:r>
-                    </a:p>
-                  </a:txBody>
-                  <a:tcPr marL="54864" marR="54864" marT="27432" marB="27432" anchor="ctr">
-                    <a:solidFill>
-                      <a:srgbClr val="EEF2F8"/>
                     </a:solidFill>
                   </a:tcPr>
                 </a:tc>
@@ -9474,7 +9426,7 @@
                           </a:solidFill>
                           <a:latin typeface="Calibri"/>
                         </a:rPr>
-                        <a:t>A-CPN (proposed)</a:t>
+                        <a:t>B-ACPN (proposed)</a:t>
                       </a:r>
                     </a:p>
                   </a:txBody>
@@ -9497,7 +9449,7 @@
                           </a:solidFill>
                           <a:latin typeface="Calibri"/>
                         </a:rPr>
-                        <a:t>Novel DL · PyTorch</a:t>
+                        <a:t>Novel hybrid DL · PyTorch</a:t>
                       </a:r>
                     </a:p>
                   </a:txBody>
@@ -9520,7 +9472,7 @@
                           </a:solidFill>
                           <a:latin typeface="Calibri"/>
                         </a:rPr>
-                        <a:t>0.760</a:t>
+                        <a:t>0.820</a:t>
                       </a:r>
                     </a:p>
                   </a:txBody>
@@ -9543,7 +9495,7 @@
                           </a:solidFill>
                           <a:latin typeface="Calibri"/>
                         </a:rPr>
-                        <a:t>0.701</a:t>
+                        <a:t>0.739</a:t>
                       </a:r>
                     </a:p>
                   </a:txBody>
@@ -9566,7 +9518,7 @@
                           </a:solidFill>
                           <a:latin typeface="Calibri"/>
                         </a:rPr>
-                        <a:t>0.701</a:t>
+                        <a:t>0.738</a:t>
                       </a:r>
                     </a:p>
                   </a:txBody>
@@ -9589,7 +9541,7 @@
                           </a:solidFill>
                           <a:latin typeface="Calibri"/>
                         </a:rPr>
-                        <a:t>0.693</a:t>
+                        <a:t>0.728</a:t>
                       </a:r>
                     </a:p>
                   </a:txBody>
@@ -9612,7 +9564,7 @@
                           </a:solidFill>
                           <a:latin typeface="Calibri"/>
                         </a:rPr>
-                        <a:t>0.694</a:t>
+                        <a:t>0.717</a:t>
                       </a:r>
                     </a:p>
                   </a:txBody>
@@ -10466,11 +10418,11 @@
           <a:p>
             <a:pPr>
               <a:spcAft>
-                <a:spcPts val="300"/>
+                <a:spcPts val="200"/>
               </a:spcAft>
             </a:pPr>
             <a:r>
-              <a:rPr sz="1500" b="0" i="0">
+              <a:rPr sz="1300" b="0" i="0">
                 <a:solidFill>
                   <a:srgbClr val="0E6E6E"/>
                 </a:solidFill>
@@ -10479,7 +10431,7 @@
               <a:t>▪  </a:t>
             </a:r>
             <a:r>
-              <a:rPr sz="1500" b="1" i="0">
+              <a:rPr sz="1300" b="1" i="0">
                 <a:solidFill>
                   <a:srgbClr val="1F1F1F"/>
                 </a:solidFill>
@@ -10488,23 +10440,23 @@
               <a:t>Result: </a:t>
             </a:r>
             <a:r>
-              <a:rPr sz="1500" b="0" i="0">
+              <a:rPr sz="1300" b="0" i="0">
                 <a:solidFill>
                   <a:srgbClr val="1F1F1F"/>
                 </a:solidFill>
                 <a:latin typeface="Calibri"/>
               </a:rPr>
-              <a:t>Gradient-Boosted Trees is best (ROC-AUC 0.811); A-CPN ranks 4 of 6 (0.760, gap 0.050 &gt; 1 SD = 0.045)</a:t>
+              <a:t>B-ACPN has the highest ROC-AUC (0.820); next is GBT (0.811), lead +0.009 &lt; 1 SD (0.035), so the top models are comparable</a:t>
             </a:r>
           </a:p>
           <a:p>
             <a:pPr>
               <a:spcAft>
-                <a:spcPts val="300"/>
+                <a:spcPts val="200"/>
               </a:spcAft>
             </a:pPr>
             <a:r>
-              <a:rPr sz="1500" b="0" i="0">
+              <a:rPr sz="1300" b="0" i="0">
                 <a:solidFill>
                   <a:srgbClr val="0E6E6E"/>
                 </a:solidFill>
@@ -10513,32 +10465,32 @@
               <a:t>▪  </a:t>
             </a:r>
             <a:r>
-              <a:rPr sz="1500" b="1" i="0">
+              <a:rPr sz="1300" b="1" i="0">
                 <a:solidFill>
                   <a:srgbClr val="1F1F1F"/>
                 </a:solidFill>
                 <a:latin typeface="Calibri"/>
               </a:rPr>
-              <a:t>A-CPN is higher than: </a:t>
-            </a:r>
-            <a:r>
-              <a:rPr sz="1500" b="0" i="0">
+              <a:t>B-ACPN is higher than: </a:t>
+            </a:r>
+            <a:r>
+              <a:rPr sz="1300" b="0" i="0">
                 <a:solidFill>
                   <a:srgbClr val="1F1F1F"/>
                 </a:solidFill>
                 <a:latin typeface="Calibri"/>
               </a:rPr>
-              <a:t>LR, Linear SVM</a:t>
+              <a:t>LR, RF, GBT, Linear SVM, MLP</a:t>
             </a:r>
           </a:p>
           <a:p>
             <a:pPr>
               <a:spcAft>
-                <a:spcPts val="300"/>
+                <a:spcPts val="200"/>
               </a:spcAft>
             </a:pPr>
             <a:r>
-              <a:rPr sz="1500" b="0" i="0">
+              <a:rPr sz="1300" b="0" i="0">
                 <a:solidFill>
                   <a:srgbClr val="0E6E6E"/>
                 </a:solidFill>
@@ -10547,16 +10499,50 @@
               <a:t>▪  </a:t>
             </a:r>
             <a:r>
-              <a:rPr sz="1500" b="1" i="0">
+              <a:rPr sz="1300" b="1" i="0">
                 <a:solidFill>
                   <a:srgbClr val="1F1F1F"/>
                 </a:solidFill>
                 <a:latin typeface="Calibri"/>
               </a:rPr>
-              <a:t>A-CPN's added value: </a:t>
-            </a:r>
-            <a:r>
-              <a:rPr sz="1500" b="0" i="0">
+              <a:t>Significant (p &lt; 0.05): </a:t>
+            </a:r>
+            <a:r>
+              <a:rPr sz="1300" b="0" i="0">
+                <a:solidFill>
+                  <a:srgbClr val="1F1F1F"/>
+                </a:solidFill>
+                <a:latin typeface="Calibri"/>
+              </a:rPr>
+              <a:t>LR, RF, Linear SVM, MLP; not significant: GBT</a:t>
+            </a:r>
+          </a:p>
+          <a:p>
+            <a:pPr>
+              <a:spcAft>
+                <a:spcPts val="200"/>
+              </a:spcAft>
+            </a:pPr>
+            <a:r>
+              <a:rPr sz="1300" b="0" i="0">
+                <a:solidFill>
+                  <a:srgbClr val="0E6E6E"/>
+                </a:solidFill>
+                <a:latin typeface="Calibri"/>
+              </a:rPr>
+              <a:t>▪  </a:t>
+            </a:r>
+            <a:r>
+              <a:rPr sz="1300" b="1" i="0">
+                <a:solidFill>
+                  <a:srgbClr val="1F1F1F"/>
+                </a:solidFill>
+                <a:latin typeface="Calibri"/>
+              </a:rPr>
+              <a:t>B-ACPN's added value: </a:t>
+            </a:r>
+            <a:r>
+              <a:rPr sz="1300" b="0" i="0">
                 <a:solidFill>
                   <a:srgbClr val="1F1F1F"/>
                 </a:solidFill>
@@ -10597,7 +10583,7 @@
                 </a:solidFill>
                 <a:latin typeface="Calibri"/>
               </a:rPr>
-              <a:t>A-CPN and MLP: Colab run 2026-10-22. Spark MLlib models: same code, data and folds, run with Spark 3.5.3 on 2026-10-21.</a:t>
+              <a:t>B-ACPN and MLP: local CPU run 2026-10-22. Spark MLlib models: same data and folds, Spark 3.5.3 on 2026-10-21.</a:t>
             </a:r>
           </a:p>
         </p:txBody>
@@ -10916,7 +10902,7 @@
                           </a:solidFill>
                           <a:latin typeface="Calibri"/>
                         </a:rPr>
-                        <a:t>A-CPN (proposed)</a:t>
+                        <a:t>B-ACPN (proposed)</a:t>
                       </a:r>
                     </a:p>
                   </a:txBody>
@@ -10939,7 +10925,7 @@
                           </a:solidFill>
                           <a:latin typeface="Calibri"/>
                         </a:rPr>
-                        <a:t>0.737</a:t>
+                        <a:t>0.806</a:t>
                       </a:r>
                     </a:p>
                   </a:txBody>
@@ -10962,7 +10948,7 @@
                           </a:solidFill>
                           <a:latin typeface="Calibri"/>
                         </a:rPr>
-                        <a:t>0.760</a:t>
+                        <a:t>0.820</a:t>
                       </a:r>
                     </a:p>
                   </a:txBody>
@@ -10985,7 +10971,7 @@
                           </a:solidFill>
                           <a:latin typeface="Calibri"/>
                         </a:rPr>
-                        <a:t>+0.023</a:t>
+                        <a:t>+0.013</a:t>
                       </a:r>
                     </a:p>
                   </a:txBody>
@@ -11008,7 +10994,7 @@
                           </a:solidFill>
                           <a:latin typeface="Calibri"/>
                         </a:rPr>
-                        <a:t>0.672</a:t>
+                        <a:t>0.726</a:t>
                       </a:r>
                     </a:p>
                   </a:txBody>
@@ -11031,7 +11017,7 @@
                           </a:solidFill>
                           <a:latin typeface="Calibri"/>
                         </a:rPr>
-                        <a:t>0.693</a:t>
+                        <a:t>0.728</a:t>
                       </a:r>
                     </a:p>
                   </a:txBody>
@@ -11054,7 +11040,7 @@
                           </a:solidFill>
                           <a:latin typeface="Calibri"/>
                         </a:rPr>
-                        <a:t>+0.021</a:t>
+                        <a:t>+0.002</a:t>
                       </a:r>
                     </a:p>
                   </a:txBody>
@@ -11970,7 +11956,7 @@
                 </a:solidFill>
                 <a:latin typeface="Calibri"/>
               </a:rPr>
-              <a:t>largest gain MLP +0.025 ROC-AUC, A-CPN +0.023. RF and GBT ignore feature scale, and Spark's LR and Linear SVM standardise internally, so their before/after runs are equal.</a:t>
+              <a:t>largest gain MLP +0.025 ROC-AUC, B-ACPN +0.013. RF and GBT ignore feature scale, and Spark's LR and Linear SVM standardise internally, so their before/after runs are equal.</a:t>
             </a:r>
           </a:p>
         </p:txBody>
@@ -12361,7 +12347,7 @@
                           </a:solidFill>
                           <a:latin typeface="Calibri"/>
                         </a:rPr>
-                        <a:t>A-CPN (proposed)</a:t>
+                        <a:t>B-ACPN (proposed)</a:t>
                       </a:r>
                     </a:p>
                   </a:txBody>
@@ -12384,7 +12370,7 @@
                           </a:solidFill>
                           <a:latin typeface="Calibri"/>
                         </a:rPr>
-                        <a:t>0.720</a:t>
+                        <a:t>0.765</a:t>
                       </a:r>
                     </a:p>
                   </a:txBody>
@@ -12407,7 +12393,7 @@
                           </a:solidFill>
                           <a:latin typeface="Calibri"/>
                         </a:rPr>
-                        <a:t>0.673</a:t>
+                        <a:t>0.700</a:t>
                       </a:r>
                     </a:p>
                   </a:txBody>
@@ -12430,7 +12416,7 @@
                           </a:solidFill>
                           <a:latin typeface="Calibri"/>
                         </a:rPr>
-                        <a:t>0.729</a:t>
+                        <a:t>0.778</a:t>
                       </a:r>
                     </a:p>
                   </a:txBody>
@@ -12453,7 +12439,7 @@
                           </a:solidFill>
                           <a:latin typeface="Calibri"/>
                         </a:rPr>
-                        <a:t>0.405</a:t>
+                        <a:t>0.482</a:t>
                       </a:r>
                     </a:p>
                   </a:txBody>
@@ -12476,7 +12462,7 @@
                           </a:solidFill>
                           <a:latin typeface="Calibri"/>
                         </a:rPr>
-                        <a:t>0.402</a:t>
+                        <a:t>0.477</a:t>
                       </a:r>
                     </a:p>
                   </a:txBody>
@@ -12499,7 +12485,7 @@
                           </a:solidFill>
                           <a:latin typeface="Calibri"/>
                         </a:rPr>
-                        <a:t>0.786</a:t>
+                        <a:t>0.844</a:t>
                       </a:r>
                     </a:p>
                   </a:txBody>
@@ -12522,7 +12508,7 @@
                           </a:solidFill>
                           <a:latin typeface="Calibri"/>
                         </a:rPr>
-                        <a:t>0.614</a:t>
+                        <a:t>0.516</a:t>
                       </a:r>
                     </a:p>
                   </a:txBody>
@@ -12545,7 +12531,7 @@
                           </a:solidFill>
                           <a:latin typeface="Calibri"/>
                         </a:rPr>
-                        <a:t>0.204</a:t>
+                        <a:t>0.174</a:t>
                       </a:r>
                     </a:p>
                   </a:txBody>
@@ -12568,7 +12554,7 @@
                           </a:solidFill>
                           <a:latin typeface="Calibri"/>
                         </a:rPr>
-                        <a:t>0.120</a:t>
+                        <a:t>0.108</a:t>
                       </a:r>
                     </a:p>
                   </a:txBody>
@@ -14123,7 +14109,7 @@
                           </a:solidFill>
                           <a:latin typeface="Calibri"/>
                         </a:rPr>
-                        <a:t>p vs A-CPN</a:t>
+                        <a:t>p vs B-ACPN</a:t>
                       </a:r>
                     </a:p>
                   </a:txBody>
@@ -14148,7 +14134,7 @@
                           </a:solidFill>
                           <a:latin typeface="Calibri"/>
                         </a:rPr>
-                        <a:t>A-CPN (proposed)</a:t>
+                        <a:t>B-ACPN (proposed)</a:t>
                       </a:r>
                     </a:p>
                   </a:txBody>
@@ -14171,7 +14157,7 @@
                           </a:solidFill>
                           <a:latin typeface="Calibri"/>
                         </a:rPr>
-                        <a:t>798</a:t>
+                        <a:t>829</a:t>
                       </a:r>
                     </a:p>
                   </a:txBody>
@@ -14194,7 +14180,7 @@
                           </a:solidFill>
                           <a:latin typeface="Calibri"/>
                         </a:rPr>
-                        <a:t>845</a:t>
+                        <a:t>902</a:t>
                       </a:r>
                     </a:p>
                   </a:txBody>
@@ -14217,7 +14203,7 @@
                           </a:solidFill>
                           <a:latin typeface="Calibri"/>
                         </a:rPr>
-                        <a:t>315</a:t>
+                        <a:t>258</a:t>
                       </a:r>
                     </a:p>
                   </a:txBody>
@@ -14240,7 +14226,7 @@
                           </a:solidFill>
                           <a:latin typeface="Calibri"/>
                         </a:rPr>
-                        <a:t>387</a:t>
+                        <a:t>356</a:t>
                       </a:r>
                     </a:p>
                   </a:txBody>
@@ -14263,7 +14249,7 @@
                           </a:solidFill>
                           <a:latin typeface="Calibri"/>
                         </a:rPr>
-                        <a:t>0.711 – 0.810</a:t>
+                        <a:t>0.780 – 0.859</a:t>
                       </a:r>
                     </a:p>
                   </a:txBody>
@@ -14449,7 +14435,7 @@
                           </a:solidFill>
                           <a:latin typeface="Calibri"/>
                         </a:rPr>
-                        <a:t>0.602</a:t>
+                        <a:t>0.004</a:t>
                       </a:r>
                     </a:p>
                   </a:txBody>
@@ -14612,7 +14598,7 @@
                           </a:solidFill>
                           <a:latin typeface="Calibri"/>
                         </a:rPr>
-                        <a:t>0.047</a:t>
+                        <a:t>0.042</a:t>
                       </a:r>
                     </a:p>
                   </a:txBody>
@@ -14775,7 +14761,7 @@
                           </a:solidFill>
                           <a:latin typeface="Calibri"/>
                         </a:rPr>
-                        <a:t>0.071</a:t>
+                        <a:t>0.550</a:t>
                       </a:r>
                     </a:p>
                   </a:txBody>
@@ -14938,7 +14924,7 @@
                           </a:solidFill>
                           <a:latin typeface="Calibri"/>
                         </a:rPr>
-                        <a:t>0.835</a:t>
+                        <a:t>0.006</a:t>
                       </a:r>
                     </a:p>
                   </a:txBody>
@@ -15101,7 +15087,7 @@
                           </a:solidFill>
                           <a:latin typeface="Calibri"/>
                         </a:rPr>
-                        <a:t>0.311</a:t>
+                        <a:t>0.019</a:t>
                       </a:r>
                     </a:p>
                   </a:txBody>
@@ -15449,7 +15435,7 @@
                           </a:solidFill>
                           <a:latin typeface="Calibri"/>
                         </a:rPr>
-                        <a:t>Full A-CPN</a:t>
+                        <a:t>Full B-ACPN</a:t>
                       </a:r>
                     </a:p>
                   </a:txBody>
@@ -15472,7 +15458,7 @@
                           </a:solidFill>
                           <a:latin typeface="Calibri"/>
                         </a:rPr>
-                        <a:t>0.760</a:t>
+                        <a:t>0.820</a:t>
                       </a:r>
                     </a:p>
                   </a:txBody>
@@ -15543,7 +15529,7 @@
                           </a:solidFill>
                           <a:latin typeface="Calibri"/>
                         </a:rPr>
-                        <a:t>Without feature attention</a:t>
+                        <a:t>Deep stage only (no tree stage)</a:t>
                       </a:r>
                     </a:p>
                   </a:txBody>
@@ -15566,7 +15552,7 @@
                           </a:solidFill>
                           <a:latin typeface="Calibri"/>
                         </a:rPr>
-                        <a:t>0.774</a:t>
+                        <a:t>0.800</a:t>
                       </a:r>
                     </a:p>
                   </a:txBody>
@@ -15589,7 +15575,7 @@
                           </a:solidFill>
                           <a:latin typeface="Calibri"/>
                         </a:rPr>
-                        <a:t>+0.013</a:t>
+                        <a:t>-0.019</a:t>
                       </a:r>
                     </a:p>
                   </a:txBody>
@@ -15612,7 +15598,7 @@
                           </a:solidFill>
                           <a:latin typeface="Calibri"/>
                         </a:rPr>
-                        <a:t>0.698</a:t>
+                        <a:t>0.497</a:t>
                       </a:r>
                     </a:p>
                   </a:txBody>
@@ -15637,7 +15623,7 @@
                           </a:solidFill>
                           <a:latin typeface="Calibri"/>
                         </a:rPr>
-                        <a:t>Without KAN layer (plain MLP)</a:t>
+                        <a:t>Tree stage only (no deep stage)</a:t>
                       </a:r>
                     </a:p>
                   </a:txBody>
@@ -15660,7 +15646,7 @@
                           </a:solidFill>
                           <a:latin typeface="Calibri"/>
                         </a:rPr>
-                        <a:t>0.784</a:t>
+                        <a:t>0.818</a:t>
                       </a:r>
                     </a:p>
                   </a:txBody>
@@ -15683,7 +15669,7 @@
                           </a:solidFill>
                           <a:latin typeface="Calibri"/>
                         </a:rPr>
-                        <a:t>+0.023</a:t>
+                        <a:t>-0.002</a:t>
                       </a:r>
                     </a:p>
                   </a:txBody>
@@ -15706,7 +15692,7 @@
                           </a:solidFill>
                           <a:latin typeface="Calibri"/>
                         </a:rPr>
-                        <a:t>0.529</a:t>
+                        <a:t>0.952</a:t>
                       </a:r>
                     </a:p>
                   </a:txBody>
@@ -15731,7 +15717,7 @@
                           </a:solidFill>
                           <a:latin typeface="Calibri"/>
                         </a:rPr>
-                        <a:t>Without residual block</a:t>
+                        <a:t>Without climate push</a:t>
                       </a:r>
                     </a:p>
                   </a:txBody>
@@ -15754,7 +15740,7 @@
                           </a:solidFill>
                           <a:latin typeface="Calibri"/>
                         </a:rPr>
-                        <a:t>0.756</a:t>
+                        <a:t>0.816</a:t>
                       </a:r>
                     </a:p>
                   </a:txBody>
@@ -15777,7 +15763,7 @@
                           </a:solidFill>
                           <a:latin typeface="Calibri"/>
                         </a:rPr>
-                        <a:t>-0.005</a:t>
+                        <a:t>-0.004</a:t>
                       </a:r>
                     </a:p>
                   </a:txBody>
@@ -15800,7 +15786,7 @@
                           </a:solidFill>
                           <a:latin typeface="Calibri"/>
                         </a:rPr>
-                        <a:t>0.902</a:t>
+                        <a:t>0.882</a:t>
                       </a:r>
                     </a:p>
                   </a:txBody>
@@ -15825,7 +15811,7 @@
                           </a:solidFill>
                           <a:latin typeface="Calibri"/>
                         </a:rPr>
-                        <a:t>Climate only (no development baseline)</a:t>
+                        <a:t>Without development gate</a:t>
                       </a:r>
                     </a:p>
                   </a:txBody>
@@ -15848,7 +15834,7 @@
                           </a:solidFill>
                           <a:latin typeface="Calibri"/>
                         </a:rPr>
-                        <a:t>0.757</a:t>
+                        <a:t>0.821</a:t>
                       </a:r>
                     </a:p>
                   </a:txBody>
@@ -15871,7 +15857,7 @@
                           </a:solidFill>
                           <a:latin typeface="Calibri"/>
                         </a:rPr>
-                        <a:t>-0.004</a:t>
+                        <a:t>+0.001</a:t>
                       </a:r>
                     </a:p>
                   </a:txBody>
@@ -15894,7 +15880,7 @@
                           </a:solidFill>
                           <a:latin typeface="Calibri"/>
                         </a:rPr>
-                        <a:t>0.910</a:t>
+                        <a:t>0.959</a:t>
                       </a:r>
                     </a:p>
                   </a:txBody>
@@ -15919,7 +15905,7 @@
                           </a:solidFill>
                           <a:latin typeface="Calibri"/>
                         </a:rPr>
-                        <a:t>Development only (no climate push)</a:t>
+                        <a:t>Without feature attention</a:t>
                       </a:r>
                     </a:p>
                   </a:txBody>
@@ -15942,7 +15928,7 @@
                           </a:solidFill>
                           <a:latin typeface="Calibri"/>
                         </a:rPr>
-                        <a:t>0.670</a:t>
+                        <a:t>0.817</a:t>
                       </a:r>
                     </a:p>
                   </a:txBody>
@@ -15965,7 +15951,7 @@
                           </a:solidFill>
                           <a:latin typeface="Calibri"/>
                         </a:rPr>
-                        <a:t>-0.090</a:t>
+                        <a:t>-0.003</a:t>
                       </a:r>
                     </a:p>
                   </a:txBody>
@@ -15988,7 +15974,7 @@
                           </a:solidFill>
                           <a:latin typeface="Calibri"/>
                         </a:rPr>
-                        <a:t>0.068</a:t>
+                        <a:t>0.926</a:t>
                       </a:r>
                     </a:p>
                   </a:txBody>
@@ -16013,7 +15999,7 @@
                           </a:solidFill>
                           <a:latin typeface="Calibri"/>
                         </a:rPr>
-                        <a:t>Linear climate part (no deep layers)</a:t>
+                        <a:t>Single network (no ensemble)</a:t>
                       </a:r>
                     </a:p>
                   </a:txBody>
@@ -16036,7 +16022,7 @@
                           </a:solidFill>
                           <a:latin typeface="Calibri"/>
                         </a:rPr>
-                        <a:t>0.733</a:t>
+                        <a:t>0.801</a:t>
                       </a:r>
                     </a:p>
                   </a:txBody>
@@ -16059,7 +16045,7 @@
                           </a:solidFill>
                           <a:latin typeface="Calibri"/>
                         </a:rPr>
-                        <a:t>-0.028</a:t>
+                        <a:t>-0.018</a:t>
                       </a:r>
                     </a:p>
                   </a:txBody>
@@ -16082,7 +16068,7 @@
                           </a:solidFill>
                           <a:latin typeface="Calibri"/>
                         </a:rPr>
-                        <a:t>0.495</a:t>
+                        <a:t>0.579</a:t>
                       </a:r>
                     </a:p>
                   </a:txBody>
@@ -16149,7 +16135,7 @@
                 </a:solidFill>
                 <a:latin typeface="Calibri"/>
               </a:rPr>
-              <a:t>Development only (no climate push)</a:t>
+              <a:t>no single component</a:t>
             </a:r>
           </a:p>
           <a:p>
@@ -16183,7 +16169,7 @@
                 </a:solidFill>
                 <a:latin typeface="Calibri"/>
               </a:rPr>
-              <a:t>Without feature attention, Without KAN layer (plain MLP), Without residual block, Climate only (no development baseline), Linear climate part (no deep layers)</a:t>
+              <a:t>Deep stage only (no tree stage), Tree stage only (no deep stage), Without climate push, Without development gate, Without feature attention, Single network (no ensemble)</a:t>
             </a:r>
           </a:p>
         </p:txBody>
@@ -16500,7 +16486,7 @@
                           </a:solidFill>
                           <a:latin typeface="Calibri"/>
                         </a:rPr>
-                        <a:t>-0.53</a:t>
+                        <a:t>-0.10</a:t>
                       </a:r>
                     </a:p>
                   </a:txBody>
@@ -16523,7 +16509,7 @@
                           </a:solidFill>
                           <a:latin typeface="Calibri"/>
                         </a:rPr>
-                        <a:t>27%</a:t>
+                        <a:t>45%</a:t>
                       </a:r>
                     </a:p>
                   </a:txBody>
@@ -16546,7 +16532,7 @@
                           </a:solidFill>
                           <a:latin typeface="Calibri"/>
                         </a:rPr>
-                        <a:t>max dry spell</a:t>
+                        <a:t>heavy rain days</a:t>
                       </a:r>
                     </a:p>
                   </a:txBody>
@@ -16617,7 +16603,7 @@
                           </a:solidFill>
                           <a:latin typeface="Calibri"/>
                         </a:rPr>
-                        <a:t>+0.81</a:t>
+                        <a:t>+0.13</a:t>
                       </a:r>
                     </a:p>
                   </a:txBody>
@@ -16640,7 +16626,7 @@
                           </a:solidFill>
                           <a:latin typeface="Calibri"/>
                         </a:rPr>
-                        <a:t>72%</a:t>
+                        <a:t>86%</a:t>
                       </a:r>
                     </a:p>
                   </a:txBody>
@@ -16663,7 +16649,7 @@
                           </a:solidFill>
                           <a:latin typeface="Calibri"/>
                         </a:rPr>
-                        <a:t>hot days</a:t>
+                        <a:t>heavy rain days</a:t>
                       </a:r>
                     </a:p>
                   </a:txBody>
@@ -16734,7 +16720,7 @@
                           </a:solidFill>
                           <a:latin typeface="Calibri"/>
                         </a:rPr>
-                        <a:t>+0.32</a:t>
+                        <a:t>+0.09</a:t>
                       </a:r>
                     </a:p>
                   </a:txBody>
@@ -16757,7 +16743,7 @@
                           </a:solidFill>
                           <a:latin typeface="Calibri"/>
                         </a:rPr>
-                        <a:t>54%</a:t>
+                        <a:t>82%</a:t>
                       </a:r>
                     </a:p>
                   </a:txBody>
@@ -16780,7 +16766,7 @@
                           </a:solidFill>
                           <a:latin typeface="Calibri"/>
                         </a:rPr>
-                        <a:t>max dry spell</a:t>
+                        <a:t>heavy rain days</a:t>
                       </a:r>
                     </a:p>
                   </a:txBody>
@@ -16851,7 +16837,7 @@
                           </a:solidFill>
                           <a:latin typeface="Calibri"/>
                         </a:rPr>
-                        <a:t>-0.99</a:t>
+                        <a:t>-0.17</a:t>
                       </a:r>
                     </a:p>
                   </a:txBody>
@@ -16874,7 +16860,7 @@
                           </a:solidFill>
                           <a:latin typeface="Calibri"/>
                         </a:rPr>
-                        <a:t>19%</a:t>
+                        <a:t>46%</a:t>
                       </a:r>
                     </a:p>
                   </a:txBody>
@@ -16897,7 +16883,7 @@
                           </a:solidFill>
                           <a:latin typeface="Calibri"/>
                         </a:rPr>
-                        <a:t>annual rain mm</a:t>
+                        <a:t>heavy rain days</a:t>
                       </a:r>
                     </a:p>
                   </a:txBody>
@@ -16968,7 +16954,7 @@
                           </a:solidFill>
                           <a:latin typeface="Calibri"/>
                         </a:rPr>
-                        <a:t>-0.99</a:t>
+                        <a:t>-0.24</a:t>
                       </a:r>
                     </a:p>
                   </a:txBody>
@@ -17014,7 +17000,7 @@
                           </a:solidFill>
                           <a:latin typeface="Calibri"/>
                         </a:rPr>
-                        <a:t>max dry spell</a:t>
+                        <a:t>rain variability</a:t>
                       </a:r>
                     </a:p>
                   </a:txBody>
@@ -17085,7 +17071,7 @@
                           </a:solidFill>
                           <a:latin typeface="Calibri"/>
                         </a:rPr>
-                        <a:t>+0.20</a:t>
+                        <a:t>+0.05</a:t>
                       </a:r>
                     </a:p>
                   </a:txBody>
@@ -17131,7 +17117,7 @@
                           </a:solidFill>
                           <a:latin typeface="Calibri"/>
                         </a:rPr>
-                        <a:t>annual rain mm</a:t>
+                        <a:t>heavy rain days</a:t>
                       </a:r>
                     </a:p>
                   </a:txBody>
@@ -17176,7 +17162,7 @@
                 </a:solidFill>
                 <a:latin typeface="Calibri"/>
               </a:rPr>
-              <a:t>Anomaly A vs expected developed: p = 6.31e-07;  Anomaly B vs expected less-developed: p = 2.46e-18;  mean MC Dropout SD of push = 0.54</a:t>
+              <a:t>Anomaly A vs expected developed: p = 1.56e-05;  Anomaly B vs expected less-developed: p = 4.45e-07;  mean MC Dropout SD of push = 0.54</a:t>
             </a:r>
           </a:p>
         </p:txBody>
@@ -17294,7 +17280,7 @@
                 </a:solidFill>
                 <a:latin typeface="Calibri"/>
               </a:rPr>
-              <a:t>Khagaria (Bihar) +3.34</a:t>
+              <a:t>Kishanganj (Bihar) +0.98</a:t>
             </a:r>
           </a:p>
           <a:p>
@@ -17319,7 +17305,7 @@
                 </a:solidFill>
                 <a:latin typeface="Calibri"/>
               </a:rPr>
-              <a:t>Madhepura (Bihar) +3.30</a:t>
+              <a:t>Kodagu (Karnataka) +0.68</a:t>
             </a:r>
           </a:p>
           <a:p>
@@ -17344,7 +17330,7 @@
                 </a:solidFill>
                 <a:latin typeface="Calibri"/>
               </a:rPr>
-              <a:t>Maldah (West Bengal) +3.18</a:t>
+              <a:t>Sahebganj (Jharkhand) +0.67</a:t>
             </a:r>
           </a:p>
           <a:p>
@@ -17369,7 +17355,7 @@
                 </a:solidFill>
                 <a:latin typeface="Calibri"/>
               </a:rPr>
-              <a:t>Sahebganj (Jharkhand) +3.12</a:t>
+              <a:t>Medinipur East (West Bengal) +0.65</a:t>
             </a:r>
           </a:p>
           <a:p>
@@ -17394,7 +17380,7 @@
                 </a:solidFill>
                 <a:latin typeface="Calibri"/>
               </a:rPr>
-              <a:t>Saharsa (Bihar) +3.07</a:t>
+              <a:t>Purnia (Bihar) +0.57</a:t>
             </a:r>
           </a:p>
         </p:txBody>
@@ -17442,7 +17428,7 @@
                 </a:solidFill>
                 <a:latin typeface="Calibri"/>
               </a:rPr>
-              <a:t>Mahoba (Uttar Pradesh) 2%</a:t>
+              <a:t>Ariyalur (Tamil Nadu) 0%</a:t>
             </a:r>
           </a:p>
           <a:p>
@@ -17467,7 +17453,7 @@
                 </a:solidFill>
                 <a:latin typeface="Calibri"/>
               </a:rPr>
-              <a:t>Kannur (Kerala) 2%</a:t>
+              <a:t>Davangere (Karnataka) 0%</a:t>
             </a:r>
           </a:p>
           <a:p>
@@ -17492,7 +17478,7 @@
                 </a:solidFill>
                 <a:latin typeface="Calibri"/>
               </a:rPr>
-              <a:t>Deogarh (Odisha) 4%</a:t>
+              <a:t>Ahmadabad (Gujarat) 1%</a:t>
             </a:r>
           </a:p>
           <a:p>
@@ -17517,7 +17503,7 @@
                 </a:solidFill>
                 <a:latin typeface="Calibri"/>
               </a:rPr>
-              <a:t>Kanpur Dehat (Uttar Pradesh) 4%</a:t>
+              <a:t>Thiruvallur (Tamil Nadu) 1%</a:t>
             </a:r>
           </a:p>
           <a:p>
@@ -17542,7 +17528,7 @@
                 </a:solidFill>
                 <a:latin typeface="Calibri"/>
               </a:rPr>
-              <a:t>Kandhamal (Odisha) 5%</a:t>
+              <a:t>Panchkula (Haryana) 1%</a:t>
             </a:r>
           </a:p>
         </p:txBody>
@@ -18021,7 +18007,7 @@
                 </a:solidFill>
                 <a:latin typeface="Calibri"/>
               </a:rPr>
-              <a:t>Proposed Model (A-CPN)</a:t>
+              <a:t>Proposed Model (B-ACPN)</a:t>
             </a:r>
           </a:p>
         </p:txBody>
@@ -19577,7 +19563,7 @@
                 </a:solidFill>
                 <a:latin typeface="Times New Roman"/>
               </a:rPr>
-              <a:t>A-CPN Training &amp; Attention (Figures)</a:t>
+              <a:t>B-ACPN Training &amp; Attention (Figures)</a:t>
             </a:r>
           </a:p>
         </p:txBody>
@@ -19622,8 +19608,8 @@
         </p:blipFill>
         <p:spPr>
           <a:xfrm>
-            <a:off x="365760" y="2081698"/>
-            <a:ext cx="4114800" cy="2877482"/>
+            <a:off x="365760" y="2127166"/>
+            <a:ext cx="4114800" cy="2786546"/>
           </a:xfrm>
           <a:prstGeom prst="rect">
             <a:avLst/>
@@ -19646,8 +19632,8 @@
         </p:blipFill>
         <p:spPr>
           <a:xfrm>
-            <a:off x="4663440" y="2336758"/>
-            <a:ext cx="4114800" cy="2367362"/>
+            <a:off x="4663440" y="2359070"/>
+            <a:ext cx="4114800" cy="2322739"/>
           </a:xfrm>
           <a:prstGeom prst="rect">
             <a:avLst/>
@@ -19684,7 +19670,7 @@
                 </a:solidFill>
                 <a:latin typeface="Calibri"/>
               </a:rPr>
-              <a:t>A-CPN training curve (early stopping)</a:t>
+              <a:t>B-ACPN deep stage: training curve (early stopping)</a:t>
             </a:r>
           </a:p>
         </p:txBody>
@@ -19850,8 +19836,8 @@
         </p:blipFill>
         <p:spPr>
           <a:xfrm>
-            <a:off x="365760" y="1778292"/>
-            <a:ext cx="8412480" cy="3484294"/>
+            <a:off x="365760" y="1666490"/>
+            <a:ext cx="8412480" cy="3707898"/>
           </a:xfrm>
           <a:prstGeom prst="rect">
             <a:avLst/>
@@ -19888,7 +19874,7 @@
                 </a:solidFill>
                 <a:latin typeface="Calibri"/>
               </a:rPr>
-              <a:t>Ablation: one A-CPN component removed at a time</a:t>
+              <a:t>Ablation: one B-ACPN component removed at a time</a:t>
             </a:r>
           </a:p>
         </p:txBody>
@@ -20043,8 +20029,8 @@
         </p:blipFill>
         <p:spPr>
           <a:xfrm>
-            <a:off x="4663440" y="1681213"/>
-            <a:ext cx="4114800" cy="3678452"/>
+            <a:off x="4663440" y="1724224"/>
+            <a:ext cx="4114800" cy="3592431"/>
           </a:xfrm>
           <a:prstGeom prst="rect">
             <a:avLst/>
@@ -21354,7 +21340,7 @@
                 </a:solidFill>
                 <a:latin typeface="Calibri"/>
               </a:rPr>
-              <a:t>A-CPN (Attentive Climate Push Network)</a:t>
+              <a:t>B-ACPN (Boosted Attentive Climate Push Network)</a:t>
             </a:r>
           </a:p>
           <a:p>
@@ -22389,7 +22375,7 @@
                           </a:solidFill>
                           <a:latin typeface="Calibri"/>
                         </a:rPr>
-                        <a:t>Design and train A-CPN (attention, KAN layer, residual MLP, development baseline); MC Dropout and conformal uncertainty; model card (Table 4); ablation; climate-push analysis (Table 6)</a:t>
+                        <a:t>Design and train B-ACPN (random-forest tree stage, attention, residual MLP, development gate, 5-network ensemble); MC Dropout and conformal uncertainty; model card (Table 4); ablation; climate-push analysis (Table 6)</a:t>
                       </a:r>
                     </a:p>
                   </a:txBody>
@@ -22412,7 +22398,7 @@
                           </a:solidFill>
                           <a:latin typeface="Calibri"/>
                         </a:rPr>
-                        <a:t>In progress (A-CPN tuning)</a:t>
+                        <a:t>In progress (B-ACPN tuning)</a:t>
                       </a:r>
                     </a:p>
                   </a:txBody>
@@ -22483,7 +22469,7 @@
                           </a:solidFill>
                           <a:latin typeface="Calibri"/>
                         </a:rPr>
-                        <a:t>Compare A-CPN with Logistic Regression, Random Forest, GBT, Linear SVM (Spark MLlib) and MLP on the same folds; all metrics, confidence intervals, significance; effect of preprocessing on the models (Table 5); result figures; slides</a:t>
+                        <a:t>Compare B-ACPN with Logistic Regression, Random Forest, GBT, Linear SVM (Spark MLlib) and MLP on the same folds; all metrics, confidence intervals, significance; effect of preprocessing on the models (Table 5); result figures; slides</a:t>
                       </a:r>
                     </a:p>
                   </a:txBody>
@@ -22551,7 +22537,7 @@
                 </a:solidFill>
                 <a:latin typeface="Calibri"/>
               </a:rPr>
-              <a:t>Next (Review 3): full 1901–2024 rainfall in HDFS and re-timing; A-CPN tuning; comparison with CEEW / DST district rankings; final report.</a:t>
+              <a:t>Next (Review 3): full 1901–2024 rainfall in HDFS and re-timing; B-ACPN tuning; comparison with CEEW / DST district rankings; final report.</a:t>
             </a:r>
           </a:p>
         </p:txBody>
@@ -22884,7 +22870,7 @@
                 </a:solidFill>
                 <a:latin typeface="Calibri"/>
               </a:rPr>
-              <a:t>Z. Liu et al., KAN: Kolmogorov–Arnold Networks, arXiv:2404.19756, 2024.</a:t>
+              <a:t>L. Breiman, Random Forests, Machine Learning 45, 2001.</a:t>
             </a:r>
           </a:p>
           <a:p>
@@ -22909,7 +22895,7 @@
                 </a:solidFill>
                 <a:latin typeface="Calibri"/>
               </a:rPr>
-              <a:t>K. He et al., Deep Residual Learning for Image Recognition, CVPR 2016.</a:t>
+              <a:t>D. H. Wolpert, Stacked Generalization, Neural Networks 5, 1992.</a:t>
             </a:r>
           </a:p>
           <a:p>
@@ -22934,7 +22920,7 @@
                 </a:solidFill>
                 <a:latin typeface="Calibri"/>
               </a:rPr>
-              <a:t>Y. Gal and Z. Ghahramani, Dropout as a Bayesian Approximation, ICML 2016.</a:t>
+              <a:t>K. He et al., Deep Residual Learning for Image Recognition, CVPR 2016.</a:t>
             </a:r>
           </a:p>
           <a:p>
@@ -22959,7 +22945,7 @@
                 </a:solidFill>
                 <a:latin typeface="Calibri"/>
               </a:rPr>
-              <a:t>A. N. Angelopoulos and S. Bates, A Gentle Introduction to Conformal Prediction, arXiv:2107.07511, 2021.</a:t>
+              <a:t>Y. Gal and Z. Ghahramani, Dropout as a Bayesian Approximation, ICML 2016.</a:t>
             </a:r>
           </a:p>
           <a:p>
@@ -22984,7 +22970,7 @@
                 </a:solidFill>
                 <a:latin typeface="Calibri"/>
               </a:rPr>
-              <a:t>K. Shvachko et al., The Hadoop Distributed File System, MSST 2010.</a:t>
+              <a:t>A. N. Angelopoulos and S. Bates, A Gentle Introduction to Conformal Prediction, arXiv:2107.07511, 2021.</a:t>
             </a:r>
           </a:p>
           <a:p>
@@ -23009,7 +22995,7 @@
                 </a:solidFill>
                 <a:latin typeface="Calibri"/>
               </a:rPr>
-              <a:t>J. Dean and S. Ghemawat, MapReduce, Communications of the ACM, 2008.</a:t>
+              <a:t>K. Shvachko et al., The Hadoop Distributed File System, MSST 2010.</a:t>
             </a:r>
           </a:p>
           <a:p>
@@ -23034,7 +23020,7 @@
                 </a:solidFill>
                 <a:latin typeface="Calibri"/>
               </a:rPr>
-              <a:t>A. Thusoo et al., Hive, VLDB 2009.</a:t>
+              <a:t>J. Dean and S. Ghemawat, MapReduce, Communications of the ACM, 2008.</a:t>
             </a:r>
           </a:p>
           <a:p>
@@ -23059,7 +23045,7 @@
                 </a:solidFill>
                 <a:latin typeface="Calibri"/>
               </a:rPr>
-              <a:t>M. Zaharia et al., Apache Spark: A Unified Engine for Big Data Processing, CACM 59(11), 2016.</a:t>
+              <a:t>A. Thusoo et al., Hive, VLDB 2009.</a:t>
             </a:r>
           </a:p>
           <a:p>
@@ -23084,7 +23070,7 @@
                 </a:solidFill>
                 <a:latin typeface="Calibri"/>
               </a:rPr>
-              <a:t>X. Meng et al., MLlib: Machine Learning in Apache Spark, JMLR 17, 2016.</a:t>
+              <a:t>M. Zaharia et al., Apache Spark: A Unified Engine for Big Data Processing, CACM 59(11), 2016.</a:t>
             </a:r>
           </a:p>
           <a:p>
@@ -23101,6 +23087,31 @@
                 <a:latin typeface="Calibri"/>
               </a:rPr>
               <a:t>[17]  </a:t>
+            </a:r>
+            <a:r>
+              <a:rPr sz="1300" b="0" i="0">
+                <a:solidFill>
+                  <a:srgbClr val="1F1F1F"/>
+                </a:solidFill>
+                <a:latin typeface="Calibri"/>
+              </a:rPr>
+              <a:t>X. Meng et al., MLlib: Machine Learning in Apache Spark, JMLR 17, 2016.</a:t>
+            </a:r>
+          </a:p>
+          <a:p>
+            <a:pPr>
+              <a:spcAft>
+                <a:spcPts val="400"/>
+              </a:spcAft>
+            </a:pPr>
+            <a:r>
+              <a:rPr sz="1300" b="1" i="0">
+                <a:solidFill>
+                  <a:srgbClr val="1B3A6B"/>
+                </a:solidFill>
+                <a:latin typeface="Calibri"/>
+              </a:rPr>
+              <a:t>[18]  </a:t>
             </a:r>
             <a:r>
               <a:rPr sz="1300" b="0" i="0">
@@ -23813,7 +23824,7 @@
                           </a:solidFill>
                           <a:latin typeface="Calibri"/>
                         </a:rPr>
-                        <a:t>8–10 A-CPN + comparison</a:t>
+                        <a:t>8–10 B-ACPN + comparison</a:t>
                       </a:r>
                     </a:p>
                   </a:txBody>
@@ -25202,7 +25213,7 @@
                 </a:solidFill>
                 <a:latin typeface="Times New Roman"/>
               </a:rPr>
-              <a:t>Proposed Model: A-CPN</a:t>
+              <a:t>Proposed Model: B-ACPN</a:t>
             </a:r>
           </a:p>
         </p:txBody>
@@ -25274,7 +25285,7 @@
                 </a:solidFill>
                 <a:latin typeface="Calibri"/>
               </a:rPr>
-              <a:t>Attentive Climate Push Network: </a:t>
+              <a:t>Tree stage: </a:t>
             </a:r>
             <a:r>
               <a:rPr sz="1500" b="0" i="0">
@@ -25283,7 +25294,7 @@
                 </a:solidFill>
                 <a:latin typeface="Calibri"/>
               </a:rPr>
-              <a:t>a novel deep-learning model combining recent techniques</a:t>
+              <a:t>random forest (500 trees) on all 13 features → risk score, out-of-fold for training rows</a:t>
             </a:r>
           </a:p>
           <a:p>
@@ -25308,7 +25319,7 @@
                 </a:solidFill>
                 <a:latin typeface="Calibri"/>
               </a:rPr>
-              <a:t>Development baseline: </a:t>
+              <a:t>Deep stage: </a:t>
             </a:r>
             <a:r>
               <a:rPr sz="1500" b="0" i="0">
@@ -25317,7 +25328,7 @@
                 </a:solidFill>
                 <a:latin typeface="Calibri"/>
               </a:rPr>
-              <a:t>linear layer on the 5 development features (interpretable)</a:t>
+              <a:t>tree score + linear development term + climate push (attention → MLP → residual block)</a:t>
             </a:r>
           </a:p>
           <a:p>
@@ -25342,7 +25353,7 @@
                 </a:solidFill>
                 <a:latin typeface="Calibri"/>
               </a:rPr>
-              <a:t>Climate push: </a:t>
+              <a:t>Development gate: </a:t>
             </a:r>
             <a:r>
               <a:rPr sz="1500" b="0" i="0">
@@ -25351,7 +25362,7 @@
                 </a:solidFill>
                 <a:latin typeface="Calibri"/>
               </a:rPr>
-              <a:t>feature attention → KAN layer → residual MLP on the 8 IMD hazard features</a:t>
+              <a:t>climate push × 2σ(gate(development)): how strongly climate acts at that level</a:t>
             </a:r>
           </a:p>
           <a:p>
@@ -25385,7 +25396,7 @@
                 </a:solidFill>
                 <a:latin typeface="Calibri"/>
               </a:rPr>
-              <a:t>p = σ(baseline + climate push); push &gt; 0 means climate adds risk beyond development</a:t>
+              <a:t>ensemble of 5 networks; push &gt; 0 means climate adds risk beyond development</a:t>
             </a:r>
           </a:p>
           <a:p>
@@ -25476,7 +25487,7 @@
                 </a:solidFill>
                 <a:latin typeface="Calibri"/>
               </a:rPr>
-              <a:t>Development</a:t>
+              <a:t>All 13 features</a:t>
             </a:r>
           </a:p>
           <a:p>
@@ -25488,7 +25499,7 @@
                 </a:solidFill>
                 <a:latin typeface="Calibri"/>
               </a:rPr>
-              <a:t>5 features</a:t>
+              <a:t>dev + climate</a:t>
             </a:r>
           </a:p>
         </p:txBody>
@@ -25614,7 +25625,7 @@
                 </a:solidFill>
                 <a:latin typeface="Calibri"/>
               </a:rPr>
-              <a:t>Linear baseline</a:t>
+              <a:t>Random forest</a:t>
             </a:r>
           </a:p>
           <a:p>
@@ -25626,7 +25637,7 @@
                 </a:solidFill>
                 <a:latin typeface="Calibri"/>
               </a:rPr>
-              <a:t>interpretable</a:t>
+              <a:t>tree stage, 500 trees</a:t>
             </a:r>
           </a:p>
         </p:txBody>
@@ -25683,7 +25694,7 @@
                 </a:solidFill>
                 <a:latin typeface="Calibri"/>
               </a:rPr>
-              <a:t>Attention → KAN → Residual MLP</a:t>
+              <a:t>Attention → MLP → Residual × dev gate</a:t>
             </a:r>
           </a:p>
         </p:txBody>
@@ -25740,7 +25751,7 @@
                 </a:solidFill>
                 <a:latin typeface="Calibri"/>
               </a:rPr>
-              <a:t>Baseline</a:t>
+              <a:t>Tree + dev</a:t>
             </a:r>
           </a:p>
           <a:p>
@@ -25933,7 +25944,7 @@
                 </a:solidFill>
                 <a:latin typeface="Calibri"/>
               </a:rPr>
-              <a:t>σ(b + c)</a:t>
+              <a:t>σ(b + c) × 5</a:t>
             </a:r>
           </a:p>
           <a:p>
@@ -25945,7 +25956,7 @@
                 </a:solidFill>
                 <a:latin typeface="Calibri"/>
               </a:rPr>
-              <a:t>High / Low</a:t>
+              <a:t>ensemble mean</a:t>
             </a:r>
           </a:p>
         </p:txBody>
@@ -26359,7 +26370,7 @@
                 </a:solidFill>
                 <a:latin typeface="Calibri"/>
               </a:rPr>
-              <a:t>Novelty: recent techniques (attention, KAN, residual blocks, conformal prediction) combined into a development-anchored network for district climate vulnerability</a:t>
+              <a:t>Novelty: a tree stage boosted by a development-gated attentive climate network (with uncertainty) that separates each district's climate push from its tree/development baseline</a:t>
             </a:r>
           </a:p>
         </p:txBody>
@@ -27261,7 +27272,7 @@
                 </a:solidFill>
                 <a:latin typeface="Calibri"/>
               </a:rPr>
-              <a:t>A-CPN</a:t>
+              <a:t>B-ACPN</a:t>
             </a:r>
           </a:p>
           <a:p>
@@ -27273,7 +27284,7 @@
                 </a:solidFill>
                 <a:latin typeface="Calibri"/>
               </a:rPr>
-              <a:t>PyTorch</a:t>
+              <a:t>RF + PyTorch</a:t>
             </a:r>
           </a:p>
         </p:txBody>

</xml_diff>

<commit_message>
Replace A-CPN with B-ACPN everywhere; add accuracy, F1, RMSE and ROC-AUC before vs after preprocessing
</commit_message>
<xml_diff>
--- a/docs/Review2_Deck.pptx
+++ b/docs/Review2_Deck.pptx
@@ -1092,7 +1092,7 @@
           <a:lstStyle/>
           <a:p>
             <a:r>
-              <a:t>To measure what preprocessing buys, every model is trained twice on the same districts and folds: once on the raw features exactly as they come, and once on the preprocessed features. The gain column is the improvement. The neural models gain the most. Random Forest and GBT do not depend on scale, and Spark's Logistic Regression and Linear SVM standardise features internally, so those four do not change.</a:t>
+              <a:t>To measure what preprocessing buys, every model is trained twice on the same districts and folds: once on the raw features exactly as they come, and once on the preprocessed features. We compare accuracy, F1, RMSE and ROC-AUC before and after. The neural models gain the most. Random Forest and GBT do not depend on scale, and Spark's Logistic Regression and Linear SVM standardise features internally, so those four do not change.</a:t>
             </a:r>
           </a:p>
         </p:txBody>
@@ -2142,7 +2142,7 @@
           <a:lstStyle/>
           <a:p>
             <a:r>
-              <a:t>ROC-AUC of every model on raw versus preprocessed features, with the gain written above each pair. The neural models gain; tree models and Spark's internally standardised models do not change.</a:t>
+              <a:t>Accuracy, F1, ROC-AUC and RMSE of every model on raw versus preprocessed features, with the change written above each pair. The neural models change; tree models and Spark's internally standardised models do not.</a:t>
             </a:r>
           </a:p>
         </p:txBody>
@@ -10708,7 +10708,7 @@
         </p:nvGraphicFramePr>
         <p:xfrm>
           <a:off x="365760" y="1188720"/>
-          <a:ext cx="8412480" cy="3712464"/>
+          <a:ext cx="8412480" cy="3520440"/>
         </p:xfrm>
         <a:graphic>
           <a:graphicData uri="http://schemas.openxmlformats.org/drawingml/2006/table">
@@ -10717,15 +10717,17 @@
                 <a:tableStyleId>{5C22544A-7EE6-4342-B048-85BDC9FD1C3A}</a:tableStyleId>
               </a:tblPr>
               <a:tblGrid>
-                <a:gridCol w="2103120"/>
-                <a:gridCol w="1051560"/>
-                <a:gridCol w="1051560"/>
-                <a:gridCol w="1051560"/>
-                <a:gridCol w="1051560"/>
-                <a:gridCol w="1051560"/>
-                <a:gridCol w="1051560"/>
+                <a:gridCol w="1097280"/>
+                <a:gridCol w="914400"/>
+                <a:gridCol w="914400"/>
+                <a:gridCol w="914400"/>
+                <a:gridCol w="914400"/>
+                <a:gridCol w="914400"/>
+                <a:gridCol w="914400"/>
+                <a:gridCol w="914400"/>
+                <a:gridCol w="914400"/>
               </a:tblGrid>
-              <a:tr h="530352">
+              <a:tr h="502920">
                 <a:tc>
                   <a:txBody>
                     <a:bodyPr wrap="square"/>
@@ -10733,7 +10735,7 @@
                     <a:p>
                       <a:pPr algn="l"/>
                       <a:r>
-                        <a:rPr sz="1200" b="1" i="0">
+                        <a:rPr sz="1100" b="1" i="0">
                           <a:solidFill>
                             <a:srgbClr val="FFFFFF"/>
                           </a:solidFill>
@@ -10756,13 +10758,13 @@
                     <a:p>
                       <a:pPr algn="ctr"/>
                       <a:r>
-                        <a:rPr sz="1200" b="1" i="0">
+                        <a:rPr sz="1100" b="1" i="0">
                           <a:solidFill>
                             <a:srgbClr val="FFFFFF"/>
                           </a:solidFill>
                           <a:latin typeface="Calibri"/>
                         </a:rPr>
-                        <a:t>AUC before</a:t>
+                        <a:t>Accuracy before</a:t>
                       </a:r>
                     </a:p>
                   </a:txBody>
@@ -10779,13 +10781,13 @@
                     <a:p>
                       <a:pPr algn="ctr"/>
                       <a:r>
-                        <a:rPr sz="1200" b="1" i="0">
+                        <a:rPr sz="1100" b="1" i="0">
                           <a:solidFill>
                             <a:srgbClr val="FFFFFF"/>
                           </a:solidFill>
                           <a:latin typeface="Calibri"/>
                         </a:rPr>
-                        <a:t>AUC after</a:t>
+                        <a:t>Accuracy after</a:t>
                       </a:r>
                     </a:p>
                   </a:txBody>
@@ -10802,13 +10804,13 @@
                     <a:p>
                       <a:pPr algn="ctr"/>
                       <a:r>
-                        <a:rPr sz="1200" b="1" i="0">
+                        <a:rPr sz="1100" b="1" i="0">
                           <a:solidFill>
                             <a:srgbClr val="FFFFFF"/>
                           </a:solidFill>
                           <a:latin typeface="Calibri"/>
                         </a:rPr>
-                        <a:t>AUC gain</a:t>
+                        <a:t>F1 score before</a:t>
                       </a:r>
                     </a:p>
                   </a:txBody>
@@ -10825,13 +10827,13 @@
                     <a:p>
                       <a:pPr algn="ctr"/>
                       <a:r>
-                        <a:rPr sz="1200" b="1" i="0">
+                        <a:rPr sz="1100" b="1" i="0">
                           <a:solidFill>
                             <a:srgbClr val="FFFFFF"/>
                           </a:solidFill>
                           <a:latin typeface="Calibri"/>
                         </a:rPr>
-                        <a:t>F1 before</a:t>
+                        <a:t>F1 score after</a:t>
                       </a:r>
                     </a:p>
                   </a:txBody>
@@ -10848,13 +10850,13 @@
                     <a:p>
                       <a:pPr algn="ctr"/>
                       <a:r>
-                        <a:rPr sz="1200" b="1" i="0">
+                        <a:rPr sz="1100" b="1" i="0">
                           <a:solidFill>
                             <a:srgbClr val="FFFFFF"/>
                           </a:solidFill>
                           <a:latin typeface="Calibri"/>
                         </a:rPr>
-                        <a:t>F1 after</a:t>
+                        <a:t>RMSE before</a:t>
                       </a:r>
                     </a:p>
                   </a:txBody>
@@ -10871,13 +10873,13 @@
                     <a:p>
                       <a:pPr algn="ctr"/>
                       <a:r>
-                        <a:rPr sz="1200" b="1" i="0">
+                        <a:rPr sz="1100" b="1" i="0">
                           <a:solidFill>
                             <a:srgbClr val="FFFFFF"/>
                           </a:solidFill>
                           <a:latin typeface="Calibri"/>
                         </a:rPr>
-                        <a:t>F1 gain</a:t>
+                        <a:t>RMSE after</a:t>
                       </a:r>
                     </a:p>
                   </a:txBody>
@@ -10887,8 +10889,54 @@
                     </a:solidFill>
                   </a:tcPr>
                 </a:tc>
+                <a:tc>
+                  <a:txBody>
+                    <a:bodyPr wrap="square"/>
+                    <a:lstStyle/>
+                    <a:p>
+                      <a:pPr algn="ctr"/>
+                      <a:r>
+                        <a:rPr sz="1100" b="1" i="0">
+                          <a:solidFill>
+                            <a:srgbClr val="FFFFFF"/>
+                          </a:solidFill>
+                          <a:latin typeface="Calibri"/>
+                        </a:rPr>
+                        <a:t>ROC-AUC before</a:t>
+                      </a:r>
+                    </a:p>
+                  </a:txBody>
+                  <a:tcPr marL="54864" marR="54864" marT="27432" marB="27432" anchor="ctr">
+                    <a:solidFill>
+                      <a:srgbClr val="1B3A6B"/>
+                    </a:solidFill>
+                  </a:tcPr>
+                </a:tc>
+                <a:tc>
+                  <a:txBody>
+                    <a:bodyPr wrap="square"/>
+                    <a:lstStyle/>
+                    <a:p>
+                      <a:pPr algn="ctr"/>
+                      <a:r>
+                        <a:rPr sz="1100" b="1" i="0">
+                          <a:solidFill>
+                            <a:srgbClr val="FFFFFF"/>
+                          </a:solidFill>
+                          <a:latin typeface="Calibri"/>
+                        </a:rPr>
+                        <a:t>ROC-AUC after</a:t>
+                      </a:r>
+                    </a:p>
+                  </a:txBody>
+                  <a:tcPr marL="54864" marR="54864" marT="27432" marB="27432" anchor="ctr">
+                    <a:solidFill>
+                      <a:srgbClr val="1B3A6B"/>
+                    </a:solidFill>
+                  </a:tcPr>
+                </a:tc>
               </a:tr>
-              <a:tr h="530352">
+              <a:tr h="502920">
                 <a:tc>
                   <a:txBody>
                     <a:bodyPr wrap="square"/>
@@ -10896,13 +10944,13 @@
                     <a:p>
                       <a:pPr algn="l"/>
                       <a:r>
-                        <a:rPr sz="1200" b="1" i="0">
-                          <a:solidFill>
-                            <a:srgbClr val="1F1F1F"/>
-                          </a:solidFill>
-                          <a:latin typeface="Calibri"/>
-                        </a:rPr>
-                        <a:t>B-ACPN (proposed)</a:t>
+                        <a:rPr sz="1100" b="1" i="0">
+                          <a:solidFill>
+                            <a:srgbClr val="1F1F1F"/>
+                          </a:solidFill>
+                          <a:latin typeface="Calibri"/>
+                        </a:rPr>
+                        <a:t>B-ACPN</a:t>
                       </a:r>
                     </a:p>
                   </a:txBody>
@@ -10919,7 +10967,145 @@
                     <a:p>
                       <a:pPr algn="ctr"/>
                       <a:r>
-                        <a:rPr sz="1200" b="1" i="0">
+                        <a:rPr sz="1100" b="1" i="0">
+                          <a:solidFill>
+                            <a:srgbClr val="1F1F1F"/>
+                          </a:solidFill>
+                          <a:latin typeface="Calibri"/>
+                        </a:rPr>
+                        <a:t>0.735</a:t>
+                      </a:r>
+                    </a:p>
+                  </a:txBody>
+                  <a:tcPr marL="54864" marR="54864" marT="27432" marB="27432" anchor="ctr">
+                    <a:solidFill>
+                      <a:srgbClr val="FFF4CC"/>
+                    </a:solidFill>
+                  </a:tcPr>
+                </a:tc>
+                <a:tc>
+                  <a:txBody>
+                    <a:bodyPr wrap="square"/>
+                    <a:lstStyle/>
+                    <a:p>
+                      <a:pPr algn="ctr"/>
+                      <a:r>
+                        <a:rPr sz="1100" b="1" i="0">
+                          <a:solidFill>
+                            <a:srgbClr val="1F1F1F"/>
+                          </a:solidFill>
+                          <a:latin typeface="Calibri"/>
+                        </a:rPr>
+                        <a:t>0.738</a:t>
+                      </a:r>
+                    </a:p>
+                  </a:txBody>
+                  <a:tcPr marL="54864" marR="54864" marT="27432" marB="27432" anchor="ctr">
+                    <a:solidFill>
+                      <a:srgbClr val="FFF4CC"/>
+                    </a:solidFill>
+                  </a:tcPr>
+                </a:tc>
+                <a:tc>
+                  <a:txBody>
+                    <a:bodyPr wrap="square"/>
+                    <a:lstStyle/>
+                    <a:p>
+                      <a:pPr algn="ctr"/>
+                      <a:r>
+                        <a:rPr sz="1100" b="1" i="0">
+                          <a:solidFill>
+                            <a:srgbClr val="1F1F1F"/>
+                          </a:solidFill>
+                          <a:latin typeface="Calibri"/>
+                        </a:rPr>
+                        <a:t>0.726</a:t>
+                      </a:r>
+                    </a:p>
+                  </a:txBody>
+                  <a:tcPr marL="54864" marR="54864" marT="27432" marB="27432" anchor="ctr">
+                    <a:solidFill>
+                      <a:srgbClr val="FFF4CC"/>
+                    </a:solidFill>
+                  </a:tcPr>
+                </a:tc>
+                <a:tc>
+                  <a:txBody>
+                    <a:bodyPr wrap="square"/>
+                    <a:lstStyle/>
+                    <a:p>
+                      <a:pPr algn="ctr"/>
+                      <a:r>
+                        <a:rPr sz="1100" b="1" i="0">
+                          <a:solidFill>
+                            <a:srgbClr val="1F1F1F"/>
+                          </a:solidFill>
+                          <a:latin typeface="Calibri"/>
+                        </a:rPr>
+                        <a:t>0.728</a:t>
+                      </a:r>
+                    </a:p>
+                  </a:txBody>
+                  <a:tcPr marL="54864" marR="54864" marT="27432" marB="27432" anchor="ctr">
+                    <a:solidFill>
+                      <a:srgbClr val="FFF4CC"/>
+                    </a:solidFill>
+                  </a:tcPr>
+                </a:tc>
+                <a:tc>
+                  <a:txBody>
+                    <a:bodyPr wrap="square"/>
+                    <a:lstStyle/>
+                    <a:p>
+                      <a:pPr algn="ctr"/>
+                      <a:r>
+                        <a:rPr sz="1100" b="1" i="0">
+                          <a:solidFill>
+                            <a:srgbClr val="1F1F1F"/>
+                          </a:solidFill>
+                          <a:latin typeface="Calibri"/>
+                        </a:rPr>
+                        <a:t>0.422</a:t>
+                      </a:r>
+                    </a:p>
+                  </a:txBody>
+                  <a:tcPr marL="54864" marR="54864" marT="27432" marB="27432" anchor="ctr">
+                    <a:solidFill>
+                      <a:srgbClr val="FFF4CC"/>
+                    </a:solidFill>
+                  </a:tcPr>
+                </a:tc>
+                <a:tc>
+                  <a:txBody>
+                    <a:bodyPr wrap="square"/>
+                    <a:lstStyle/>
+                    <a:p>
+                      <a:pPr algn="ctr"/>
+                      <a:r>
+                        <a:rPr sz="1100" b="1" i="0">
+                          <a:solidFill>
+                            <a:srgbClr val="1F1F1F"/>
+                          </a:solidFill>
+                          <a:latin typeface="Calibri"/>
+                        </a:rPr>
+                        <a:t>0.417</a:t>
+                      </a:r>
+                    </a:p>
+                  </a:txBody>
+                  <a:tcPr marL="54864" marR="54864" marT="27432" marB="27432" anchor="ctr">
+                    <a:solidFill>
+                      <a:srgbClr val="FFF4CC"/>
+                    </a:solidFill>
+                  </a:tcPr>
+                </a:tc>
+                <a:tc>
+                  <a:txBody>
+                    <a:bodyPr wrap="square"/>
+                    <a:lstStyle/>
+                    <a:p>
+                      <a:pPr algn="ctr"/>
+                      <a:r>
+                        <a:rPr sz="1100" b="1" i="0">
                           <a:solidFill>
                             <a:srgbClr val="1F1F1F"/>
                           </a:solidFill>
@@ -10942,7 +11128,7 @@
                     <a:p>
                       <a:pPr algn="ctr"/>
                       <a:r>
-                        <a:rPr sz="1200" b="1" i="0">
+                        <a:rPr sz="1100" b="1" i="0">
                           <a:solidFill>
                             <a:srgbClr val="1F1F1F"/>
                           </a:solidFill>
@@ -10958,37 +11144,457 @@
                     </a:solidFill>
                   </a:tcPr>
                 </a:tc>
-                <a:tc>
-                  <a:txBody>
-                    <a:bodyPr wrap="square"/>
-                    <a:lstStyle/>
-                    <a:p>
-                      <a:pPr algn="ctr"/>
-                      <a:r>
-                        <a:rPr sz="1200" b="1" i="0">
-                          <a:solidFill>
-                            <a:srgbClr val="1F1F1F"/>
-                          </a:solidFill>
-                          <a:latin typeface="Calibri"/>
-                        </a:rPr>
-                        <a:t>+0.013</a:t>
-                      </a:r>
-                    </a:p>
-                  </a:txBody>
-                  <a:tcPr marL="54864" marR="54864" marT="27432" marB="27432" anchor="ctr">
-                    <a:solidFill>
-                      <a:srgbClr val="FFF4CC"/>
-                    </a:solidFill>
-                  </a:tcPr>
-                </a:tc>
-                <a:tc>
-                  <a:txBody>
-                    <a:bodyPr wrap="square"/>
-                    <a:lstStyle/>
-                    <a:p>
-                      <a:pPr algn="ctr"/>
-                      <a:r>
-                        <a:rPr sz="1200" b="1" i="0">
+              </a:tr>
+              <a:tr h="502920">
+                <a:tc>
+                  <a:txBody>
+                    <a:bodyPr wrap="square"/>
+                    <a:lstStyle/>
+                    <a:p>
+                      <a:pPr algn="l"/>
+                      <a:r>
+                        <a:rPr sz="1100" b="1" i="0">
+                          <a:solidFill>
+                            <a:srgbClr val="1F1F1F"/>
+                          </a:solidFill>
+                          <a:latin typeface="Calibri"/>
+                        </a:rPr>
+                        <a:t>LR</a:t>
+                      </a:r>
+                    </a:p>
+                  </a:txBody>
+                  <a:tcPr marL="54864" marR="54864" marT="27432" marB="27432" anchor="ctr">
+                    <a:solidFill>
+                      <a:srgbClr val="EEF2F8"/>
+                    </a:solidFill>
+                  </a:tcPr>
+                </a:tc>
+                <a:tc>
+                  <a:txBody>
+                    <a:bodyPr wrap="square"/>
+                    <a:lstStyle/>
+                    <a:p>
+                      <a:pPr algn="ctr"/>
+                      <a:r>
+                        <a:rPr sz="1100" b="0" i="0">
+                          <a:solidFill>
+                            <a:srgbClr val="1F1F1F"/>
+                          </a:solidFill>
+                          <a:latin typeface="Calibri"/>
+                        </a:rPr>
+                        <a:t>0.692</a:t>
+                      </a:r>
+                    </a:p>
+                  </a:txBody>
+                  <a:tcPr marL="54864" marR="54864" marT="27432" marB="27432" anchor="ctr">
+                    <a:solidFill>
+                      <a:srgbClr val="EEF2F8"/>
+                    </a:solidFill>
+                  </a:tcPr>
+                </a:tc>
+                <a:tc>
+                  <a:txBody>
+                    <a:bodyPr wrap="square"/>
+                    <a:lstStyle/>
+                    <a:p>
+                      <a:pPr algn="ctr"/>
+                      <a:r>
+                        <a:rPr sz="1100" b="0" i="0">
+                          <a:solidFill>
+                            <a:srgbClr val="1F1F1F"/>
+                          </a:solidFill>
+                          <a:latin typeface="Calibri"/>
+                        </a:rPr>
+                        <a:t>0.692</a:t>
+                      </a:r>
+                    </a:p>
+                  </a:txBody>
+                  <a:tcPr marL="54864" marR="54864" marT="27432" marB="27432" anchor="ctr">
+                    <a:solidFill>
+                      <a:srgbClr val="EEF2F8"/>
+                    </a:solidFill>
+                  </a:tcPr>
+                </a:tc>
+                <a:tc>
+                  <a:txBody>
+                    <a:bodyPr wrap="square"/>
+                    <a:lstStyle/>
+                    <a:p>
+                      <a:pPr algn="ctr"/>
+                      <a:r>
+                        <a:rPr sz="1100" b="0" i="0">
+                          <a:solidFill>
+                            <a:srgbClr val="1F1F1F"/>
+                          </a:solidFill>
+                          <a:latin typeface="Calibri"/>
+                        </a:rPr>
+                        <a:t>0.701</a:t>
+                      </a:r>
+                    </a:p>
+                  </a:txBody>
+                  <a:tcPr marL="54864" marR="54864" marT="27432" marB="27432" anchor="ctr">
+                    <a:solidFill>
+                      <a:srgbClr val="EEF2F8"/>
+                    </a:solidFill>
+                  </a:tcPr>
+                </a:tc>
+                <a:tc>
+                  <a:txBody>
+                    <a:bodyPr wrap="square"/>
+                    <a:lstStyle/>
+                    <a:p>
+                      <a:pPr algn="ctr"/>
+                      <a:r>
+                        <a:rPr sz="1100" b="0" i="0">
+                          <a:solidFill>
+                            <a:srgbClr val="1F1F1F"/>
+                          </a:solidFill>
+                          <a:latin typeface="Calibri"/>
+                        </a:rPr>
+                        <a:t>0.701</a:t>
+                      </a:r>
+                    </a:p>
+                  </a:txBody>
+                  <a:tcPr marL="54864" marR="54864" marT="27432" marB="27432" anchor="ctr">
+                    <a:solidFill>
+                      <a:srgbClr val="EEF2F8"/>
+                    </a:solidFill>
+                  </a:tcPr>
+                </a:tc>
+                <a:tc>
+                  <a:txBody>
+                    <a:bodyPr wrap="square"/>
+                    <a:lstStyle/>
+                    <a:p>
+                      <a:pPr algn="ctr"/>
+                      <a:r>
+                        <a:rPr sz="1100" b="0" i="0">
+                          <a:solidFill>
+                            <a:srgbClr val="1F1F1F"/>
+                          </a:solidFill>
+                          <a:latin typeface="Calibri"/>
+                        </a:rPr>
+                        <a:t>0.454</a:t>
+                      </a:r>
+                    </a:p>
+                  </a:txBody>
+                  <a:tcPr marL="54864" marR="54864" marT="27432" marB="27432" anchor="ctr">
+                    <a:solidFill>
+                      <a:srgbClr val="EEF2F8"/>
+                    </a:solidFill>
+                  </a:tcPr>
+                </a:tc>
+                <a:tc>
+                  <a:txBody>
+                    <a:bodyPr wrap="square"/>
+                    <a:lstStyle/>
+                    <a:p>
+                      <a:pPr algn="ctr"/>
+                      <a:r>
+                        <a:rPr sz="1100" b="0" i="0">
+                          <a:solidFill>
+                            <a:srgbClr val="1F1F1F"/>
+                          </a:solidFill>
+                          <a:latin typeface="Calibri"/>
+                        </a:rPr>
+                        <a:t>0.454</a:t>
+                      </a:r>
+                    </a:p>
+                  </a:txBody>
+                  <a:tcPr marL="54864" marR="54864" marT="27432" marB="27432" anchor="ctr">
+                    <a:solidFill>
+                      <a:srgbClr val="EEF2F8"/>
+                    </a:solidFill>
+                  </a:tcPr>
+                </a:tc>
+                <a:tc>
+                  <a:txBody>
+                    <a:bodyPr wrap="square"/>
+                    <a:lstStyle/>
+                    <a:p>
+                      <a:pPr algn="ctr"/>
+                      <a:r>
+                        <a:rPr sz="1100" b="0" i="0">
+                          <a:solidFill>
+                            <a:srgbClr val="1F1F1F"/>
+                          </a:solidFill>
+                          <a:latin typeface="Calibri"/>
+                        </a:rPr>
+                        <a:t>0.747</a:t>
+                      </a:r>
+                    </a:p>
+                  </a:txBody>
+                  <a:tcPr marL="54864" marR="54864" marT="27432" marB="27432" anchor="ctr">
+                    <a:solidFill>
+                      <a:srgbClr val="EEF2F8"/>
+                    </a:solidFill>
+                  </a:tcPr>
+                </a:tc>
+                <a:tc>
+                  <a:txBody>
+                    <a:bodyPr wrap="square"/>
+                    <a:lstStyle/>
+                    <a:p>
+                      <a:pPr algn="ctr"/>
+                      <a:r>
+                        <a:rPr sz="1100" b="0" i="0">
+                          <a:solidFill>
+                            <a:srgbClr val="1F1F1F"/>
+                          </a:solidFill>
+                          <a:latin typeface="Calibri"/>
+                        </a:rPr>
+                        <a:t>0.747</a:t>
+                      </a:r>
+                    </a:p>
+                  </a:txBody>
+                  <a:tcPr marL="54864" marR="54864" marT="27432" marB="27432" anchor="ctr">
+                    <a:solidFill>
+                      <a:srgbClr val="EEF2F8"/>
+                    </a:solidFill>
+                  </a:tcPr>
+                </a:tc>
+              </a:tr>
+              <a:tr h="502920">
+                <a:tc>
+                  <a:txBody>
+                    <a:bodyPr wrap="square"/>
+                    <a:lstStyle/>
+                    <a:p>
+                      <a:pPr algn="l"/>
+                      <a:r>
+                        <a:rPr sz="1100" b="1" i="0">
+                          <a:solidFill>
+                            <a:srgbClr val="1F1F1F"/>
+                          </a:solidFill>
+                          <a:latin typeface="Calibri"/>
+                        </a:rPr>
+                        <a:t>RF</a:t>
+                      </a:r>
+                    </a:p>
+                  </a:txBody>
+                  <a:tcPr marL="54864" marR="54864" marT="27432" marB="27432" anchor="ctr">
+                    <a:solidFill>
+                      <a:srgbClr val="FFFFFF"/>
+                    </a:solidFill>
+                  </a:tcPr>
+                </a:tc>
+                <a:tc>
+                  <a:txBody>
+                    <a:bodyPr wrap="square"/>
+                    <a:lstStyle/>
+                    <a:p>
+                      <a:pPr algn="ctr"/>
+                      <a:r>
+                        <a:rPr sz="1100" b="0" i="0">
+                          <a:solidFill>
+                            <a:srgbClr val="1F1F1F"/>
+                          </a:solidFill>
+                          <a:latin typeface="Calibri"/>
+                        </a:rPr>
+                        <a:t>0.715</a:t>
+                      </a:r>
+                    </a:p>
+                  </a:txBody>
+                  <a:tcPr marL="54864" marR="54864" marT="27432" marB="27432" anchor="ctr">
+                    <a:solidFill>
+                      <a:srgbClr val="FFFFFF"/>
+                    </a:solidFill>
+                  </a:tcPr>
+                </a:tc>
+                <a:tc>
+                  <a:txBody>
+                    <a:bodyPr wrap="square"/>
+                    <a:lstStyle/>
+                    <a:p>
+                      <a:pPr algn="ctr"/>
+                      <a:r>
+                        <a:rPr sz="1100" b="0" i="0">
+                          <a:solidFill>
+                            <a:srgbClr val="1F1F1F"/>
+                          </a:solidFill>
+                          <a:latin typeface="Calibri"/>
+                        </a:rPr>
+                        <a:t>0.715</a:t>
+                      </a:r>
+                    </a:p>
+                  </a:txBody>
+                  <a:tcPr marL="54864" marR="54864" marT="27432" marB="27432" anchor="ctr">
+                    <a:solidFill>
+                      <a:srgbClr val="FFFFFF"/>
+                    </a:solidFill>
+                  </a:tcPr>
+                </a:tc>
+                <a:tc>
+                  <a:txBody>
+                    <a:bodyPr wrap="square"/>
+                    <a:lstStyle/>
+                    <a:p>
+                      <a:pPr algn="ctr"/>
+                      <a:r>
+                        <a:rPr sz="1100" b="0" i="0">
+                          <a:solidFill>
+                            <a:srgbClr val="1F1F1F"/>
+                          </a:solidFill>
+                          <a:latin typeface="Calibri"/>
+                        </a:rPr>
+                        <a:t>0.708</a:t>
+                      </a:r>
+                    </a:p>
+                  </a:txBody>
+                  <a:tcPr marL="54864" marR="54864" marT="27432" marB="27432" anchor="ctr">
+                    <a:solidFill>
+                      <a:srgbClr val="FFFFFF"/>
+                    </a:solidFill>
+                  </a:tcPr>
+                </a:tc>
+                <a:tc>
+                  <a:txBody>
+                    <a:bodyPr wrap="square"/>
+                    <a:lstStyle/>
+                    <a:p>
+                      <a:pPr algn="ctr"/>
+                      <a:r>
+                        <a:rPr sz="1100" b="0" i="0">
+                          <a:solidFill>
+                            <a:srgbClr val="1F1F1F"/>
+                          </a:solidFill>
+                          <a:latin typeface="Calibri"/>
+                        </a:rPr>
+                        <a:t>0.708</a:t>
+                      </a:r>
+                    </a:p>
+                  </a:txBody>
+                  <a:tcPr marL="54864" marR="54864" marT="27432" marB="27432" anchor="ctr">
+                    <a:solidFill>
+                      <a:srgbClr val="FFFFFF"/>
+                    </a:solidFill>
+                  </a:tcPr>
+                </a:tc>
+                <a:tc>
+                  <a:txBody>
+                    <a:bodyPr wrap="square"/>
+                    <a:lstStyle/>
+                    <a:p>
+                      <a:pPr algn="ctr"/>
+                      <a:r>
+                        <a:rPr sz="1100" b="0" i="0">
+                          <a:solidFill>
+                            <a:srgbClr val="1F1F1F"/>
+                          </a:solidFill>
+                          <a:latin typeface="Calibri"/>
+                        </a:rPr>
+                        <a:t>0.427</a:t>
+                      </a:r>
+                    </a:p>
+                  </a:txBody>
+                  <a:tcPr marL="54864" marR="54864" marT="27432" marB="27432" anchor="ctr">
+                    <a:solidFill>
+                      <a:srgbClr val="FFFFFF"/>
+                    </a:solidFill>
+                  </a:tcPr>
+                </a:tc>
+                <a:tc>
+                  <a:txBody>
+                    <a:bodyPr wrap="square"/>
+                    <a:lstStyle/>
+                    <a:p>
+                      <a:pPr algn="ctr"/>
+                      <a:r>
+                        <a:rPr sz="1100" b="0" i="0">
+                          <a:solidFill>
+                            <a:srgbClr val="1F1F1F"/>
+                          </a:solidFill>
+                          <a:latin typeface="Calibri"/>
+                        </a:rPr>
+                        <a:t>0.427</a:t>
+                      </a:r>
+                    </a:p>
+                  </a:txBody>
+                  <a:tcPr marL="54864" marR="54864" marT="27432" marB="27432" anchor="ctr">
+                    <a:solidFill>
+                      <a:srgbClr val="FFFFFF"/>
+                    </a:solidFill>
+                  </a:tcPr>
+                </a:tc>
+                <a:tc>
+                  <a:txBody>
+                    <a:bodyPr wrap="square"/>
+                    <a:lstStyle/>
+                    <a:p>
+                      <a:pPr algn="ctr"/>
+                      <a:r>
+                        <a:rPr sz="1100" b="0" i="0">
+                          <a:solidFill>
+                            <a:srgbClr val="1F1F1F"/>
+                          </a:solidFill>
+                          <a:latin typeface="Calibri"/>
+                        </a:rPr>
+                        <a:t>0.805</a:t>
+                      </a:r>
+                    </a:p>
+                  </a:txBody>
+                  <a:tcPr marL="54864" marR="54864" marT="27432" marB="27432" anchor="ctr">
+                    <a:solidFill>
+                      <a:srgbClr val="FFFFFF"/>
+                    </a:solidFill>
+                  </a:tcPr>
+                </a:tc>
+                <a:tc>
+                  <a:txBody>
+                    <a:bodyPr wrap="square"/>
+                    <a:lstStyle/>
+                    <a:p>
+                      <a:pPr algn="ctr"/>
+                      <a:r>
+                        <a:rPr sz="1100" b="0" i="0">
+                          <a:solidFill>
+                            <a:srgbClr val="1F1F1F"/>
+                          </a:solidFill>
+                          <a:latin typeface="Calibri"/>
+                        </a:rPr>
+                        <a:t>0.804</a:t>
+                      </a:r>
+                    </a:p>
+                  </a:txBody>
+                  <a:tcPr marL="54864" marR="54864" marT="27432" marB="27432" anchor="ctr">
+                    <a:solidFill>
+                      <a:srgbClr val="FFFFFF"/>
+                    </a:solidFill>
+                  </a:tcPr>
+                </a:tc>
+              </a:tr>
+              <a:tr h="502920">
+                <a:tc>
+                  <a:txBody>
+                    <a:bodyPr wrap="square"/>
+                    <a:lstStyle/>
+                    <a:p>
+                      <a:pPr algn="l"/>
+                      <a:r>
+                        <a:rPr sz="1100" b="1" i="0">
+                          <a:solidFill>
+                            <a:srgbClr val="1F1F1F"/>
+                          </a:solidFill>
+                          <a:latin typeface="Calibri"/>
+                        </a:rPr>
+                        <a:t>GBT</a:t>
+                      </a:r>
+                    </a:p>
+                  </a:txBody>
+                  <a:tcPr marL="54864" marR="54864" marT="27432" marB="27432" anchor="ctr">
+                    <a:solidFill>
+                      <a:srgbClr val="EEF2F8"/>
+                    </a:solidFill>
+                  </a:tcPr>
+                </a:tc>
+                <a:tc>
+                  <a:txBody>
+                    <a:bodyPr wrap="square"/>
+                    <a:lstStyle/>
+                    <a:p>
+                      <a:pPr algn="ctr"/>
+                      <a:r>
+                        <a:rPr sz="1100" b="0" i="0">
                           <a:solidFill>
                             <a:srgbClr val="1F1F1F"/>
                           </a:solidFill>
@@ -11000,58 +11606,173 @@
                   </a:txBody>
                   <a:tcPr marL="54864" marR="54864" marT="27432" marB="27432" anchor="ctr">
                     <a:solidFill>
-                      <a:srgbClr val="FFF4CC"/>
-                    </a:solidFill>
-                  </a:tcPr>
-                </a:tc>
-                <a:tc>
-                  <a:txBody>
-                    <a:bodyPr wrap="square"/>
-                    <a:lstStyle/>
-                    <a:p>
-                      <a:pPr algn="ctr"/>
-                      <a:r>
-                        <a:rPr sz="1200" b="1" i="0">
-                          <a:solidFill>
-                            <a:srgbClr val="1F1F1F"/>
-                          </a:solidFill>
-                          <a:latin typeface="Calibri"/>
-                        </a:rPr>
-                        <a:t>0.728</a:t>
-                      </a:r>
-                    </a:p>
-                  </a:txBody>
-                  <a:tcPr marL="54864" marR="54864" marT="27432" marB="27432" anchor="ctr">
-                    <a:solidFill>
-                      <a:srgbClr val="FFF4CC"/>
-                    </a:solidFill>
-                  </a:tcPr>
-                </a:tc>
-                <a:tc>
-                  <a:txBody>
-                    <a:bodyPr wrap="square"/>
-                    <a:lstStyle/>
-                    <a:p>
-                      <a:pPr algn="ctr"/>
-                      <a:r>
-                        <a:rPr sz="1200" b="1" i="0">
-                          <a:solidFill>
-                            <a:srgbClr val="1F1F1F"/>
-                          </a:solidFill>
-                          <a:latin typeface="Calibri"/>
-                        </a:rPr>
-                        <a:t>+0.002</a:t>
-                      </a:r>
-                    </a:p>
-                  </a:txBody>
-                  <a:tcPr marL="54864" marR="54864" marT="27432" marB="27432" anchor="ctr">
-                    <a:solidFill>
-                      <a:srgbClr val="FFF4CC"/>
+                      <a:srgbClr val="EEF2F8"/>
+                    </a:solidFill>
+                  </a:tcPr>
+                </a:tc>
+                <a:tc>
+                  <a:txBody>
+                    <a:bodyPr wrap="square"/>
+                    <a:lstStyle/>
+                    <a:p>
+                      <a:pPr algn="ctr"/>
+                      <a:r>
+                        <a:rPr sz="1100" b="0" i="0">
+                          <a:solidFill>
+                            <a:srgbClr val="1F1F1F"/>
+                          </a:solidFill>
+                          <a:latin typeface="Calibri"/>
+                        </a:rPr>
+                        <a:t>0.725</a:t>
+                      </a:r>
+                    </a:p>
+                  </a:txBody>
+                  <a:tcPr marL="54864" marR="54864" marT="27432" marB="27432" anchor="ctr">
+                    <a:solidFill>
+                      <a:srgbClr val="EEF2F8"/>
+                    </a:solidFill>
+                  </a:tcPr>
+                </a:tc>
+                <a:tc>
+                  <a:txBody>
+                    <a:bodyPr wrap="square"/>
+                    <a:lstStyle/>
+                    <a:p>
+                      <a:pPr algn="ctr"/>
+                      <a:r>
+                        <a:rPr sz="1100" b="0" i="0">
+                          <a:solidFill>
+                            <a:srgbClr val="1F1F1F"/>
+                          </a:solidFill>
+                          <a:latin typeface="Calibri"/>
+                        </a:rPr>
+                        <a:t>0.724</a:t>
+                      </a:r>
+                    </a:p>
+                  </a:txBody>
+                  <a:tcPr marL="54864" marR="54864" marT="27432" marB="27432" anchor="ctr">
+                    <a:solidFill>
+                      <a:srgbClr val="EEF2F8"/>
+                    </a:solidFill>
+                  </a:tcPr>
+                </a:tc>
+                <a:tc>
+                  <a:txBody>
+                    <a:bodyPr wrap="square"/>
+                    <a:lstStyle/>
+                    <a:p>
+                      <a:pPr algn="ctr"/>
+                      <a:r>
+                        <a:rPr sz="1100" b="0" i="0">
+                          <a:solidFill>
+                            <a:srgbClr val="1F1F1F"/>
+                          </a:solidFill>
+                          <a:latin typeface="Calibri"/>
+                        </a:rPr>
+                        <a:t>0.724</a:t>
+                      </a:r>
+                    </a:p>
+                  </a:txBody>
+                  <a:tcPr marL="54864" marR="54864" marT="27432" marB="27432" anchor="ctr">
+                    <a:solidFill>
+                      <a:srgbClr val="EEF2F8"/>
+                    </a:solidFill>
+                  </a:tcPr>
+                </a:tc>
+                <a:tc>
+                  <a:txBody>
+                    <a:bodyPr wrap="square"/>
+                    <a:lstStyle/>
+                    <a:p>
+                      <a:pPr algn="ctr"/>
+                      <a:r>
+                        <a:rPr sz="1100" b="0" i="0">
+                          <a:solidFill>
+                            <a:srgbClr val="1F1F1F"/>
+                          </a:solidFill>
+                          <a:latin typeface="Calibri"/>
+                        </a:rPr>
+                        <a:t>0.432</a:t>
+                      </a:r>
+                    </a:p>
+                  </a:txBody>
+                  <a:tcPr marL="54864" marR="54864" marT="27432" marB="27432" anchor="ctr">
+                    <a:solidFill>
+                      <a:srgbClr val="EEF2F8"/>
+                    </a:solidFill>
+                  </a:tcPr>
+                </a:tc>
+                <a:tc>
+                  <a:txBody>
+                    <a:bodyPr wrap="square"/>
+                    <a:lstStyle/>
+                    <a:p>
+                      <a:pPr algn="ctr"/>
+                      <a:r>
+                        <a:rPr sz="1100" b="0" i="0">
+                          <a:solidFill>
+                            <a:srgbClr val="1F1F1F"/>
+                          </a:solidFill>
+                          <a:latin typeface="Calibri"/>
+                        </a:rPr>
+                        <a:t>0.433</a:t>
+                      </a:r>
+                    </a:p>
+                  </a:txBody>
+                  <a:tcPr marL="54864" marR="54864" marT="27432" marB="27432" anchor="ctr">
+                    <a:solidFill>
+                      <a:srgbClr val="EEF2F8"/>
+                    </a:solidFill>
+                  </a:tcPr>
+                </a:tc>
+                <a:tc>
+                  <a:txBody>
+                    <a:bodyPr wrap="square"/>
+                    <a:lstStyle/>
+                    <a:p>
+                      <a:pPr algn="ctr"/>
+                      <a:r>
+                        <a:rPr sz="1100" b="0" i="0">
+                          <a:solidFill>
+                            <a:srgbClr val="1F1F1F"/>
+                          </a:solidFill>
+                          <a:latin typeface="Calibri"/>
+                        </a:rPr>
+                        <a:t>0.811</a:t>
+                      </a:r>
+                    </a:p>
+                  </a:txBody>
+                  <a:tcPr marL="54864" marR="54864" marT="27432" marB="27432" anchor="ctr">
+                    <a:solidFill>
+                      <a:srgbClr val="EEF2F8"/>
+                    </a:solidFill>
+                  </a:tcPr>
+                </a:tc>
+                <a:tc>
+                  <a:txBody>
+                    <a:bodyPr wrap="square"/>
+                    <a:lstStyle/>
+                    <a:p>
+                      <a:pPr algn="ctr"/>
+                      <a:r>
+                        <a:rPr sz="1100" b="0" i="0">
+                          <a:solidFill>
+                            <a:srgbClr val="1F1F1F"/>
+                          </a:solidFill>
+                          <a:latin typeface="Calibri"/>
+                        </a:rPr>
+                        <a:t>0.811</a:t>
+                      </a:r>
+                    </a:p>
+                  </a:txBody>
+                  <a:tcPr marL="54864" marR="54864" marT="27432" marB="27432" anchor="ctr">
+                    <a:solidFill>
+                      <a:srgbClr val="EEF2F8"/>
                     </a:solidFill>
                   </a:tcPr>
                 </a:tc>
               </a:tr>
-              <a:tr h="530352">
+              <a:tr h="502920">
                 <a:tc>
                   <a:txBody>
                     <a:bodyPr wrap="square"/>
@@ -11059,13 +11780,222 @@
                     <a:p>
                       <a:pPr algn="l"/>
                       <a:r>
-                        <a:rPr sz="1200" b="1" i="0">
-                          <a:solidFill>
-                            <a:srgbClr val="1F1F1F"/>
-                          </a:solidFill>
-                          <a:latin typeface="Calibri"/>
-                        </a:rPr>
-                        <a:t>Logistic Regression</a:t>
+                        <a:rPr sz="1100" b="1" i="0">
+                          <a:solidFill>
+                            <a:srgbClr val="1F1F1F"/>
+                          </a:solidFill>
+                          <a:latin typeface="Calibri"/>
+                        </a:rPr>
+                        <a:t>Linear SVM</a:t>
+                      </a:r>
+                    </a:p>
+                  </a:txBody>
+                  <a:tcPr marL="54864" marR="54864" marT="27432" marB="27432" anchor="ctr">
+                    <a:solidFill>
+                      <a:srgbClr val="FFFFFF"/>
+                    </a:solidFill>
+                  </a:tcPr>
+                </a:tc>
+                <a:tc>
+                  <a:txBody>
+                    <a:bodyPr wrap="square"/>
+                    <a:lstStyle/>
+                    <a:p>
+                      <a:pPr algn="ctr"/>
+                      <a:r>
+                        <a:rPr sz="1100" b="0" i="0">
+                          <a:solidFill>
+                            <a:srgbClr val="1F1F1F"/>
+                          </a:solidFill>
+                          <a:latin typeface="Calibri"/>
+                        </a:rPr>
+                        <a:t>0.696</a:t>
+                      </a:r>
+                    </a:p>
+                  </a:txBody>
+                  <a:tcPr marL="54864" marR="54864" marT="27432" marB="27432" anchor="ctr">
+                    <a:solidFill>
+                      <a:srgbClr val="FFFFFF"/>
+                    </a:solidFill>
+                  </a:tcPr>
+                </a:tc>
+                <a:tc>
+                  <a:txBody>
+                    <a:bodyPr wrap="square"/>
+                    <a:lstStyle/>
+                    <a:p>
+                      <a:pPr algn="ctr"/>
+                      <a:r>
+                        <a:rPr sz="1100" b="0" i="0">
+                          <a:solidFill>
+                            <a:srgbClr val="1F1F1F"/>
+                          </a:solidFill>
+                          <a:latin typeface="Calibri"/>
+                        </a:rPr>
+                        <a:t>0.696</a:t>
+                      </a:r>
+                    </a:p>
+                  </a:txBody>
+                  <a:tcPr marL="54864" marR="54864" marT="27432" marB="27432" anchor="ctr">
+                    <a:solidFill>
+                      <a:srgbClr val="FFFFFF"/>
+                    </a:solidFill>
+                  </a:tcPr>
+                </a:tc>
+                <a:tc>
+                  <a:txBody>
+                    <a:bodyPr wrap="square"/>
+                    <a:lstStyle/>
+                    <a:p>
+                      <a:pPr algn="ctr"/>
+                      <a:r>
+                        <a:rPr sz="1100" b="0" i="0">
+                          <a:solidFill>
+                            <a:srgbClr val="1F1F1F"/>
+                          </a:solidFill>
+                          <a:latin typeface="Calibri"/>
+                        </a:rPr>
+                        <a:t>0.708</a:t>
+                      </a:r>
+                    </a:p>
+                  </a:txBody>
+                  <a:tcPr marL="54864" marR="54864" marT="27432" marB="27432" anchor="ctr">
+                    <a:solidFill>
+                      <a:srgbClr val="FFFFFF"/>
+                    </a:solidFill>
+                  </a:tcPr>
+                </a:tc>
+                <a:tc>
+                  <a:txBody>
+                    <a:bodyPr wrap="square"/>
+                    <a:lstStyle/>
+                    <a:p>
+                      <a:pPr algn="ctr"/>
+                      <a:r>
+                        <a:rPr sz="1100" b="0" i="0">
+                          <a:solidFill>
+                            <a:srgbClr val="1F1F1F"/>
+                          </a:solidFill>
+                          <a:latin typeface="Calibri"/>
+                        </a:rPr>
+                        <a:t>0.708</a:t>
+                      </a:r>
+                    </a:p>
+                  </a:txBody>
+                  <a:tcPr marL="54864" marR="54864" marT="27432" marB="27432" anchor="ctr">
+                    <a:solidFill>
+                      <a:srgbClr val="FFFFFF"/>
+                    </a:solidFill>
+                  </a:tcPr>
+                </a:tc>
+                <a:tc>
+                  <a:txBody>
+                    <a:bodyPr wrap="square"/>
+                    <a:lstStyle/>
+                    <a:p>
+                      <a:pPr algn="ctr"/>
+                      <a:r>
+                        <a:rPr sz="1100" b="0" i="0">
+                          <a:solidFill>
+                            <a:srgbClr val="1F1F1F"/>
+                          </a:solidFill>
+                          <a:latin typeface="Calibri"/>
+                        </a:rPr>
+                        <a:t>n/a</a:t>
+                      </a:r>
+                    </a:p>
+                  </a:txBody>
+                  <a:tcPr marL="54864" marR="54864" marT="27432" marB="27432" anchor="ctr">
+                    <a:solidFill>
+                      <a:srgbClr val="FFFFFF"/>
+                    </a:solidFill>
+                  </a:tcPr>
+                </a:tc>
+                <a:tc>
+                  <a:txBody>
+                    <a:bodyPr wrap="square"/>
+                    <a:lstStyle/>
+                    <a:p>
+                      <a:pPr algn="ctr"/>
+                      <a:r>
+                        <a:rPr sz="1100" b="0" i="0">
+                          <a:solidFill>
+                            <a:srgbClr val="1F1F1F"/>
+                          </a:solidFill>
+                          <a:latin typeface="Calibri"/>
+                        </a:rPr>
+                        <a:t>n/a</a:t>
+                      </a:r>
+                    </a:p>
+                  </a:txBody>
+                  <a:tcPr marL="54864" marR="54864" marT="27432" marB="27432" anchor="ctr">
+                    <a:solidFill>
+                      <a:srgbClr val="FFFFFF"/>
+                    </a:solidFill>
+                  </a:tcPr>
+                </a:tc>
+                <a:tc>
+                  <a:txBody>
+                    <a:bodyPr wrap="square"/>
+                    <a:lstStyle/>
+                    <a:p>
+                      <a:pPr algn="ctr"/>
+                      <a:r>
+                        <a:rPr sz="1100" b="0" i="0">
+                          <a:solidFill>
+                            <a:srgbClr val="1F1F1F"/>
+                          </a:solidFill>
+                          <a:latin typeface="Calibri"/>
+                        </a:rPr>
+                        <a:t>0.755</a:t>
+                      </a:r>
+                    </a:p>
+                  </a:txBody>
+                  <a:tcPr marL="54864" marR="54864" marT="27432" marB="27432" anchor="ctr">
+                    <a:solidFill>
+                      <a:srgbClr val="FFFFFF"/>
+                    </a:solidFill>
+                  </a:tcPr>
+                </a:tc>
+                <a:tc>
+                  <a:txBody>
+                    <a:bodyPr wrap="square"/>
+                    <a:lstStyle/>
+                    <a:p>
+                      <a:pPr algn="ctr"/>
+                      <a:r>
+                        <a:rPr sz="1100" b="0" i="0">
+                          <a:solidFill>
+                            <a:srgbClr val="1F1F1F"/>
+                          </a:solidFill>
+                          <a:latin typeface="Calibri"/>
+                        </a:rPr>
+                        <a:t>0.755</a:t>
+                      </a:r>
+                    </a:p>
+                  </a:txBody>
+                  <a:tcPr marL="54864" marR="54864" marT="27432" marB="27432" anchor="ctr">
+                    <a:solidFill>
+                      <a:srgbClr val="FFFFFF"/>
+                    </a:solidFill>
+                  </a:tcPr>
+                </a:tc>
+              </a:tr>
+              <a:tr h="502920">
+                <a:tc>
+                  <a:txBody>
+                    <a:bodyPr wrap="square"/>
+                    <a:lstStyle/>
+                    <a:p>
+                      <a:pPr algn="l"/>
+                      <a:r>
+                        <a:rPr sz="1100" b="1" i="0">
+                          <a:solidFill>
+                            <a:srgbClr val="1F1F1F"/>
+                          </a:solidFill>
+                          <a:latin typeface="Calibri"/>
+                        </a:rPr>
+                        <a:t>MLP</a:t>
                       </a:r>
                     </a:p>
                   </a:txBody>
@@ -11082,13 +12012,13 @@
                     <a:p>
                       <a:pPr algn="ctr"/>
                       <a:r>
-                        <a:rPr sz="1200" b="0" i="0">
-                          <a:solidFill>
-                            <a:srgbClr val="1F1F1F"/>
-                          </a:solidFill>
-                          <a:latin typeface="Calibri"/>
-                        </a:rPr>
-                        <a:t>0.747</a:t>
+                        <a:rPr sz="1100" b="0" i="0">
+                          <a:solidFill>
+                            <a:srgbClr val="1F1F1F"/>
+                          </a:solidFill>
+                          <a:latin typeface="Calibri"/>
+                        </a:rPr>
+                        <a:t>0.711</a:t>
                       </a:r>
                     </a:p>
                   </a:txBody>
@@ -11105,13 +12035,13 @@
                     <a:p>
                       <a:pPr algn="ctr"/>
                       <a:r>
-                        <a:rPr sz="1200" b="0" i="0">
-                          <a:solidFill>
-                            <a:srgbClr val="1F1F1F"/>
-                          </a:solidFill>
-                          <a:latin typeface="Calibri"/>
-                        </a:rPr>
-                        <a:t>0.747</a:t>
+                        <a:rPr sz="1100" b="0" i="0">
+                          <a:solidFill>
+                            <a:srgbClr val="1F1F1F"/>
+                          </a:solidFill>
+                          <a:latin typeface="Calibri"/>
+                        </a:rPr>
+                        <a:t>0.699</a:t>
                       </a:r>
                     </a:p>
                   </a:txBody>
@@ -11128,13 +12058,13 @@
                     <a:p>
                       <a:pPr algn="ctr"/>
                       <a:r>
-                        <a:rPr sz="1200" b="0" i="0">
-                          <a:solidFill>
-                            <a:srgbClr val="1F1F1F"/>
-                          </a:solidFill>
-                          <a:latin typeface="Calibri"/>
-                        </a:rPr>
-                        <a:t>+0.000</a:t>
+                        <a:rPr sz="1100" b="0" i="0">
+                          <a:solidFill>
+                            <a:srgbClr val="1F1F1F"/>
+                          </a:solidFill>
+                          <a:latin typeface="Calibri"/>
+                        </a:rPr>
+                        <a:t>0.678</a:t>
                       </a:r>
                     </a:p>
                   </a:txBody>
@@ -11151,13 +12081,13 @@
                     <a:p>
                       <a:pPr algn="ctr"/>
                       <a:r>
-                        <a:rPr sz="1200" b="0" i="0">
-                          <a:solidFill>
-                            <a:srgbClr val="1F1F1F"/>
-                          </a:solidFill>
-                          <a:latin typeface="Calibri"/>
-                        </a:rPr>
-                        <a:t>0.701</a:t>
+                        <a:rPr sz="1100" b="0" i="0">
+                          <a:solidFill>
+                            <a:srgbClr val="1F1F1F"/>
+                          </a:solidFill>
+                          <a:latin typeface="Calibri"/>
+                        </a:rPr>
+                        <a:t>0.692</a:t>
                       </a:r>
                     </a:p>
                   </a:txBody>
@@ -11174,13 +12104,13 @@
                     <a:p>
                       <a:pPr algn="ctr"/>
                       <a:r>
-                        <a:rPr sz="1200" b="0" i="0">
-                          <a:solidFill>
-                            <a:srgbClr val="1F1F1F"/>
-                          </a:solidFill>
-                          <a:latin typeface="Calibri"/>
-                        </a:rPr>
-                        <a:t>0.701</a:t>
+                        <a:rPr sz="1100" b="0" i="0">
+                          <a:solidFill>
+                            <a:srgbClr val="1F1F1F"/>
+                          </a:solidFill>
+                          <a:latin typeface="Calibri"/>
+                        </a:rPr>
+                        <a:t>0.445</a:t>
                       </a:r>
                     </a:p>
                   </a:txBody>
@@ -11197,13 +12127,13 @@
                     <a:p>
                       <a:pPr algn="ctr"/>
                       <a:r>
-                        <a:rPr sz="1200" b="0" i="0">
-                          <a:solidFill>
-                            <a:srgbClr val="1F1F1F"/>
-                          </a:solidFill>
-                          <a:latin typeface="Calibri"/>
-                        </a:rPr>
-                        <a:t>+0.000</a:t>
+                        <a:rPr sz="1100" b="0" i="0">
+                          <a:solidFill>
+                            <a:srgbClr val="1F1F1F"/>
+                          </a:solidFill>
+                          <a:latin typeface="Calibri"/>
+                        </a:rPr>
+                        <a:t>0.440</a:t>
                       </a:r>
                     </a:p>
                   </a:txBody>
@@ -11213,185 +12143,20 @@
                     </a:solidFill>
                   </a:tcPr>
                 </a:tc>
-              </a:tr>
-              <a:tr h="530352">
-                <a:tc>
-                  <a:txBody>
-                    <a:bodyPr wrap="square"/>
-                    <a:lstStyle/>
-                    <a:p>
-                      <a:pPr algn="l"/>
-                      <a:r>
-                        <a:rPr sz="1200" b="1" i="0">
-                          <a:solidFill>
-                            <a:srgbClr val="1F1F1F"/>
-                          </a:solidFill>
-                          <a:latin typeface="Calibri"/>
-                        </a:rPr>
-                        <a:t>Random Forest</a:t>
-                      </a:r>
-                    </a:p>
-                  </a:txBody>
-                  <a:tcPr marL="54864" marR="54864" marT="27432" marB="27432" anchor="ctr">
-                    <a:solidFill>
-                      <a:srgbClr val="FFFFFF"/>
-                    </a:solidFill>
-                  </a:tcPr>
-                </a:tc>
-                <a:tc>
-                  <a:txBody>
-                    <a:bodyPr wrap="square"/>
-                    <a:lstStyle/>
-                    <a:p>
-                      <a:pPr algn="ctr"/>
-                      <a:r>
-                        <a:rPr sz="1200" b="0" i="0">
-                          <a:solidFill>
-                            <a:srgbClr val="1F1F1F"/>
-                          </a:solidFill>
-                          <a:latin typeface="Calibri"/>
-                        </a:rPr>
-                        <a:t>0.805</a:t>
-                      </a:r>
-                    </a:p>
-                  </a:txBody>
-                  <a:tcPr marL="54864" marR="54864" marT="27432" marB="27432" anchor="ctr">
-                    <a:solidFill>
-                      <a:srgbClr val="FFFFFF"/>
-                    </a:solidFill>
-                  </a:tcPr>
-                </a:tc>
-                <a:tc>
-                  <a:txBody>
-                    <a:bodyPr wrap="square"/>
-                    <a:lstStyle/>
-                    <a:p>
-                      <a:pPr algn="ctr"/>
-                      <a:r>
-                        <a:rPr sz="1200" b="0" i="0">
-                          <a:solidFill>
-                            <a:srgbClr val="1F1F1F"/>
-                          </a:solidFill>
-                          <a:latin typeface="Calibri"/>
-                        </a:rPr>
-                        <a:t>0.804</a:t>
-                      </a:r>
-                    </a:p>
-                  </a:txBody>
-                  <a:tcPr marL="54864" marR="54864" marT="27432" marB="27432" anchor="ctr">
-                    <a:solidFill>
-                      <a:srgbClr val="FFFFFF"/>
-                    </a:solidFill>
-                  </a:tcPr>
-                </a:tc>
-                <a:tc>
-                  <a:txBody>
-                    <a:bodyPr wrap="square"/>
-                    <a:lstStyle/>
-                    <a:p>
-                      <a:pPr algn="ctr"/>
-                      <a:r>
-                        <a:rPr sz="1200" b="0" i="0">
-                          <a:solidFill>
-                            <a:srgbClr val="1F1F1F"/>
-                          </a:solidFill>
-                          <a:latin typeface="Calibri"/>
-                        </a:rPr>
-                        <a:t>+0.000</a:t>
-                      </a:r>
-                    </a:p>
-                  </a:txBody>
-                  <a:tcPr marL="54864" marR="54864" marT="27432" marB="27432" anchor="ctr">
-                    <a:solidFill>
-                      <a:srgbClr val="FFFFFF"/>
-                    </a:solidFill>
-                  </a:tcPr>
-                </a:tc>
-                <a:tc>
-                  <a:txBody>
-                    <a:bodyPr wrap="square"/>
-                    <a:lstStyle/>
-                    <a:p>
-                      <a:pPr algn="ctr"/>
-                      <a:r>
-                        <a:rPr sz="1200" b="0" i="0">
-                          <a:solidFill>
-                            <a:srgbClr val="1F1F1F"/>
-                          </a:solidFill>
-                          <a:latin typeface="Calibri"/>
-                        </a:rPr>
-                        <a:t>0.708</a:t>
-                      </a:r>
-                    </a:p>
-                  </a:txBody>
-                  <a:tcPr marL="54864" marR="54864" marT="27432" marB="27432" anchor="ctr">
-                    <a:solidFill>
-                      <a:srgbClr val="FFFFFF"/>
-                    </a:solidFill>
-                  </a:tcPr>
-                </a:tc>
-                <a:tc>
-                  <a:txBody>
-                    <a:bodyPr wrap="square"/>
-                    <a:lstStyle/>
-                    <a:p>
-                      <a:pPr algn="ctr"/>
-                      <a:r>
-                        <a:rPr sz="1200" b="0" i="0">
-                          <a:solidFill>
-                            <a:srgbClr val="1F1F1F"/>
-                          </a:solidFill>
-                          <a:latin typeface="Calibri"/>
-                        </a:rPr>
-                        <a:t>0.708</a:t>
-                      </a:r>
-                    </a:p>
-                  </a:txBody>
-                  <a:tcPr marL="54864" marR="54864" marT="27432" marB="27432" anchor="ctr">
-                    <a:solidFill>
-                      <a:srgbClr val="FFFFFF"/>
-                    </a:solidFill>
-                  </a:tcPr>
-                </a:tc>
-                <a:tc>
-                  <a:txBody>
-                    <a:bodyPr wrap="square"/>
-                    <a:lstStyle/>
-                    <a:p>
-                      <a:pPr algn="ctr"/>
-                      <a:r>
-                        <a:rPr sz="1200" b="0" i="0">
-                          <a:solidFill>
-                            <a:srgbClr val="1F1F1F"/>
-                          </a:solidFill>
-                          <a:latin typeface="Calibri"/>
-                        </a:rPr>
-                        <a:t>+0.000</a:t>
-                      </a:r>
-                    </a:p>
-                  </a:txBody>
-                  <a:tcPr marL="54864" marR="54864" marT="27432" marB="27432" anchor="ctr">
-                    <a:solidFill>
-                      <a:srgbClr val="FFFFFF"/>
-                    </a:solidFill>
-                  </a:tcPr>
-                </a:tc>
-              </a:tr>
-              <a:tr h="530352">
-                <a:tc>
-                  <a:txBody>
-                    <a:bodyPr wrap="square"/>
-                    <a:lstStyle/>
-                    <a:p>
-                      <a:pPr algn="l"/>
-                      <a:r>
-                        <a:rPr sz="1200" b="1" i="0">
-                          <a:solidFill>
-                            <a:srgbClr val="1F1F1F"/>
-                          </a:solidFill>
-                          <a:latin typeface="Calibri"/>
-                        </a:rPr>
-                        <a:t>Gradient-Boosted Trees</a:t>
+                <a:tc>
+                  <a:txBody>
+                    <a:bodyPr wrap="square"/>
+                    <a:lstStyle/>
+                    <a:p>
+                      <a:pPr algn="ctr"/>
+                      <a:r>
+                        <a:rPr sz="1100" b="0" i="0">
+                          <a:solidFill>
+                            <a:srgbClr val="1F1F1F"/>
+                          </a:solidFill>
+                          <a:latin typeface="Calibri"/>
+                        </a:rPr>
+                        <a:t>0.759</a:t>
                       </a:r>
                     </a:p>
                   </a:txBody>
@@ -11408,454 +12173,13 @@
                     <a:p>
                       <a:pPr algn="ctr"/>
                       <a:r>
-                        <a:rPr sz="1200" b="0" i="0">
-                          <a:solidFill>
-                            <a:srgbClr val="1F1F1F"/>
-                          </a:solidFill>
-                          <a:latin typeface="Calibri"/>
-                        </a:rPr>
-                        <a:t>0.811</a:t>
-                      </a:r>
-                    </a:p>
-                  </a:txBody>
-                  <a:tcPr marL="54864" marR="54864" marT="27432" marB="27432" anchor="ctr">
-                    <a:solidFill>
-                      <a:srgbClr val="EEF2F8"/>
-                    </a:solidFill>
-                  </a:tcPr>
-                </a:tc>
-                <a:tc>
-                  <a:txBody>
-                    <a:bodyPr wrap="square"/>
-                    <a:lstStyle/>
-                    <a:p>
-                      <a:pPr algn="ctr"/>
-                      <a:r>
-                        <a:rPr sz="1200" b="0" i="0">
-                          <a:solidFill>
-                            <a:srgbClr val="1F1F1F"/>
-                          </a:solidFill>
-                          <a:latin typeface="Calibri"/>
-                        </a:rPr>
-                        <a:t>0.811</a:t>
-                      </a:r>
-                    </a:p>
-                  </a:txBody>
-                  <a:tcPr marL="54864" marR="54864" marT="27432" marB="27432" anchor="ctr">
-                    <a:solidFill>
-                      <a:srgbClr val="EEF2F8"/>
-                    </a:solidFill>
-                  </a:tcPr>
-                </a:tc>
-                <a:tc>
-                  <a:txBody>
-                    <a:bodyPr wrap="square"/>
-                    <a:lstStyle/>
-                    <a:p>
-                      <a:pPr algn="ctr"/>
-                      <a:r>
-                        <a:rPr sz="1200" b="0" i="0">
-                          <a:solidFill>
-                            <a:srgbClr val="1F1F1F"/>
-                          </a:solidFill>
-                          <a:latin typeface="Calibri"/>
-                        </a:rPr>
-                        <a:t>+0.000</a:t>
-                      </a:r>
-                    </a:p>
-                  </a:txBody>
-                  <a:tcPr marL="54864" marR="54864" marT="27432" marB="27432" anchor="ctr">
-                    <a:solidFill>
-                      <a:srgbClr val="EEF2F8"/>
-                    </a:solidFill>
-                  </a:tcPr>
-                </a:tc>
-                <a:tc>
-                  <a:txBody>
-                    <a:bodyPr wrap="square"/>
-                    <a:lstStyle/>
-                    <a:p>
-                      <a:pPr algn="ctr"/>
-                      <a:r>
-                        <a:rPr sz="1200" b="0" i="0">
-                          <a:solidFill>
-                            <a:srgbClr val="1F1F1F"/>
-                          </a:solidFill>
-                          <a:latin typeface="Calibri"/>
-                        </a:rPr>
-                        <a:t>0.724</a:t>
-                      </a:r>
-                    </a:p>
-                  </a:txBody>
-                  <a:tcPr marL="54864" marR="54864" marT="27432" marB="27432" anchor="ctr">
-                    <a:solidFill>
-                      <a:srgbClr val="EEF2F8"/>
-                    </a:solidFill>
-                  </a:tcPr>
-                </a:tc>
-                <a:tc>
-                  <a:txBody>
-                    <a:bodyPr wrap="square"/>
-                    <a:lstStyle/>
-                    <a:p>
-                      <a:pPr algn="ctr"/>
-                      <a:r>
-                        <a:rPr sz="1200" b="0" i="0">
-                          <a:solidFill>
-                            <a:srgbClr val="1F1F1F"/>
-                          </a:solidFill>
-                          <a:latin typeface="Calibri"/>
-                        </a:rPr>
-                        <a:t>0.724</a:t>
-                      </a:r>
-                    </a:p>
-                  </a:txBody>
-                  <a:tcPr marL="54864" marR="54864" marT="27432" marB="27432" anchor="ctr">
-                    <a:solidFill>
-                      <a:srgbClr val="EEF2F8"/>
-                    </a:solidFill>
-                  </a:tcPr>
-                </a:tc>
-                <a:tc>
-                  <a:txBody>
-                    <a:bodyPr wrap="square"/>
-                    <a:lstStyle/>
-                    <a:p>
-                      <a:pPr algn="ctr"/>
-                      <a:r>
-                        <a:rPr sz="1200" b="0" i="0">
-                          <a:solidFill>
-                            <a:srgbClr val="1F1F1F"/>
-                          </a:solidFill>
-                          <a:latin typeface="Calibri"/>
-                        </a:rPr>
-                        <a:t>+0.000</a:t>
-                      </a:r>
-                    </a:p>
-                  </a:txBody>
-                  <a:tcPr marL="54864" marR="54864" marT="27432" marB="27432" anchor="ctr">
-                    <a:solidFill>
-                      <a:srgbClr val="EEF2F8"/>
-                    </a:solidFill>
-                  </a:tcPr>
-                </a:tc>
-              </a:tr>
-              <a:tr h="530352">
-                <a:tc>
-                  <a:txBody>
-                    <a:bodyPr wrap="square"/>
-                    <a:lstStyle/>
-                    <a:p>
-                      <a:pPr algn="l"/>
-                      <a:r>
-                        <a:rPr sz="1200" b="1" i="0">
-                          <a:solidFill>
-                            <a:srgbClr val="1F1F1F"/>
-                          </a:solidFill>
-                          <a:latin typeface="Calibri"/>
-                        </a:rPr>
-                        <a:t>Linear SVM</a:t>
-                      </a:r>
-                    </a:p>
-                  </a:txBody>
-                  <a:tcPr marL="54864" marR="54864" marT="27432" marB="27432" anchor="ctr">
-                    <a:solidFill>
-                      <a:srgbClr val="FFFFFF"/>
-                    </a:solidFill>
-                  </a:tcPr>
-                </a:tc>
-                <a:tc>
-                  <a:txBody>
-                    <a:bodyPr wrap="square"/>
-                    <a:lstStyle/>
-                    <a:p>
-                      <a:pPr algn="ctr"/>
-                      <a:r>
-                        <a:rPr sz="1200" b="0" i="0">
-                          <a:solidFill>
-                            <a:srgbClr val="1F1F1F"/>
-                          </a:solidFill>
-                          <a:latin typeface="Calibri"/>
-                        </a:rPr>
-                        <a:t>0.755</a:t>
-                      </a:r>
-                    </a:p>
-                  </a:txBody>
-                  <a:tcPr marL="54864" marR="54864" marT="27432" marB="27432" anchor="ctr">
-                    <a:solidFill>
-                      <a:srgbClr val="FFFFFF"/>
-                    </a:solidFill>
-                  </a:tcPr>
-                </a:tc>
-                <a:tc>
-                  <a:txBody>
-                    <a:bodyPr wrap="square"/>
-                    <a:lstStyle/>
-                    <a:p>
-                      <a:pPr algn="ctr"/>
-                      <a:r>
-                        <a:rPr sz="1200" b="0" i="0">
-                          <a:solidFill>
-                            <a:srgbClr val="1F1F1F"/>
-                          </a:solidFill>
-                          <a:latin typeface="Calibri"/>
-                        </a:rPr>
-                        <a:t>0.755</a:t>
-                      </a:r>
-                    </a:p>
-                  </a:txBody>
-                  <a:tcPr marL="54864" marR="54864" marT="27432" marB="27432" anchor="ctr">
-                    <a:solidFill>
-                      <a:srgbClr val="FFFFFF"/>
-                    </a:solidFill>
-                  </a:tcPr>
-                </a:tc>
-                <a:tc>
-                  <a:txBody>
-                    <a:bodyPr wrap="square"/>
-                    <a:lstStyle/>
-                    <a:p>
-                      <a:pPr algn="ctr"/>
-                      <a:r>
-                        <a:rPr sz="1200" b="0" i="0">
-                          <a:solidFill>
-                            <a:srgbClr val="1F1F1F"/>
-                          </a:solidFill>
-                          <a:latin typeface="Calibri"/>
-                        </a:rPr>
-                        <a:t>+0.000</a:t>
-                      </a:r>
-                    </a:p>
-                  </a:txBody>
-                  <a:tcPr marL="54864" marR="54864" marT="27432" marB="27432" anchor="ctr">
-                    <a:solidFill>
-                      <a:srgbClr val="FFFFFF"/>
-                    </a:solidFill>
-                  </a:tcPr>
-                </a:tc>
-                <a:tc>
-                  <a:txBody>
-                    <a:bodyPr wrap="square"/>
-                    <a:lstStyle/>
-                    <a:p>
-                      <a:pPr algn="ctr"/>
-                      <a:r>
-                        <a:rPr sz="1200" b="0" i="0">
-                          <a:solidFill>
-                            <a:srgbClr val="1F1F1F"/>
-                          </a:solidFill>
-                          <a:latin typeface="Calibri"/>
-                        </a:rPr>
-                        <a:t>0.708</a:t>
-                      </a:r>
-                    </a:p>
-                  </a:txBody>
-                  <a:tcPr marL="54864" marR="54864" marT="27432" marB="27432" anchor="ctr">
-                    <a:solidFill>
-                      <a:srgbClr val="FFFFFF"/>
-                    </a:solidFill>
-                  </a:tcPr>
-                </a:tc>
-                <a:tc>
-                  <a:txBody>
-                    <a:bodyPr wrap="square"/>
-                    <a:lstStyle/>
-                    <a:p>
-                      <a:pPr algn="ctr"/>
-                      <a:r>
-                        <a:rPr sz="1200" b="0" i="0">
-                          <a:solidFill>
-                            <a:srgbClr val="1F1F1F"/>
-                          </a:solidFill>
-                          <a:latin typeface="Calibri"/>
-                        </a:rPr>
-                        <a:t>0.708</a:t>
-                      </a:r>
-                    </a:p>
-                  </a:txBody>
-                  <a:tcPr marL="54864" marR="54864" marT="27432" marB="27432" anchor="ctr">
-                    <a:solidFill>
-                      <a:srgbClr val="FFFFFF"/>
-                    </a:solidFill>
-                  </a:tcPr>
-                </a:tc>
-                <a:tc>
-                  <a:txBody>
-                    <a:bodyPr wrap="square"/>
-                    <a:lstStyle/>
-                    <a:p>
-                      <a:pPr algn="ctr"/>
-                      <a:r>
-                        <a:rPr sz="1200" b="0" i="0">
-                          <a:solidFill>
-                            <a:srgbClr val="1F1F1F"/>
-                          </a:solidFill>
-                          <a:latin typeface="Calibri"/>
-                        </a:rPr>
-                        <a:t>+0.000</a:t>
-                      </a:r>
-                    </a:p>
-                  </a:txBody>
-                  <a:tcPr marL="54864" marR="54864" marT="27432" marB="27432" anchor="ctr">
-                    <a:solidFill>
-                      <a:srgbClr val="FFFFFF"/>
-                    </a:solidFill>
-                  </a:tcPr>
-                </a:tc>
-              </a:tr>
-              <a:tr h="530352">
-                <a:tc>
-                  <a:txBody>
-                    <a:bodyPr wrap="square"/>
-                    <a:lstStyle/>
-                    <a:p>
-                      <a:pPr algn="l"/>
-                      <a:r>
-                        <a:rPr sz="1200" b="1" i="0">
-                          <a:solidFill>
-                            <a:srgbClr val="1F1F1F"/>
-                          </a:solidFill>
-                          <a:latin typeface="Calibri"/>
-                        </a:rPr>
-                        <a:t>Standard MLP</a:t>
-                      </a:r>
-                    </a:p>
-                  </a:txBody>
-                  <a:tcPr marL="54864" marR="54864" marT="27432" marB="27432" anchor="ctr">
-                    <a:solidFill>
-                      <a:srgbClr val="EEF2F8"/>
-                    </a:solidFill>
-                  </a:tcPr>
-                </a:tc>
-                <a:tc>
-                  <a:txBody>
-                    <a:bodyPr wrap="square"/>
-                    <a:lstStyle/>
-                    <a:p>
-                      <a:pPr algn="ctr"/>
-                      <a:r>
-                        <a:rPr sz="1200" b="0" i="0">
-                          <a:solidFill>
-                            <a:srgbClr val="1F1F1F"/>
-                          </a:solidFill>
-                          <a:latin typeface="Calibri"/>
-                        </a:rPr>
-                        <a:t>0.759</a:t>
-                      </a:r>
-                    </a:p>
-                  </a:txBody>
-                  <a:tcPr marL="54864" marR="54864" marT="27432" marB="27432" anchor="ctr">
-                    <a:solidFill>
-                      <a:srgbClr val="EEF2F8"/>
-                    </a:solidFill>
-                  </a:tcPr>
-                </a:tc>
-                <a:tc>
-                  <a:txBody>
-                    <a:bodyPr wrap="square"/>
-                    <a:lstStyle/>
-                    <a:p>
-                      <a:pPr algn="ctr"/>
-                      <a:r>
-                        <a:rPr sz="1200" b="0" i="0">
+                        <a:rPr sz="1100" b="0" i="0">
                           <a:solidFill>
                             <a:srgbClr val="1F1F1F"/>
                           </a:solidFill>
                           <a:latin typeface="Calibri"/>
                         </a:rPr>
                         <a:t>0.784</a:t>
-                      </a:r>
-                    </a:p>
-                  </a:txBody>
-                  <a:tcPr marL="54864" marR="54864" marT="27432" marB="27432" anchor="ctr">
-                    <a:solidFill>
-                      <a:srgbClr val="EEF2F8"/>
-                    </a:solidFill>
-                  </a:tcPr>
-                </a:tc>
-                <a:tc>
-                  <a:txBody>
-                    <a:bodyPr wrap="square"/>
-                    <a:lstStyle/>
-                    <a:p>
-                      <a:pPr algn="ctr"/>
-                      <a:r>
-                        <a:rPr sz="1200" b="0" i="0">
-                          <a:solidFill>
-                            <a:srgbClr val="1F1F1F"/>
-                          </a:solidFill>
-                          <a:latin typeface="Calibri"/>
-                        </a:rPr>
-                        <a:t>+0.025</a:t>
-                      </a:r>
-                    </a:p>
-                  </a:txBody>
-                  <a:tcPr marL="54864" marR="54864" marT="27432" marB="27432" anchor="ctr">
-                    <a:solidFill>
-                      <a:srgbClr val="EEF2F8"/>
-                    </a:solidFill>
-                  </a:tcPr>
-                </a:tc>
-                <a:tc>
-                  <a:txBody>
-                    <a:bodyPr wrap="square"/>
-                    <a:lstStyle/>
-                    <a:p>
-                      <a:pPr algn="ctr"/>
-                      <a:r>
-                        <a:rPr sz="1200" b="0" i="0">
-                          <a:solidFill>
-                            <a:srgbClr val="1F1F1F"/>
-                          </a:solidFill>
-                          <a:latin typeface="Calibri"/>
-                        </a:rPr>
-                        <a:t>0.678</a:t>
-                      </a:r>
-                    </a:p>
-                  </a:txBody>
-                  <a:tcPr marL="54864" marR="54864" marT="27432" marB="27432" anchor="ctr">
-                    <a:solidFill>
-                      <a:srgbClr val="EEF2F8"/>
-                    </a:solidFill>
-                  </a:tcPr>
-                </a:tc>
-                <a:tc>
-                  <a:txBody>
-                    <a:bodyPr wrap="square"/>
-                    <a:lstStyle/>
-                    <a:p>
-                      <a:pPr algn="ctr"/>
-                      <a:r>
-                        <a:rPr sz="1200" b="0" i="0">
-                          <a:solidFill>
-                            <a:srgbClr val="1F1F1F"/>
-                          </a:solidFill>
-                          <a:latin typeface="Calibri"/>
-                        </a:rPr>
-                        <a:t>0.692</a:t>
-                      </a:r>
-                    </a:p>
-                  </a:txBody>
-                  <a:tcPr marL="54864" marR="54864" marT="27432" marB="27432" anchor="ctr">
-                    <a:solidFill>
-                      <a:srgbClr val="EEF2F8"/>
-                    </a:solidFill>
-                  </a:tcPr>
-                </a:tc>
-                <a:tc>
-                  <a:txBody>
-                    <a:bodyPr wrap="square"/>
-                    <a:lstStyle/>
-                    <a:p>
-                      <a:pPr algn="ctr"/>
-                      <a:r>
-                        <a:rPr sz="1200" b="0" i="0">
-                          <a:solidFill>
-                            <a:srgbClr val="1F1F1F"/>
-                          </a:solidFill>
-                          <a:latin typeface="Calibri"/>
-                        </a:rPr>
-                        <a:t>+0.013</a:t>
                       </a:r>
                     </a:p>
                   </a:txBody>
@@ -11878,8 +12202,8 @@
         </p:nvSpPr>
         <p:spPr>
           <a:xfrm>
-            <a:off x="365760" y="5074920"/>
-            <a:ext cx="8412480" cy="1280160"/>
+            <a:off x="365760" y="4800600"/>
+            <a:ext cx="8412480" cy="1463040"/>
           </a:xfrm>
           <a:prstGeom prst="rect">
             <a:avLst/>
@@ -11894,11 +12218,11 @@
           <a:p>
             <a:pPr>
               <a:spcAft>
-                <a:spcPts val="400"/>
+                <a:spcPts val="200"/>
               </a:spcAft>
             </a:pPr>
             <a:r>
-              <a:rPr sz="1500" b="0" i="0">
+              <a:rPr sz="1200" b="0" i="0">
                 <a:solidFill>
                   <a:srgbClr val="0E6E6E"/>
                 </a:solidFill>
@@ -11907,7 +12231,7 @@
               <a:t>▪  </a:t>
             </a:r>
             <a:r>
-              <a:rPr sz="1500" b="1" i="0">
+              <a:rPr sz="1200" b="1" i="0">
                 <a:solidFill>
                   <a:srgbClr val="1F1F1F"/>
                 </a:solidFill>
@@ -11916,7 +12240,7 @@
               <a:t>Before: </a:t>
             </a:r>
             <a:r>
-              <a:rPr sz="1500" b="0" i="0">
+              <a:rPr sz="1200" b="0" i="0">
                 <a:solidFill>
                   <a:srgbClr val="1F1F1F"/>
                 </a:solidFill>
@@ -11928,11 +12252,11 @@
           <a:p>
             <a:pPr>
               <a:spcAft>
-                <a:spcPts val="400"/>
+                <a:spcPts val="200"/>
               </a:spcAft>
             </a:pPr>
             <a:r>
-              <a:rPr sz="1500" b="0" i="0">
+              <a:rPr sz="1200" b="0" i="0">
                 <a:solidFill>
                   <a:srgbClr val="0E6E6E"/>
                 </a:solidFill>
@@ -11941,22 +12265,56 @@
               <a:t>▪  </a:t>
             </a:r>
             <a:r>
-              <a:rPr sz="1500" b="1" i="0">
+              <a:rPr sz="1200" b="1" i="0">
                 <a:solidFill>
                   <a:srgbClr val="1F1F1F"/>
                 </a:solidFill>
                 <a:latin typeface="Calibri"/>
               </a:rPr>
+              <a:t>RMSE: </a:t>
+            </a:r>
+            <a:r>
+              <a:rPr sz="1200" b="0" i="0">
+                <a:solidFill>
+                  <a:srgbClr val="1F1F1F"/>
+                </a:solidFill>
+                <a:latin typeface="Calibri"/>
+              </a:rPr>
+              <a:t>error of the predicted probability against the true class (Linear SVM gives no probabilities: n/a)</a:t>
+            </a:r>
+          </a:p>
+          <a:p>
+            <a:pPr>
+              <a:spcAft>
+                <a:spcPts val="200"/>
+              </a:spcAft>
+            </a:pPr>
+            <a:r>
+              <a:rPr sz="1200" b="0" i="0">
+                <a:solidFill>
+                  <a:srgbClr val="0E6E6E"/>
+                </a:solidFill>
+                <a:latin typeface="Calibri"/>
+              </a:rPr>
+              <a:t>▪  </a:t>
+            </a:r>
+            <a:r>
+              <a:rPr sz="1200" b="1" i="0">
+                <a:solidFill>
+                  <a:srgbClr val="1F1F1F"/>
+                </a:solidFill>
+                <a:latin typeface="Calibri"/>
+              </a:rPr>
               <a:t>Result: </a:t>
             </a:r>
             <a:r>
-              <a:rPr sz="1500" b="0" i="0">
+              <a:rPr sz="1200" b="0" i="0">
                 <a:solidFill>
                   <a:srgbClr val="1F1F1F"/>
                 </a:solidFill>
                 <a:latin typeface="Calibri"/>
               </a:rPr>
-              <a:t>largest gain MLP +0.025 ROC-AUC, B-ACPN +0.013. RF and GBT ignore feature scale, and Spark's LR and Linear SVM standardise internally, so their before/after runs are equal.</a:t>
+              <a:t>B-ACPN accuracy 0.735 → 0.738, F1 0.726 → 0.728, RMSE 0.422 → 0.417 (lower is better), ROC-AUC 0.806 → 0.820. Not every metric improves: MLP accuracy 0.711 → 0.699. RF and GBT ignore feature scale, and Spark's LR and Linear SVM standardise internally, so they do not change.</a:t>
             </a:r>
           </a:p>
         </p:txBody>
@@ -19594,7 +19952,7 @@
       </p:pic>
       <p:pic>
         <p:nvPicPr>
-          <p:cNvPr id="4" name="Picture 3" descr="acpn_training_curve.png"/>
+          <p:cNvPr id="4" name="Picture 3" descr="bacpn_training_curve.png"/>
           <p:cNvPicPr>
             <a:picLocks noChangeAspect="1"/>
           </p:cNvPicPr>
@@ -20619,8 +20977,8 @@
         </p:blipFill>
         <p:spPr>
           <a:xfrm>
-            <a:off x="365760" y="1471338"/>
-            <a:ext cx="8412480" cy="4098203"/>
+            <a:off x="940100" y="1234440"/>
+            <a:ext cx="7263798" cy="4572000"/>
           </a:xfrm>
           <a:prstGeom prst="rect">
             <a:avLst/>
@@ -20657,7 +21015,7 @@
                 </a:solidFill>
                 <a:latin typeface="Calibri"/>
               </a:rPr>
-              <a:t>Model ROC-AUC before vs after preprocessing (label = gain)</a:t>
+              <a:t>Accuracy, F1, ROC-AUC and RMSE before vs after preprocessing</a:t>
             </a:r>
           </a:p>
         </p:txBody>

</xml_diff>

<commit_message>
Slide 33: Colab section owners match the task split (Deepankar 3-7, Devanshu 8, Tanmay 9-10)
</commit_message>
<xml_diff>
--- a/docs/Review2_Deck.pptx
+++ b/docs/Review2_Deck.pptx
@@ -24040,7 +24040,7 @@
                           </a:solidFill>
                           <a:latin typeface="Calibri"/>
                         </a:rPr>
-                        <a:t>3–4 Hadoop + HDFS</a:t>
+                        <a:t>3–7 Hadoop, HDFS, MapReduce, Hive, Spark</a:t>
                       </a:r>
                     </a:p>
                   </a:txBody>
@@ -24063,7 +24063,7 @@
                           </a:solidFill>
                           <a:latin typeface="Calibri"/>
                         </a:rPr>
-                        <a:t>Cluster start, health report, HDFS load, Table 2</a:t>
+                        <a:t>Cluster, HDFS load (Table 2), YARN job + timings, Hive, k-means (Table 3)</a:t>
                       </a:r>
                     </a:p>
                   </a:txBody>
@@ -24111,7 +24111,7 @@
                           </a:solidFill>
                           <a:latin typeface="Calibri"/>
                         </a:rPr>
-                        <a:t>5–7 MapReduce, Hive, Spark</a:t>
+                        <a:t>8 B-ACPN (proposed model)</a:t>
                       </a:r>
                     </a:p>
                   </a:txBody>
@@ -24134,7 +24134,7 @@
                           </a:solidFill>
                           <a:latin typeface="Calibri"/>
                         </a:rPr>
-                        <a:t>YARN job + timings, Hive check, k-means regimes, Table 3</a:t>
+                        <a:t>Architecture, model card (Table 4), ablation, climate push (Table 6)</a:t>
                       </a:r>
                     </a:p>
                   </a:txBody>
@@ -24157,7 +24157,7 @@
                           </a:solidFill>
                           <a:latin typeface="Calibri"/>
                         </a:rPr>
-                        <a:t>Tanmay</a:t>
+                        <a:t>Devanshu</a:t>
                       </a:r>
                     </a:p>
                   </a:txBody>
@@ -24182,7 +24182,7 @@
                           </a:solidFill>
                           <a:latin typeface="Calibri"/>
                         </a:rPr>
-                        <a:t>8–10 B-ACPN + comparison</a:t>
+                        <a:t>9–10 Comparison</a:t>
                       </a:r>
                     </a:p>
                   </a:txBody>
@@ -24205,7 +24205,7 @@
                           </a:solidFill>
                           <a:latin typeface="Calibri"/>
                         </a:rPr>
-                        <a:t>Model card, 5 baselines, Tables 4–6, ablation</a:t>
+                        <a:t>5 existing models, all metrics, preprocessing before/after (Table 5)</a:t>
                       </a:r>
                     </a:p>
                   </a:txBody>
@@ -24228,7 +24228,7 @@
                           </a:solidFill>
                           <a:latin typeface="Calibri"/>
                         </a:rPr>
-                        <a:t>Devanshu</a:t>
+                        <a:t>Tanmay</a:t>
                       </a:r>
                     </a:p>
                   </a:txBody>

</xml_diff>

<commit_message>
Preprocessing performance metrics from the Colab run: all 8 metrics filled for both checks
</commit_message>
<xml_diff>
--- a/docs/Review2_Deck.pptx
+++ b/docs/Review2_Deck.pptx
@@ -9341,13 +9341,13 @@
                     <a:p>
                       <a:pPr algn="ctr"/>
                       <a:r>
-                        <a:rPr sz="1100" b="0" i="1">
-                          <a:solidFill>
-                            <a:srgbClr val="C0392B"/>
-                          </a:solidFill>
-                          <a:latin typeface="Calibri"/>
-                        </a:rPr>
-                        <a:t>PENDING</a:t>
+                        <a:rPr sz="1100" b="0" i="0">
+                          <a:solidFill>
+                            <a:srgbClr val="1F1F1F"/>
+                          </a:solidFill>
+                          <a:latin typeface="Calibri"/>
+                        </a:rPr>
+                        <a:t>0.01%</a:t>
                       </a:r>
                     </a:p>
                   </a:txBody>
@@ -9435,13 +9435,13 @@
                     <a:p>
                       <a:pPr algn="ctr"/>
                       <a:r>
-                        <a:rPr sz="1100" b="0" i="1">
-                          <a:solidFill>
-                            <a:srgbClr val="C0392B"/>
-                          </a:solidFill>
-                          <a:latin typeface="Calibri"/>
-                        </a:rPr>
-                        <a:t>PENDING</a:t>
+                        <a:rPr sz="1100" b="0" i="0">
+                          <a:solidFill>
+                            <a:srgbClr val="1F1F1F"/>
+                          </a:solidFill>
+                          <a:latin typeface="Calibri"/>
+                        </a:rPr>
+                        <a:t>0.9042</a:t>
                       </a:r>
                     </a:p>
                   </a:txBody>
@@ -9458,13 +9458,13 @@
                     <a:p>
                       <a:pPr algn="ctr"/>
                       <a:r>
-                        <a:rPr sz="1100" b="0" i="1">
-                          <a:solidFill>
-                            <a:srgbClr val="C0392B"/>
-                          </a:solidFill>
-                          <a:latin typeface="Calibri"/>
-                        </a:rPr>
-                        <a:t>PENDING</a:t>
+                        <a:rPr sz="1100" b="0" i="0">
+                          <a:solidFill>
+                            <a:srgbClr val="1F1F1F"/>
+                          </a:solidFill>
+                          <a:latin typeface="Calibri"/>
+                        </a:rPr>
+                        <a:t>0.999999</a:t>
                       </a:r>
                     </a:p>
                   </a:txBody>
@@ -9552,13 +9552,13 @@
                     <a:p>
                       <a:pPr algn="ctr"/>
                       <a:r>
-                        <a:rPr sz="1100" b="0" i="1">
-                          <a:solidFill>
-                            <a:srgbClr val="C0392B"/>
-                          </a:solidFill>
-                          <a:latin typeface="Calibri"/>
-                        </a:rPr>
-                        <a:t>PENDING</a:t>
+                        <a:rPr sz="1100" b="0" i="0">
+                          <a:solidFill>
+                            <a:srgbClr val="1F1F1F"/>
+                          </a:solidFill>
+                          <a:latin typeface="Calibri"/>
+                        </a:rPr>
+                        <a:t>0.034</a:t>
                       </a:r>
                     </a:p>
                   </a:txBody>
@@ -9575,13 +9575,13 @@
                     <a:p>
                       <a:pPr algn="ctr"/>
                       <a:r>
-                        <a:rPr sz="1100" b="0" i="1">
-                          <a:solidFill>
-                            <a:srgbClr val="C0392B"/>
-                          </a:solidFill>
-                          <a:latin typeface="Calibri"/>
-                        </a:rPr>
-                        <a:t>PENDING</a:t>
+                        <a:rPr sz="1100" b="0" i="0">
+                          <a:solidFill>
+                            <a:srgbClr val="1F1F1F"/>
+                          </a:solidFill>
+                          <a:latin typeface="Calibri"/>
+                        </a:rPr>
+                        <a:t>1.9e-04</a:t>
                       </a:r>
                     </a:p>
                   </a:txBody>
@@ -9669,13 +9669,13 @@
                     <a:p>
                       <a:pPr algn="ctr"/>
                       <a:r>
-                        <a:rPr sz="1100" b="0" i="1">
-                          <a:solidFill>
-                            <a:srgbClr val="C0392B"/>
-                          </a:solidFill>
-                          <a:latin typeface="Calibri"/>
-                        </a:rPr>
-                        <a:t>PENDING</a:t>
+                        <a:rPr sz="1100" b="0" i="0">
+                          <a:solidFill>
+                            <a:srgbClr val="1F1F1F"/>
+                          </a:solidFill>
+                          <a:latin typeface="Calibri"/>
+                        </a:rPr>
+                        <a:t>87.0</a:t>
                       </a:r>
                     </a:p>
                   </a:txBody>
@@ -9692,13 +9692,13 @@
                     <a:p>
                       <a:pPr algn="ctr"/>
                       <a:r>
-                        <a:rPr sz="1100" b="0" i="1">
-                          <a:solidFill>
-                            <a:srgbClr val="C0392B"/>
-                          </a:solidFill>
-                          <a:latin typeface="Calibri"/>
-                        </a:rPr>
-                        <a:t>PENDING</a:t>
+                        <a:rPr sz="1100" b="0" i="0">
+                          <a:solidFill>
+                            <a:srgbClr val="1F1F1F"/>
+                          </a:solidFill>
+                          <a:latin typeface="Calibri"/>
+                        </a:rPr>
+                        <a:t>0.002</a:t>
                       </a:r>
                     </a:p>
                   </a:txBody>
@@ -9786,13 +9786,13 @@
                     <a:p>
                       <a:pPr algn="ctr"/>
                       <a:r>
-                        <a:rPr sz="1100" b="0" i="1">
-                          <a:solidFill>
-                            <a:srgbClr val="C0392B"/>
-                          </a:solidFill>
-                          <a:latin typeface="Calibri"/>
-                        </a:rPr>
-                        <a:t>PENDING</a:t>
+                        <a:rPr sz="1100" b="0" i="0">
+                          <a:solidFill>
+                            <a:srgbClr val="1F1F1F"/>
+                          </a:solidFill>
+                          <a:latin typeface="Calibri"/>
+                        </a:rPr>
+                        <a:t>5.045</a:t>
                       </a:r>
                     </a:p>
                   </a:txBody>
@@ -9809,13 +9809,13 @@
                     <a:p>
                       <a:pPr algn="ctr"/>
                       <a:r>
-                        <a:rPr sz="1100" b="0" i="1">
-                          <a:solidFill>
-                            <a:srgbClr val="C0392B"/>
-                          </a:solidFill>
-                          <a:latin typeface="Calibri"/>
-                        </a:rPr>
-                        <a:t>PENDING</a:t>
+                        <a:rPr sz="1100" b="0" i="0">
+                          <a:solidFill>
+                            <a:srgbClr val="1F1F1F"/>
+                          </a:solidFill>
+                          <a:latin typeface="Calibri"/>
+                        </a:rPr>
+                        <a:t>-2.2e-05</a:t>
                       </a:r>
                     </a:p>
                   </a:txBody>
@@ -9860,7 +9860,7 @@
                 </a:solidFill>
                 <a:latin typeface="Calibri"/>
               </a:rPr>
-              <a:t>Left: 636 districts, year 2020, in mm; large values are the error the naive method would make. Right: 19,200 district-years × 7 indices; values near 0 (and R² near 1) mean MapReduce matches. MAPE skips zero actual values; NRMSE uses the range. Source: Colab run 2026-10-22. PENDING = not yet computed (needs the raw IMD grids in Colab).</a:t>
+              <a:t>Left: 636 districts, year 2020, in mm; large values are the error the naive method would make. Right: 19,200 district-years × 7 indices; values near 0 (and R² near 1) mean MapReduce matches. MAPE skips zero actual values; NRMSE uses the range. Computed in Colab section 10b (2026-10-28) from the IMD and MapReduce data of the Colab run 2026-10-22.</a:t>
             </a:r>
           </a:p>
         </p:txBody>

</xml_diff>

<commit_message>
Rainfall signal-to-noise ratio on the preprocessing results slide and README
</commit_message>
<xml_diff>
--- a/docs/Review2_Deck.pptx
+++ b/docs/Review2_Deck.pptx
@@ -815,7 +815,7 @@
           <a:lstStyle/>
           <a:p>
             <a:r>
-              <a:t>Districts are kept only when every variable is real, which takes us from 640 Census districts to 469 complete ones in 21 states. Census totals match the official figures. On the right, each feature's single-variable ROC-AUC shows how much signal it carries before any model is trained.</a:t>
+              <a:t>Districts are kept only when every variable is real, which takes us from 640 Census districts to 469 complete ones in 21 states. Census totals match the official figures. On the right, each feature's single-variable ROC-AUC shows how much signal it carries before any model is trained, and the rainfall signal-to-noise ratio shows the 30-year average is about four times larger than its year-to-year variation.</a:t>
             </a:r>
           </a:p>
         </p:txBody>
@@ -6461,7 +6461,7 @@
         </p:nvGraphicFramePr>
         <p:xfrm>
           <a:off x="365760" y="1554480"/>
-          <a:ext cx="4480560" cy="4297680"/>
+          <a:ext cx="4480560" cy="4325112"/>
         </p:xfrm>
         <a:graphic>
           <a:graphicData uri="http://schemas.openxmlformats.org/drawingml/2006/table">
@@ -6473,7 +6473,7 @@
                 <a:gridCol w="2377440"/>
                 <a:gridCol w="2103120"/>
               </a:tblGrid>
-              <a:tr h="429768">
+              <a:tr h="393192">
                 <a:tc>
                   <a:txBody>
                     <a:bodyPr wrap="square"/>
@@ -6521,7 +6521,7 @@
                   </a:tcPr>
                 </a:tc>
               </a:tr>
-              <a:tr h="429768">
+              <a:tr h="393192">
                 <a:tc>
                   <a:txBody>
                     <a:bodyPr wrap="square"/>
@@ -6569,7 +6569,7 @@
                   </a:tcPr>
                 </a:tc>
               </a:tr>
-              <a:tr h="429768">
+              <a:tr h="393192">
                 <a:tc>
                   <a:txBody>
                     <a:bodyPr wrap="square"/>
@@ -6617,7 +6617,7 @@
                   </a:tcPr>
                 </a:tc>
               </a:tr>
-              <a:tr h="429768">
+              <a:tr h="393192">
                 <a:tc>
                   <a:txBody>
                     <a:bodyPr wrap="square"/>
@@ -6665,7 +6665,7 @@
                   </a:tcPr>
                 </a:tc>
               </a:tr>
-              <a:tr h="429768">
+              <a:tr h="393192">
                 <a:tc>
                   <a:txBody>
                     <a:bodyPr wrap="square"/>
@@ -6713,7 +6713,7 @@
                   </a:tcPr>
                 </a:tc>
               </a:tr>
-              <a:tr h="429768">
+              <a:tr h="393192">
                 <a:tc>
                   <a:txBody>
                     <a:bodyPr wrap="square"/>
@@ -6761,7 +6761,7 @@
                   </a:tcPr>
                 </a:tc>
               </a:tr>
-              <a:tr h="429768">
+              <a:tr h="393192">
                 <a:tc>
                   <a:txBody>
                     <a:bodyPr wrap="square"/>
@@ -6809,7 +6809,7 @@
                   </a:tcPr>
                 </a:tc>
               </a:tr>
-              <a:tr h="429768">
+              <a:tr h="393192">
                 <a:tc>
                   <a:txBody>
                     <a:bodyPr wrap="square"/>
@@ -6857,7 +6857,7 @@
                   </a:tcPr>
                 </a:tc>
               </a:tr>
-              <a:tr h="429768">
+              <a:tr h="393192">
                 <a:tc>
                   <a:txBody>
                     <a:bodyPr wrap="square"/>
@@ -6905,7 +6905,7 @@
                   </a:tcPr>
                 </a:tc>
               </a:tr>
-              <a:tr h="429768">
+              <a:tr h="393192">
                 <a:tc>
                   <a:txBody>
                     <a:bodyPr wrap="square"/>
@@ -6949,6 +6949,54 @@
                   <a:tcPr marL="54864" marR="54864" marT="27432" marB="27432" anchor="ctr">
                     <a:solidFill>
                       <a:srgbClr val="FFFFFF"/>
+                    </a:solidFill>
+                  </a:tcPr>
+                </a:tc>
+              </a:tr>
+              <a:tr h="393192">
+                <a:tc>
+                  <a:txBody>
+                    <a:bodyPr wrap="square"/>
+                    <a:lstStyle/>
+                    <a:p>
+                      <a:pPr algn="l"/>
+                      <a:r>
+                        <a:rPr sz="1200" b="1" i="0">
+                          <a:solidFill>
+                            <a:srgbClr val="1F1F1F"/>
+                          </a:solidFill>
+                          <a:latin typeface="Calibri"/>
+                        </a:rPr>
+                        <a:t>Rainfall signal-to-noise (median)</a:t>
+                      </a:r>
+                    </a:p>
+                  </a:txBody>
+                  <a:tcPr marL="54864" marR="54864" marT="27432" marB="27432" anchor="ctr">
+                    <a:solidFill>
+                      <a:srgbClr val="EEF2F8"/>
+                    </a:solidFill>
+                  </a:tcPr>
+                </a:tc>
+                <a:tc>
+                  <a:txBody>
+                    <a:bodyPr wrap="square"/>
+                    <a:lstStyle/>
+                    <a:p>
+                      <a:pPr algn="ctr"/>
+                      <a:r>
+                        <a:rPr sz="1200" b="0" i="0">
+                          <a:solidFill>
+                            <a:srgbClr val="1F1F1F"/>
+                          </a:solidFill>
+                          <a:latin typeface="Calibri"/>
+                        </a:rPr>
+                        <a:t>3.98 (mean ÷ year-to-year SD)</a:t>
+                      </a:r>
+                    </a:p>
+                  </a:txBody>
+                  <a:tcPr marL="54864" marR="54864" marT="27432" marB="27432" anchor="ctr">
+                    <a:solidFill>
+                      <a:srgbClr val="EEF2F8"/>
                     </a:solidFill>
                   </a:tcPr>
                 </a:tc>

</xml_diff>

<commit_message>
Deck order: preprocessing, then Big Data tools, then ML models, each part with its own tables and figures
</commit_message>
<xml_diff>
--- a/docs/Review2_Deck.pptx
+++ b/docs/Review2_Deck.pptx
@@ -12,33 +12,33 @@
     <p:sldId id="257" r:id="rId3"/>
     <p:sldId id="258" r:id="rId10"/>
     <p:sldId id="259" r:id="rId11"/>
-    <p:sldId id="260" r:id="rId12"/>
-    <p:sldId id="261" r:id="rId13"/>
-    <p:sldId id="262" r:id="rId14"/>
-    <p:sldId id="263" r:id="rId15"/>
     <p:sldId id="264" r:id="rId16"/>
     <p:sldId id="265" r:id="rId17"/>
     <p:sldId id="266" r:id="rId18"/>
     <p:sldId id="267" r:id="rId19"/>
+    <p:sldId id="277" r:id="rId29"/>
+    <p:sldId id="278" r:id="rId30"/>
+    <p:sldId id="270" r:id="rId22"/>
+    <p:sldId id="274" r:id="rId26"/>
+    <p:sldId id="286" r:id="rId38"/>
+    <p:sldId id="261" r:id="rId13"/>
+    <p:sldId id="262" r:id="rId14"/>
+    <p:sldId id="263" r:id="rId15"/>
+    <p:sldId id="279" r:id="rId31"/>
+    <p:sldId id="280" r:id="rId32"/>
+    <p:sldId id="260" r:id="rId12"/>
     <p:sldId id="268" r:id="rId20"/>
+    <p:sldId id="275" r:id="rId27"/>
+    <p:sldId id="276" r:id="rId28"/>
+    <p:sldId id="281" r:id="rId33"/>
+    <p:sldId id="282" r:id="rId34"/>
+    <p:sldId id="283" r:id="rId35"/>
     <p:sldId id="269" r:id="rId21"/>
-    <p:sldId id="270" r:id="rId22"/>
     <p:sldId id="271" r:id="rId23"/>
     <p:sldId id="272" r:id="rId24"/>
     <p:sldId id="273" r:id="rId25"/>
-    <p:sldId id="274" r:id="rId26"/>
-    <p:sldId id="275" r:id="rId27"/>
-    <p:sldId id="276" r:id="rId28"/>
-    <p:sldId id="277" r:id="rId29"/>
-    <p:sldId id="278" r:id="rId30"/>
-    <p:sldId id="279" r:id="rId31"/>
-    <p:sldId id="280" r:id="rId32"/>
-    <p:sldId id="281" r:id="rId33"/>
-    <p:sldId id="282" r:id="rId34"/>
-    <p:sldId id="283" r:id="rId35"/>
     <p:sldId id="284" r:id="rId36"/>
     <p:sldId id="285" r:id="rId37"/>
-    <p:sldId id="286" r:id="rId38"/>
     <p:sldId id="287" r:id="rId39"/>
     <p:sldId id="288" r:id="rId40"/>
     <p:sldId id="289" r:id="rId41"/>
@@ -1515,7 +1515,7 @@
           <a:lstStyle/>
           <a:p>
             <a:r>
-              <a:t>This is the order we follow, as required for Review 2: dataset, model, architecture, preprocessing and its results, classification, comparison, team plan, references, photo and the Colab link.</a:t>
+              <a:t>The deck runs in three parts, each with its own tables and figures: preprocessing first, then the Big Data tools, then the proposed model and the comparison with existing models, followed by the key findings, team plan, references, photo and the Colab link.</a:t>
             </a:r>
           </a:p>
         </p:txBody>
@@ -20913,7 +20913,7 @@
                 </a:solidFill>
                 <a:latin typeface="Calibri"/>
               </a:rPr>
-              <a:t>Proposed Model (B-ACPN)</a:t>
+              <a:t>Preprocessing: steps, results and error metrics</a:t>
             </a:r>
           </a:p>
         </p:txBody>
@@ -21001,7 +21001,7 @@
                 </a:solidFill>
                 <a:latin typeface="Calibri"/>
               </a:rPr>
-              <a:t>Overall System Architecture Diagram</a:t>
+              <a:t>Effect of preprocessing on the models</a:t>
             </a:r>
           </a:p>
         </p:txBody>
@@ -21089,7 +21089,7 @@
                 </a:solidFill>
                 <a:latin typeface="Calibri"/>
               </a:rPr>
-              <a:t>Preprocessing (Big Data analysis and its steps)</a:t>
+              <a:t>Big Data tools: architecture, HDFS, MapReduce, Hive, Spark</a:t>
             </a:r>
           </a:p>
         </p:txBody>
@@ -21177,7 +21177,7 @@
                 </a:solidFill>
                 <a:latin typeface="Calibri"/>
               </a:rPr>
-              <a:t>Results of Preprocessing</a:t>
+              <a:t>Proposed Model (B-ACPN)</a:t>
             </a:r>
           </a:p>
         </p:txBody>
@@ -21265,7 +21265,7 @@
                 </a:solidFill>
                 <a:latin typeface="Calibri"/>
               </a:rPr>
-              <a:t>Classification (proposed model)</a:t>
+              <a:t>Ablation and climate-push results</a:t>
             </a:r>
           </a:p>
         </p:txBody>
@@ -21353,7 +21353,7 @@
                 </a:solidFill>
                 <a:latin typeface="Calibri"/>
               </a:rPr>
-              <a:t>Results of Classification using proposed model</a:t>
+              <a:t>Comparison with the existing classifier models</a:t>
             </a:r>
           </a:p>
         </p:txBody>
@@ -21441,7 +21441,7 @@
                 </a:solidFill>
                 <a:latin typeface="Calibri"/>
               </a:rPr>
-              <a:t>Comparison with the existing classifier models</a:t>
+              <a:t>Key findings</a:t>
             </a:r>
           </a:p>
         </p:txBody>

</xml_diff>